<commit_message>
Ranking PPTX: pasang logo Danantara di kop
Logo Danantara dikirim user sebagai gambar, sebelumnya kop hanya memakai
teks 'Danantara Indonesia'.

- Logo ditanam sebagai base64 di dalam kode (src/lib/sip/ranking-pptx.ts)
  supaya ikut di dalam berkas PPTX yang diunduh — kalau hanya merujuk
  berkas di public/, logo hilang saat PPTX dibuka di komputer lain
- Kotak putihnya dibuat PERSEGI (0,78 x 0,78 inci) karena logo rasionya
  1:1; kotak 1,78 x 0,62 membuat logo gepeng
- Versi Python (scripts/buat-pptx-ranking.py) juga memakai logo dari
  public/danantara-logo.png
</commit_message>
<xml_diff>
--- a/ranking-nyata.pptx
+++ b/ranking-nyata.pptx
@@ -1016,85 +1016,58 @@
       </p:sp>
       <p:sp>
         <p:nvSpPr>
-          <p:cNvPr id="4" name="Text 2"/>
-          <p:cNvSpPr/>
-          <p:nvPr/>
-        </p:nvSpPr>
-        <p:spPr>
-          <a:xfrm>
-            <a:off x="320040" y="146304"/>
-            <a:ext cx="1828800" cy="274320"/>
-          </a:xfrm>
-          <a:prstGeom prst="rect">
-            <a:avLst/>
-          </a:prstGeom>
-          <a:noFill/>
-          <a:ln/>
-        </p:spPr>
-        <p:txBody>
-          <a:bodyPr wrap="square" rtlCol="0" anchor="ctr"/>
-          <a:lstStyle/>
-          <a:p>
-            <a:pPr indent="0" marL="0">
-              <a:buNone/>
-            </a:pPr>
-            <a:r>
-              <a:rPr lang="en-US" sz="1300" b="1" dirty="0">
-                <a:solidFill>
-                  <a:srgbClr val="FFFFFF"/>
-                </a:solidFill>
-                <a:latin typeface="Arial" pitchFamily="34" charset="0"/>
-                <a:ea typeface="Arial" pitchFamily="34" charset="-122"/>
-                <a:cs typeface="Arial" pitchFamily="34" charset="-120"/>
-              </a:rPr>
-              <a:t>Danantara</a:t>
-            </a:r>
-            <a:endParaRPr lang="en-US" sz="1300" dirty="0"/>
-          </a:p>
-        </p:txBody>
-      </p:sp>
-      <p:sp>
-        <p:nvSpPr>
-          <p:cNvPr id="5" name="Text 3"/>
-          <p:cNvSpPr/>
-          <p:nvPr/>
-        </p:nvSpPr>
-        <p:spPr>
-          <a:xfrm>
-            <a:off x="320040" y="384048"/>
-            <a:ext cx="1828800" cy="274320"/>
-          </a:xfrm>
-          <a:prstGeom prst="rect">
-            <a:avLst/>
-          </a:prstGeom>
-          <a:noFill/>
-          <a:ln/>
-        </p:spPr>
-        <p:txBody>
-          <a:bodyPr wrap="square" rtlCol="0" anchor="ctr"/>
-          <a:lstStyle/>
-          <a:p>
-            <a:pPr indent="0" marL="0">
-              <a:buNone/>
-            </a:pPr>
-            <a:r>
-              <a:rPr lang="en-US" sz="1300" b="1" dirty="0">
-                <a:solidFill>
-                  <a:srgbClr val="FFFFFF"/>
-                </a:solidFill>
-                <a:latin typeface="Arial" pitchFamily="34" charset="0"/>
-                <a:ea typeface="Arial" pitchFamily="34" charset="-122"/>
-                <a:cs typeface="Arial" pitchFamily="34" charset="-120"/>
-              </a:rPr>
-              <a:t>Indonesia</a:t>
-            </a:r>
-            <a:endParaRPr lang="en-US" sz="1300" dirty="0"/>
-          </a:p>
-        </p:txBody>
-      </p:sp>
-      <p:sp>
-        <p:nvSpPr>
-          <p:cNvPr id="6" name="Text 4"/>
+          <p:cNvPr id="4" name="Shape 2"/>
+          <p:cNvSpPr/>
+          <p:nvPr/>
+        </p:nvSpPr>
+        <p:spPr>
+          <a:xfrm>
+            <a:off x="274320" y="201168"/>
+            <a:ext cx="713232" cy="713232"/>
+          </a:xfrm>
+          <a:prstGeom prst="roundRect">
+            <a:avLst>
+              <a:gd name="adj" fmla="val 15385"/>
+            </a:avLst>
+          </a:prstGeom>
+          <a:solidFill>
+            <a:srgbClr val="FFFFFF"/>
+          </a:solidFill>
+          <a:ln w="12700">
+            <a:solidFill>
+              <a:srgbClr val="FFFFFF"/>
+            </a:solidFill>
+            <a:prstDash val="solid"/>
+          </a:ln>
+        </p:spPr>
+      </p:sp>
+      <p:pic>
+        <p:nvPicPr>
+          <p:cNvPr id="5" name="Image 0" descr="preencoded.png">    </p:cNvPr>
+          <p:cNvPicPr>
+            <a:picLocks noChangeAspect="1"/>
+          </p:cNvPicPr>
+          <p:nvPr/>
+        </p:nvPicPr>
+        <p:blipFill>
+          <a:blip r:embed="rId1"/>
+          <a:stretch>
+            <a:fillRect/>
+          </a:stretch>
+        </p:blipFill>
+        <p:spPr>
+          <a:xfrm>
+            <a:off x="310896" y="237744"/>
+            <a:ext cx="640080" cy="640080"/>
+          </a:xfrm>
+          <a:prstGeom prst="rect">
+            <a:avLst/>
+          </a:prstGeom>
+        </p:spPr>
+      </p:pic>
+      <p:sp>
+        <p:nvSpPr>
+          <p:cNvPr id="6" name="Text 3"/>
           <p:cNvSpPr/>
           <p:nvPr/>
         </p:nvSpPr>
@@ -1133,7 +1106,7 @@
       </p:sp>
       <p:sp>
         <p:nvSpPr>
-          <p:cNvPr id="7" name="Text 5"/>
+          <p:cNvPr id="7" name="Text 4"/>
           <p:cNvSpPr/>
           <p:nvPr/>
         </p:nvSpPr>
@@ -1172,7 +1145,7 @@
       </p:sp>
       <p:sp>
         <p:nvSpPr>
-          <p:cNvPr id="8" name="Text 6"/>
+          <p:cNvPr id="8" name="Text 5"/>
           <p:cNvSpPr/>
           <p:nvPr/>
         </p:nvSpPr>
@@ -1211,7 +1184,7 @@
       </p:sp>
       <p:sp>
         <p:nvSpPr>
-          <p:cNvPr id="9" name="Text 7"/>
+          <p:cNvPr id="9" name="Text 6"/>
           <p:cNvSpPr/>
           <p:nvPr/>
         </p:nvSpPr>
@@ -1250,7 +1223,7 @@
       </p:sp>
       <p:sp>
         <p:nvSpPr>
-          <p:cNvPr id="10" name="Text 8"/>
+          <p:cNvPr id="10" name="Text 7"/>
           <p:cNvSpPr/>
           <p:nvPr/>
         </p:nvSpPr>
@@ -1289,7 +1262,7 @@
       </p:sp>
       <p:sp>
         <p:nvSpPr>
-          <p:cNvPr id="11" name="Text 9"/>
+          <p:cNvPr id="11" name="Text 8"/>
           <p:cNvSpPr/>
           <p:nvPr/>
         </p:nvSpPr>
@@ -1328,7 +1301,7 @@
       </p:sp>
       <p:sp>
         <p:nvSpPr>
-          <p:cNvPr id="12" name="Text 10"/>
+          <p:cNvPr id="12" name="Text 9"/>
           <p:cNvSpPr/>
           <p:nvPr/>
         </p:nvSpPr>
@@ -1367,7 +1340,7 @@
       </p:sp>
       <p:sp>
         <p:nvSpPr>
-          <p:cNvPr id="13" name="Text 11"/>
+          <p:cNvPr id="13" name="Text 10"/>
           <p:cNvSpPr/>
           <p:nvPr/>
         </p:nvSpPr>
@@ -1406,7 +1379,7 @@
       </p:sp>
       <p:sp>
         <p:nvSpPr>
-          <p:cNvPr id="14" name="Text 12"/>
+          <p:cNvPr id="14" name="Text 11"/>
           <p:cNvSpPr/>
           <p:nvPr/>
         </p:nvSpPr>
@@ -1445,7 +1418,7 @@
       </p:sp>
       <p:sp>
         <p:nvSpPr>
-          <p:cNvPr id="15" name="Text 13"/>
+          <p:cNvPr id="15" name="Text 12"/>
           <p:cNvSpPr/>
           <p:nvPr/>
         </p:nvSpPr>
@@ -1484,7 +1457,7 @@
       </p:sp>
       <p:sp>
         <p:nvSpPr>
-          <p:cNvPr id="16" name="Text 14"/>
+          <p:cNvPr id="16" name="Text 13"/>
           <p:cNvSpPr/>
           <p:nvPr/>
         </p:nvSpPr>
@@ -1523,7 +1496,7 @@
       </p:sp>
       <p:sp>
         <p:nvSpPr>
-          <p:cNvPr id="17" name="Text 15"/>
+          <p:cNvPr id="17" name="Text 14"/>
           <p:cNvSpPr/>
           <p:nvPr/>
         </p:nvSpPr>
@@ -1562,7 +1535,7 @@
       </p:sp>
       <p:sp>
         <p:nvSpPr>
-          <p:cNvPr id="18" name="Text 16"/>
+          <p:cNvPr id="18" name="Text 15"/>
           <p:cNvSpPr/>
           <p:nvPr/>
         </p:nvSpPr>
@@ -1683,85 +1656,58 @@
       </p:sp>
       <p:sp>
         <p:nvSpPr>
-          <p:cNvPr id="4" name="Text 2"/>
-          <p:cNvSpPr/>
-          <p:nvPr/>
-        </p:nvSpPr>
-        <p:spPr>
-          <a:xfrm>
-            <a:off x="320040" y="146304"/>
-            <a:ext cx="1828800" cy="274320"/>
-          </a:xfrm>
-          <a:prstGeom prst="rect">
-            <a:avLst/>
-          </a:prstGeom>
-          <a:noFill/>
-          <a:ln/>
-        </p:spPr>
-        <p:txBody>
-          <a:bodyPr wrap="square" rtlCol="0" anchor="ctr"/>
-          <a:lstStyle/>
-          <a:p>
-            <a:pPr indent="0" marL="0">
-              <a:buNone/>
-            </a:pPr>
-            <a:r>
-              <a:rPr lang="en-US" sz="1300" b="1" dirty="0">
-                <a:solidFill>
-                  <a:srgbClr val="FFFFFF"/>
-                </a:solidFill>
-                <a:latin typeface="Arial" pitchFamily="34" charset="0"/>
-                <a:ea typeface="Arial" pitchFamily="34" charset="-122"/>
-                <a:cs typeface="Arial" pitchFamily="34" charset="-120"/>
-              </a:rPr>
-              <a:t>Danantara</a:t>
-            </a:r>
-            <a:endParaRPr lang="en-US" sz="1300" dirty="0"/>
-          </a:p>
-        </p:txBody>
-      </p:sp>
-      <p:sp>
-        <p:nvSpPr>
-          <p:cNvPr id="5" name="Text 3"/>
-          <p:cNvSpPr/>
-          <p:nvPr/>
-        </p:nvSpPr>
-        <p:spPr>
-          <a:xfrm>
-            <a:off x="320040" y="384048"/>
-            <a:ext cx="1828800" cy="274320"/>
-          </a:xfrm>
-          <a:prstGeom prst="rect">
-            <a:avLst/>
-          </a:prstGeom>
-          <a:noFill/>
-          <a:ln/>
-        </p:spPr>
-        <p:txBody>
-          <a:bodyPr wrap="square" rtlCol="0" anchor="ctr"/>
-          <a:lstStyle/>
-          <a:p>
-            <a:pPr indent="0" marL="0">
-              <a:buNone/>
-            </a:pPr>
-            <a:r>
-              <a:rPr lang="en-US" sz="1300" b="1" dirty="0">
-                <a:solidFill>
-                  <a:srgbClr val="FFFFFF"/>
-                </a:solidFill>
-                <a:latin typeface="Arial" pitchFamily="34" charset="0"/>
-                <a:ea typeface="Arial" pitchFamily="34" charset="-122"/>
-                <a:cs typeface="Arial" pitchFamily="34" charset="-120"/>
-              </a:rPr>
-              <a:t>Indonesia</a:t>
-            </a:r>
-            <a:endParaRPr lang="en-US" sz="1300" dirty="0"/>
-          </a:p>
-        </p:txBody>
-      </p:sp>
-      <p:sp>
-        <p:nvSpPr>
-          <p:cNvPr id="6" name="Text 4"/>
+          <p:cNvPr id="4" name="Shape 2"/>
+          <p:cNvSpPr/>
+          <p:nvPr/>
+        </p:nvSpPr>
+        <p:spPr>
+          <a:xfrm>
+            <a:off x="274320" y="201168"/>
+            <a:ext cx="713232" cy="713232"/>
+          </a:xfrm>
+          <a:prstGeom prst="roundRect">
+            <a:avLst>
+              <a:gd name="adj" fmla="val 15385"/>
+            </a:avLst>
+          </a:prstGeom>
+          <a:solidFill>
+            <a:srgbClr val="FFFFFF"/>
+          </a:solidFill>
+          <a:ln w="12700">
+            <a:solidFill>
+              <a:srgbClr val="FFFFFF"/>
+            </a:solidFill>
+            <a:prstDash val="solid"/>
+          </a:ln>
+        </p:spPr>
+      </p:sp>
+      <p:pic>
+        <p:nvPicPr>
+          <p:cNvPr id="5" name="Image 0" descr="preencoded.png">    </p:cNvPr>
+          <p:cNvPicPr>
+            <a:picLocks noChangeAspect="1"/>
+          </p:cNvPicPr>
+          <p:nvPr/>
+        </p:nvPicPr>
+        <p:blipFill>
+          <a:blip r:embed="rId1"/>
+          <a:stretch>
+            <a:fillRect/>
+          </a:stretch>
+        </p:blipFill>
+        <p:spPr>
+          <a:xfrm>
+            <a:off x="310896" y="237744"/>
+            <a:ext cx="640080" cy="640080"/>
+          </a:xfrm>
+          <a:prstGeom prst="rect">
+            <a:avLst/>
+          </a:prstGeom>
+        </p:spPr>
+      </p:pic>
+      <p:sp>
+        <p:nvSpPr>
+          <p:cNvPr id="6" name="Text 3"/>
           <p:cNvSpPr/>
           <p:nvPr/>
         </p:nvSpPr>
@@ -1800,7 +1746,7 @@
       </p:sp>
       <p:sp>
         <p:nvSpPr>
-          <p:cNvPr id="7" name="Text 5"/>
+          <p:cNvPr id="7" name="Text 4"/>
           <p:cNvSpPr/>
           <p:nvPr/>
         </p:nvSpPr>
@@ -1839,7 +1785,7 @@
       </p:sp>
       <p:sp>
         <p:nvSpPr>
-          <p:cNvPr id="8" name="Shape 6"/>
+          <p:cNvPr id="8" name="Shape 5"/>
           <p:cNvSpPr/>
           <p:nvPr/>
         </p:nvSpPr>
@@ -1866,7 +1812,7 @@
       </p:sp>
       <p:sp>
         <p:nvSpPr>
-          <p:cNvPr id="9" name="Text 7"/>
+          <p:cNvPr id="9" name="Text 6"/>
           <p:cNvSpPr/>
           <p:nvPr/>
         </p:nvSpPr>
@@ -1905,7 +1851,7 @@
       </p:sp>
       <p:sp>
         <p:nvSpPr>
-          <p:cNvPr id="10" name="Text 8"/>
+          <p:cNvPr id="10" name="Text 7"/>
           <p:cNvSpPr/>
           <p:nvPr/>
         </p:nvSpPr>
@@ -1944,7 +1890,7 @@
       </p:sp>
       <p:sp>
         <p:nvSpPr>
-          <p:cNvPr id="11" name="Shape 9"/>
+          <p:cNvPr id="11" name="Shape 8"/>
           <p:cNvSpPr/>
           <p:nvPr/>
         </p:nvSpPr>
@@ -1969,7 +1915,7 @@
       </p:sp>
       <p:sp>
         <p:nvSpPr>
-          <p:cNvPr id="12" name="Shape 10"/>
+          <p:cNvPr id="12" name="Shape 9"/>
           <p:cNvSpPr/>
           <p:nvPr/>
         </p:nvSpPr>
@@ -1996,14 +1942,14 @@
       </p:sp>
       <p:pic>
         <p:nvPicPr>
-          <p:cNvPr id="13" name="Image 0" descr="preencoded.png">    </p:cNvPr>
+          <p:cNvPr id="13" name="Image 1" descr="preencoded.png">    </p:cNvPr>
           <p:cNvPicPr>
             <a:picLocks noChangeAspect="1"/>
           </p:cNvPicPr>
           <p:nvPr/>
         </p:nvPicPr>
         <p:blipFill>
-          <a:blip r:embed="rId1"/>
+          <a:blip r:embed="rId2"/>
           <a:stretch>
             <a:fillRect/>
           </a:stretch>
@@ -2020,7 +1966,7 @@
       </p:pic>
       <p:sp>
         <p:nvSpPr>
-          <p:cNvPr id="14" name="Text 11"/>
+          <p:cNvPr id="14" name="Text 10"/>
           <p:cNvSpPr/>
           <p:nvPr/>
         </p:nvSpPr>
@@ -2061,7 +2007,7 @@
       </p:sp>
       <p:sp>
         <p:nvSpPr>
-          <p:cNvPr id="15" name="Shape 12"/>
+          <p:cNvPr id="15" name="Shape 11"/>
           <p:cNvSpPr/>
           <p:nvPr/>
         </p:nvSpPr>
@@ -2086,7 +2032,7 @@
       </p:sp>
       <p:sp>
         <p:nvSpPr>
-          <p:cNvPr id="16" name="Text 13"/>
+          <p:cNvPr id="16" name="Text 12"/>
           <p:cNvSpPr/>
           <p:nvPr/>
         </p:nvSpPr>
@@ -2125,7 +2071,7 @@
       </p:sp>
       <p:sp>
         <p:nvSpPr>
-          <p:cNvPr id="17" name="Shape 14"/>
+          <p:cNvPr id="17" name="Shape 13"/>
           <p:cNvSpPr/>
           <p:nvPr/>
         </p:nvSpPr>
@@ -2152,7 +2098,7 @@
       </p:sp>
       <p:sp>
         <p:nvSpPr>
-          <p:cNvPr id="18" name="Text 15"/>
+          <p:cNvPr id="18" name="Text 14"/>
           <p:cNvSpPr/>
           <p:nvPr/>
         </p:nvSpPr>
@@ -2191,7 +2137,7 @@
       </p:sp>
       <p:sp>
         <p:nvSpPr>
-          <p:cNvPr id="19" name="Shape 16"/>
+          <p:cNvPr id="19" name="Shape 15"/>
           <p:cNvSpPr/>
           <p:nvPr/>
         </p:nvSpPr>
@@ -2218,7 +2164,7 @@
       </p:sp>
       <p:sp>
         <p:nvSpPr>
-          <p:cNvPr id="20" name="Text 17"/>
+          <p:cNvPr id="20" name="Text 16"/>
           <p:cNvSpPr/>
           <p:nvPr/>
         </p:nvSpPr>
@@ -2257,7 +2203,7 @@
       </p:sp>
       <p:sp>
         <p:nvSpPr>
-          <p:cNvPr id="21" name="Shape 18"/>
+          <p:cNvPr id="21" name="Shape 17"/>
           <p:cNvSpPr/>
           <p:nvPr/>
         </p:nvSpPr>
@@ -2284,7 +2230,7 @@
       </p:sp>
       <p:sp>
         <p:nvSpPr>
-          <p:cNvPr id="22" name="Shape 19"/>
+          <p:cNvPr id="22" name="Shape 18"/>
           <p:cNvSpPr/>
           <p:nvPr/>
         </p:nvSpPr>
@@ -2309,7 +2255,7 @@
       </p:sp>
       <p:sp>
         <p:nvSpPr>
-          <p:cNvPr id="23" name="Text 20"/>
+          <p:cNvPr id="23" name="Text 19"/>
           <p:cNvSpPr/>
           <p:nvPr/>
         </p:nvSpPr>
@@ -2348,7 +2294,7 @@
       </p:sp>
       <p:sp>
         <p:nvSpPr>
-          <p:cNvPr id="24" name="Text 21"/>
+          <p:cNvPr id="24" name="Text 20"/>
           <p:cNvSpPr/>
           <p:nvPr/>
         </p:nvSpPr>
@@ -2387,7 +2333,7 @@
       </p:sp>
       <p:sp>
         <p:nvSpPr>
-          <p:cNvPr id="25" name="Shape 22"/>
+          <p:cNvPr id="25" name="Shape 21"/>
           <p:cNvSpPr/>
           <p:nvPr/>
         </p:nvSpPr>
@@ -2412,7 +2358,7 @@
       </p:sp>
       <p:sp>
         <p:nvSpPr>
-          <p:cNvPr id="26" name="Text 23"/>
+          <p:cNvPr id="26" name="Text 22"/>
           <p:cNvSpPr/>
           <p:nvPr/>
         </p:nvSpPr>
@@ -2451,7 +2397,7 @@
       </p:sp>
       <p:sp>
         <p:nvSpPr>
-          <p:cNvPr id="27" name="Text 24"/>
+          <p:cNvPr id="27" name="Text 23"/>
           <p:cNvSpPr/>
           <p:nvPr/>
         </p:nvSpPr>
@@ -2490,7 +2436,7 @@
       </p:sp>
       <p:sp>
         <p:nvSpPr>
-          <p:cNvPr id="28" name="Shape 25"/>
+          <p:cNvPr id="28" name="Shape 24"/>
           <p:cNvSpPr/>
           <p:nvPr/>
         </p:nvSpPr>
@@ -2515,7 +2461,7 @@
       </p:sp>
       <p:sp>
         <p:nvSpPr>
-          <p:cNvPr id="29" name="Text 26"/>
+          <p:cNvPr id="29" name="Text 25"/>
           <p:cNvSpPr/>
           <p:nvPr/>
         </p:nvSpPr>
@@ -2554,7 +2500,7 @@
       </p:sp>
       <p:sp>
         <p:nvSpPr>
-          <p:cNvPr id="30" name="Text 27"/>
+          <p:cNvPr id="30" name="Text 26"/>
           <p:cNvSpPr/>
           <p:nvPr/>
         </p:nvSpPr>
@@ -2593,7 +2539,7 @@
       </p:sp>
       <p:sp>
         <p:nvSpPr>
-          <p:cNvPr id="31" name="Shape 28"/>
+          <p:cNvPr id="31" name="Shape 27"/>
           <p:cNvSpPr/>
           <p:nvPr/>
         </p:nvSpPr>
@@ -2618,7 +2564,7 @@
       </p:sp>
       <p:sp>
         <p:nvSpPr>
-          <p:cNvPr id="32" name="Text 29"/>
+          <p:cNvPr id="32" name="Text 28"/>
           <p:cNvSpPr/>
           <p:nvPr/>
         </p:nvSpPr>
@@ -2657,7 +2603,7 @@
       </p:sp>
       <p:sp>
         <p:nvSpPr>
-          <p:cNvPr id="33" name="Text 30"/>
+          <p:cNvPr id="33" name="Text 29"/>
           <p:cNvSpPr/>
           <p:nvPr/>
         </p:nvSpPr>
@@ -2696,7 +2642,7 @@
       </p:sp>
       <p:sp>
         <p:nvSpPr>
-          <p:cNvPr id="34" name="Shape 31"/>
+          <p:cNvPr id="34" name="Shape 30"/>
           <p:cNvSpPr/>
           <p:nvPr/>
         </p:nvSpPr>
@@ -2721,7 +2667,7 @@
       </p:sp>
       <p:sp>
         <p:nvSpPr>
-          <p:cNvPr id="35" name="Text 32"/>
+          <p:cNvPr id="35" name="Text 31"/>
           <p:cNvSpPr/>
           <p:nvPr/>
         </p:nvSpPr>
@@ -2760,7 +2706,7 @@
       </p:sp>
       <p:sp>
         <p:nvSpPr>
-          <p:cNvPr id="36" name="Text 33"/>
+          <p:cNvPr id="36" name="Text 32"/>
           <p:cNvSpPr/>
           <p:nvPr/>
         </p:nvSpPr>

</xml_diff>

<commit_message>
Ranking PPTX: pakai background asli dari user sebagai template
Background kini memakai berkas gambar asli (1280x740) yang sudah memuat
latar biru, pita merah melengkung, logo Danantara, dan logo btn.

- Seluruh latar & logo yang tadinya DIGAMBAR DARI KODE dihapus: bentuk
  biru, pita merah (rect+ellipse), kotak logo Danantara, dan tulisan btn.
  Kalau dibiarkan, logo akan tampil dobel.
- Ukuran slide disesuaikan rasio background: 13,333 x 7,7081 inci
  (dari 13,333 x 7,5) supaya gambar tidak terpotong atau gepeng.
- Background ditanam base64 di dalam kode supaya ikut di dalam berkas
  PPTX yang diunduh.
- Versi Python memakai public/background-ranking.jpg.

Halaman /laporan/ranking TIDAK berubah; tetap ada 4 filter (periode,
jenis kantor, unit/cabang, posisi).
</commit_message>
<xml_diff>
--- a/ranking-nyata.pptx
+++ b/ranking-nyata.pptx
@@ -11,8 +11,8 @@
   <p:notesMasterIdLst>
     <p:notesMasterId r:id="rId4"/>
   </p:notesMasterIdLst>
-  <p:sldSz cx="12191695" cy="6858000"/>
-  <p:notesSz cx="6858000" cy="12191695"/>
+  <p:sldSz cx="12191695" cy="7048287"/>
+  <p:notesSz cx="7048287" cy="12191695"/>
   <p:defaultTextStyle>
     <a:lvl1pPr marL="0" algn="l" defTabSz="914400" rtl="0" eaLnBrk="1" latinLnBrk="0" hangingPunct="1">
       <a:defRPr sz="1800" kern="1200">
@@ -964,86 +964,9 @@
           <a:chExt cx="0" cy="0"/>
         </a:xfrm>
       </p:grpSpPr>
-      <p:sp>
-        <p:nvSpPr>
-          <p:cNvPr id="2" name="Shape 0"/>
-          <p:cNvSpPr/>
-          <p:nvPr/>
-        </p:nvSpPr>
-        <p:spPr>
-          <a:xfrm>
-            <a:off x="0" y="6172200"/>
-            <a:ext cx="12191695" cy="685800"/>
-          </a:xfrm>
-          <a:prstGeom prst="rect">
-            <a:avLst/>
-          </a:prstGeom>
-          <a:solidFill>
-            <a:srgbClr val="D4112E"/>
-          </a:solidFill>
-          <a:ln w="12700">
-            <a:solidFill>
-              <a:srgbClr val="D4112E"/>
-            </a:solidFill>
-            <a:prstDash val="solid"/>
-          </a:ln>
-        </p:spPr>
-      </p:sp>
-      <p:sp>
-        <p:nvSpPr>
-          <p:cNvPr id="3" name="Shape 1"/>
-          <p:cNvSpPr/>
-          <p:nvPr/>
-        </p:nvSpPr>
-        <p:spPr>
-          <a:xfrm>
-            <a:off x="-1097280" y="5806440"/>
-            <a:ext cx="14386255" cy="822960"/>
-          </a:xfrm>
-          <a:prstGeom prst="ellipse">
-            <a:avLst/>
-          </a:prstGeom>
-          <a:solidFill>
-            <a:srgbClr val="D4112E"/>
-          </a:solidFill>
-          <a:ln w="12700">
-            <a:solidFill>
-              <a:srgbClr val="D4112E"/>
-            </a:solidFill>
-            <a:prstDash val="solid"/>
-          </a:ln>
-        </p:spPr>
-      </p:sp>
-      <p:sp>
-        <p:nvSpPr>
-          <p:cNvPr id="4" name="Shape 2"/>
-          <p:cNvSpPr/>
-          <p:nvPr/>
-        </p:nvSpPr>
-        <p:spPr>
-          <a:xfrm>
-            <a:off x="274320" y="201168"/>
-            <a:ext cx="713232" cy="713232"/>
-          </a:xfrm>
-          <a:prstGeom prst="roundRect">
-            <a:avLst>
-              <a:gd name="adj" fmla="val 15385"/>
-            </a:avLst>
-          </a:prstGeom>
-          <a:solidFill>
-            <a:srgbClr val="FFFFFF"/>
-          </a:solidFill>
-          <a:ln w="12700">
-            <a:solidFill>
-              <a:srgbClr val="FFFFFF"/>
-            </a:solidFill>
-            <a:prstDash val="solid"/>
-          </a:ln>
-        </p:spPr>
-      </p:sp>
       <p:pic>
         <p:nvPicPr>
-          <p:cNvPr id="5" name="Image 0" descr="preencoded.png">    </p:cNvPr>
+          <p:cNvPr id="2" name="Image 0" descr="preencoded.png">    </p:cNvPr>
           <p:cNvPicPr>
             <a:picLocks noChangeAspect="1"/>
           </p:cNvPicPr>
@@ -1057,8 +980,8 @@
         </p:blipFill>
         <p:spPr>
           <a:xfrm>
-            <a:off x="310896" y="237744"/>
-            <a:ext cx="640080" cy="640080"/>
+            <a:off x="0" y="0"/>
+            <a:ext cx="12191695" cy="7048287"/>
           </a:xfrm>
           <a:prstGeom prst="rect">
             <a:avLst/>
@@ -1067,46 +990,7 @@
       </p:pic>
       <p:sp>
         <p:nvSpPr>
-          <p:cNvPr id="6" name="Text 3"/>
-          <p:cNvSpPr/>
-          <p:nvPr/>
-        </p:nvSpPr>
-        <p:spPr>
-          <a:xfrm>
-            <a:off x="10820095" y="201168"/>
-            <a:ext cx="1051560" cy="502920"/>
-          </a:xfrm>
-          <a:prstGeom prst="rect">
-            <a:avLst/>
-          </a:prstGeom>
-          <a:noFill/>
-          <a:ln/>
-        </p:spPr>
-        <p:txBody>
-          <a:bodyPr wrap="square" rtlCol="0" anchor="ctr"/>
-          <a:lstStyle/>
-          <a:p>
-            <a:pPr algn="r" indent="0" marL="0">
-              <a:buNone/>
-            </a:pPr>
-            <a:r>
-              <a:rPr lang="en-US" sz="3400" b="1" dirty="0">
-                <a:solidFill>
-                  <a:srgbClr val="FFFFFF"/>
-                </a:solidFill>
-                <a:latin typeface="Arial" pitchFamily="34" charset="0"/>
-                <a:ea typeface="Arial" pitchFamily="34" charset="-122"/>
-                <a:cs typeface="Arial" pitchFamily="34" charset="-120"/>
-              </a:rPr>
-              <a:t>btn</a:t>
-            </a:r>
-            <a:endParaRPr lang="en-US" sz="3400" dirty="0"/>
-          </a:p>
-        </p:txBody>
-      </p:sp>
-      <p:sp>
-        <p:nvSpPr>
-          <p:cNvPr id="7" name="Text 4"/>
+          <p:cNvPr id="3" name="Text 0"/>
           <p:cNvSpPr/>
           <p:nvPr/>
         </p:nvSpPr>
@@ -1145,7 +1029,7 @@
       </p:sp>
       <p:sp>
         <p:nvSpPr>
-          <p:cNvPr id="8" name="Text 5"/>
+          <p:cNvPr id="4" name="Text 1"/>
           <p:cNvSpPr/>
           <p:nvPr/>
         </p:nvSpPr>
@@ -1184,7 +1068,7 @@
       </p:sp>
       <p:sp>
         <p:nvSpPr>
-          <p:cNvPr id="9" name="Text 6"/>
+          <p:cNvPr id="5" name="Text 2"/>
           <p:cNvSpPr/>
           <p:nvPr/>
         </p:nvSpPr>
@@ -1223,7 +1107,7 @@
       </p:sp>
       <p:sp>
         <p:nvSpPr>
-          <p:cNvPr id="10" name="Text 7"/>
+          <p:cNvPr id="6" name="Text 3"/>
           <p:cNvSpPr/>
           <p:nvPr/>
         </p:nvSpPr>
@@ -1262,7 +1146,7 @@
       </p:sp>
       <p:sp>
         <p:nvSpPr>
-          <p:cNvPr id="11" name="Text 8"/>
+          <p:cNvPr id="7" name="Text 4"/>
           <p:cNvSpPr/>
           <p:nvPr/>
         </p:nvSpPr>
@@ -1301,7 +1185,7 @@
       </p:sp>
       <p:sp>
         <p:nvSpPr>
-          <p:cNvPr id="12" name="Text 9"/>
+          <p:cNvPr id="8" name="Text 5"/>
           <p:cNvSpPr/>
           <p:nvPr/>
         </p:nvSpPr>
@@ -1340,7 +1224,7 @@
       </p:sp>
       <p:sp>
         <p:nvSpPr>
-          <p:cNvPr id="13" name="Text 10"/>
+          <p:cNvPr id="9" name="Text 6"/>
           <p:cNvSpPr/>
           <p:nvPr/>
         </p:nvSpPr>
@@ -1379,7 +1263,7 @@
       </p:sp>
       <p:sp>
         <p:nvSpPr>
-          <p:cNvPr id="14" name="Text 11"/>
+          <p:cNvPr id="10" name="Text 7"/>
           <p:cNvSpPr/>
           <p:nvPr/>
         </p:nvSpPr>
@@ -1418,7 +1302,7 @@
       </p:sp>
       <p:sp>
         <p:nvSpPr>
-          <p:cNvPr id="15" name="Text 12"/>
+          <p:cNvPr id="11" name="Text 8"/>
           <p:cNvSpPr/>
           <p:nvPr/>
         </p:nvSpPr>
@@ -1457,7 +1341,7 @@
       </p:sp>
       <p:sp>
         <p:nvSpPr>
-          <p:cNvPr id="16" name="Text 13"/>
+          <p:cNvPr id="12" name="Text 9"/>
           <p:cNvSpPr/>
           <p:nvPr/>
         </p:nvSpPr>
@@ -1496,7 +1380,7 @@
       </p:sp>
       <p:sp>
         <p:nvSpPr>
-          <p:cNvPr id="17" name="Text 14"/>
+          <p:cNvPr id="13" name="Text 10"/>
           <p:cNvSpPr/>
           <p:nvPr/>
         </p:nvSpPr>
@@ -1535,7 +1419,7 @@
       </p:sp>
       <p:sp>
         <p:nvSpPr>
-          <p:cNvPr id="18" name="Text 15"/>
+          <p:cNvPr id="14" name="Text 11"/>
           <p:cNvSpPr/>
           <p:nvPr/>
         </p:nvSpPr>
@@ -1604,86 +1488,9 @@
           <a:chExt cx="0" cy="0"/>
         </a:xfrm>
       </p:grpSpPr>
-      <p:sp>
-        <p:nvSpPr>
-          <p:cNvPr id="2" name="Shape 0"/>
-          <p:cNvSpPr/>
-          <p:nvPr/>
-        </p:nvSpPr>
-        <p:spPr>
-          <a:xfrm>
-            <a:off x="0" y="6172200"/>
-            <a:ext cx="12191695" cy="685800"/>
-          </a:xfrm>
-          <a:prstGeom prst="rect">
-            <a:avLst/>
-          </a:prstGeom>
-          <a:solidFill>
-            <a:srgbClr val="D4112E"/>
-          </a:solidFill>
-          <a:ln w="12700">
-            <a:solidFill>
-              <a:srgbClr val="D4112E"/>
-            </a:solidFill>
-            <a:prstDash val="solid"/>
-          </a:ln>
-        </p:spPr>
-      </p:sp>
-      <p:sp>
-        <p:nvSpPr>
-          <p:cNvPr id="3" name="Shape 1"/>
-          <p:cNvSpPr/>
-          <p:nvPr/>
-        </p:nvSpPr>
-        <p:spPr>
-          <a:xfrm>
-            <a:off x="-1097280" y="5806440"/>
-            <a:ext cx="14386255" cy="822960"/>
-          </a:xfrm>
-          <a:prstGeom prst="ellipse">
-            <a:avLst/>
-          </a:prstGeom>
-          <a:solidFill>
-            <a:srgbClr val="D4112E"/>
-          </a:solidFill>
-          <a:ln w="12700">
-            <a:solidFill>
-              <a:srgbClr val="D4112E"/>
-            </a:solidFill>
-            <a:prstDash val="solid"/>
-          </a:ln>
-        </p:spPr>
-      </p:sp>
-      <p:sp>
-        <p:nvSpPr>
-          <p:cNvPr id="4" name="Shape 2"/>
-          <p:cNvSpPr/>
-          <p:nvPr/>
-        </p:nvSpPr>
-        <p:spPr>
-          <a:xfrm>
-            <a:off x="274320" y="201168"/>
-            <a:ext cx="713232" cy="713232"/>
-          </a:xfrm>
-          <a:prstGeom prst="roundRect">
-            <a:avLst>
-              <a:gd name="adj" fmla="val 15385"/>
-            </a:avLst>
-          </a:prstGeom>
-          <a:solidFill>
-            <a:srgbClr val="FFFFFF"/>
-          </a:solidFill>
-          <a:ln w="12700">
-            <a:solidFill>
-              <a:srgbClr val="FFFFFF"/>
-            </a:solidFill>
-            <a:prstDash val="solid"/>
-          </a:ln>
-        </p:spPr>
-      </p:sp>
       <p:pic>
         <p:nvPicPr>
-          <p:cNvPr id="5" name="Image 0" descr="preencoded.png">    </p:cNvPr>
+          <p:cNvPr id="2" name="Image 0" descr="preencoded.png">    </p:cNvPr>
           <p:cNvPicPr>
             <a:picLocks noChangeAspect="1"/>
           </p:cNvPicPr>
@@ -1697,8 +1504,8 @@
         </p:blipFill>
         <p:spPr>
           <a:xfrm>
-            <a:off x="310896" y="237744"/>
-            <a:ext cx="640080" cy="640080"/>
+            <a:off x="0" y="0"/>
+            <a:ext cx="12191695" cy="7048287"/>
           </a:xfrm>
           <a:prstGeom prst="rect">
             <a:avLst/>
@@ -1707,46 +1514,7 @@
       </p:pic>
       <p:sp>
         <p:nvSpPr>
-          <p:cNvPr id="6" name="Text 3"/>
-          <p:cNvSpPr/>
-          <p:nvPr/>
-        </p:nvSpPr>
-        <p:spPr>
-          <a:xfrm>
-            <a:off x="10820095" y="201168"/>
-            <a:ext cx="1051560" cy="502920"/>
-          </a:xfrm>
-          <a:prstGeom prst="rect">
-            <a:avLst/>
-          </a:prstGeom>
-          <a:noFill/>
-          <a:ln/>
-        </p:spPr>
-        <p:txBody>
-          <a:bodyPr wrap="square" rtlCol="0" anchor="ctr"/>
-          <a:lstStyle/>
-          <a:p>
-            <a:pPr algn="r" indent="0" marL="0">
-              <a:buNone/>
-            </a:pPr>
-            <a:r>
-              <a:rPr lang="en-US" sz="3400" b="1" dirty="0">
-                <a:solidFill>
-                  <a:srgbClr val="FFFFFF"/>
-                </a:solidFill>
-                <a:latin typeface="Arial" pitchFamily="34" charset="0"/>
-                <a:ea typeface="Arial" pitchFamily="34" charset="-122"/>
-                <a:cs typeface="Arial" pitchFamily="34" charset="-120"/>
-              </a:rPr>
-              <a:t>btn</a:t>
-            </a:r>
-            <a:endParaRPr lang="en-US" sz="3400" dirty="0"/>
-          </a:p>
-        </p:txBody>
-      </p:sp>
-      <p:sp>
-        <p:nvSpPr>
-          <p:cNvPr id="7" name="Text 4"/>
+          <p:cNvPr id="3" name="Text 0"/>
           <p:cNvSpPr/>
           <p:nvPr/>
         </p:nvSpPr>
@@ -1785,7 +1553,7 @@
       </p:sp>
       <p:sp>
         <p:nvSpPr>
-          <p:cNvPr id="8" name="Shape 5"/>
+          <p:cNvPr id="4" name="Shape 1"/>
           <p:cNvSpPr/>
           <p:nvPr/>
         </p:nvSpPr>
@@ -1812,7 +1580,7 @@
       </p:sp>
       <p:sp>
         <p:nvSpPr>
-          <p:cNvPr id="9" name="Text 6"/>
+          <p:cNvPr id="5" name="Text 2"/>
           <p:cNvSpPr/>
           <p:nvPr/>
         </p:nvSpPr>
@@ -1851,7 +1619,7 @@
       </p:sp>
       <p:sp>
         <p:nvSpPr>
-          <p:cNvPr id="10" name="Text 7"/>
+          <p:cNvPr id="6" name="Text 3"/>
           <p:cNvSpPr/>
           <p:nvPr/>
         </p:nvSpPr>
@@ -1890,7 +1658,7 @@
       </p:sp>
       <p:sp>
         <p:nvSpPr>
-          <p:cNvPr id="11" name="Shape 8"/>
+          <p:cNvPr id="7" name="Shape 4"/>
           <p:cNvSpPr/>
           <p:nvPr/>
         </p:nvSpPr>
@@ -1915,7 +1683,7 @@
       </p:sp>
       <p:sp>
         <p:nvSpPr>
-          <p:cNvPr id="12" name="Shape 9"/>
+          <p:cNvPr id="8" name="Shape 5"/>
           <p:cNvSpPr/>
           <p:nvPr/>
         </p:nvSpPr>
@@ -1942,7 +1710,7 @@
       </p:sp>
       <p:pic>
         <p:nvPicPr>
-          <p:cNvPr id="13" name="Image 1" descr="preencoded.png">    </p:cNvPr>
+          <p:cNvPr id="9" name="Image 1" descr="preencoded.png">    </p:cNvPr>
           <p:cNvPicPr>
             <a:picLocks noChangeAspect="1"/>
           </p:cNvPicPr>
@@ -1966,7 +1734,7 @@
       </p:pic>
       <p:sp>
         <p:nvSpPr>
-          <p:cNvPr id="14" name="Text 10"/>
+          <p:cNvPr id="10" name="Text 6"/>
           <p:cNvSpPr/>
           <p:nvPr/>
         </p:nvSpPr>
@@ -2007,7 +1775,7 @@
       </p:sp>
       <p:sp>
         <p:nvSpPr>
-          <p:cNvPr id="15" name="Shape 11"/>
+          <p:cNvPr id="11" name="Shape 7"/>
           <p:cNvSpPr/>
           <p:nvPr/>
         </p:nvSpPr>
@@ -2032,7 +1800,7 @@
       </p:sp>
       <p:sp>
         <p:nvSpPr>
-          <p:cNvPr id="16" name="Text 12"/>
+          <p:cNvPr id="12" name="Text 8"/>
           <p:cNvSpPr/>
           <p:nvPr/>
         </p:nvSpPr>
@@ -2071,7 +1839,7 @@
       </p:sp>
       <p:sp>
         <p:nvSpPr>
-          <p:cNvPr id="17" name="Shape 13"/>
+          <p:cNvPr id="13" name="Shape 9"/>
           <p:cNvSpPr/>
           <p:nvPr/>
         </p:nvSpPr>
@@ -2098,7 +1866,7 @@
       </p:sp>
       <p:sp>
         <p:nvSpPr>
-          <p:cNvPr id="18" name="Text 14"/>
+          <p:cNvPr id="14" name="Text 10"/>
           <p:cNvSpPr/>
           <p:nvPr/>
         </p:nvSpPr>
@@ -2137,13 +1905,13 @@
       </p:sp>
       <p:sp>
         <p:nvSpPr>
-          <p:cNvPr id="19" name="Shape 15"/>
-          <p:cNvSpPr/>
-          <p:nvPr/>
-        </p:nvSpPr>
-        <p:spPr>
-          <a:xfrm>
-            <a:off x="5254600" y="5925312"/>
+          <p:cNvPr id="15" name="Shape 11"/>
+          <p:cNvSpPr/>
+          <p:nvPr/>
+        </p:nvSpPr>
+        <p:spPr>
+          <a:xfrm>
+            <a:off x="5254600" y="6115599"/>
             <a:ext cx="1691640" cy="256032"/>
           </a:xfrm>
           <a:prstGeom prst="roundRect">
@@ -2164,13 +1932,13 @@
       </p:sp>
       <p:sp>
         <p:nvSpPr>
-          <p:cNvPr id="20" name="Text 16"/>
-          <p:cNvSpPr/>
-          <p:nvPr/>
-        </p:nvSpPr>
-        <p:spPr>
-          <a:xfrm>
-            <a:off x="5254600" y="5925312"/>
+          <p:cNvPr id="16" name="Text 12"/>
+          <p:cNvSpPr/>
+          <p:nvPr/>
+        </p:nvSpPr>
+        <p:spPr>
+          <a:xfrm>
+            <a:off x="5254600" y="6115599"/>
             <a:ext cx="1691640" cy="256032"/>
           </a:xfrm>
           <a:prstGeom prst="rect">
@@ -2203,13 +1971,13 @@
       </p:sp>
       <p:sp>
         <p:nvSpPr>
-          <p:cNvPr id="21" name="Shape 17"/>
-          <p:cNvSpPr/>
-          <p:nvPr/>
-        </p:nvSpPr>
-        <p:spPr>
-          <a:xfrm>
-            <a:off x="3883000" y="6199632"/>
+          <p:cNvPr id="17" name="Shape 13"/>
+          <p:cNvSpPr/>
+          <p:nvPr/>
+        </p:nvSpPr>
+        <p:spPr>
+          <a:xfrm>
+            <a:off x="3883000" y="6389919"/>
             <a:ext cx="4434840" cy="457200"/>
           </a:xfrm>
           <a:prstGeom prst="roundRect">
@@ -2230,13 +1998,13 @@
       </p:sp>
       <p:sp>
         <p:nvSpPr>
-          <p:cNvPr id="22" name="Shape 18"/>
-          <p:cNvSpPr/>
-          <p:nvPr/>
-        </p:nvSpPr>
-        <p:spPr>
-          <a:xfrm>
-            <a:off x="4084168" y="6309360"/>
+          <p:cNvPr id="18" name="Shape 14"/>
+          <p:cNvSpPr/>
+          <p:nvPr/>
+        </p:nvSpPr>
+        <p:spPr>
+          <a:xfrm>
+            <a:off x="4084168" y="6499647"/>
             <a:ext cx="91440" cy="91440"/>
           </a:xfrm>
           <a:prstGeom prst="ellipse">
@@ -2255,13 +2023,13 @@
       </p:sp>
       <p:sp>
         <p:nvSpPr>
-          <p:cNvPr id="23" name="Text 19"/>
-          <p:cNvSpPr/>
-          <p:nvPr/>
-        </p:nvSpPr>
-        <p:spPr>
-          <a:xfrm>
-            <a:off x="4212184" y="6263640"/>
+          <p:cNvPr id="19" name="Text 15"/>
+          <p:cNvSpPr/>
+          <p:nvPr/>
+        </p:nvSpPr>
+        <p:spPr>
+          <a:xfrm>
+            <a:off x="4212184" y="6453927"/>
             <a:ext cx="713232" cy="155448"/>
           </a:xfrm>
           <a:prstGeom prst="rect">
@@ -2294,13 +2062,13 @@
       </p:sp>
       <p:sp>
         <p:nvSpPr>
-          <p:cNvPr id="24" name="Text 20"/>
-          <p:cNvSpPr/>
-          <p:nvPr/>
-        </p:nvSpPr>
-        <p:spPr>
-          <a:xfrm>
-            <a:off x="4212184" y="6409944"/>
+          <p:cNvPr id="20" name="Text 16"/>
+          <p:cNvSpPr/>
+          <p:nvPr/>
+        </p:nvSpPr>
+        <p:spPr>
+          <a:xfrm>
+            <a:off x="4212184" y="6600231"/>
             <a:ext cx="713232" cy="155448"/>
           </a:xfrm>
           <a:prstGeom prst="rect">
@@ -2333,13 +2101,13 @@
       </p:sp>
       <p:sp>
         <p:nvSpPr>
-          <p:cNvPr id="25" name="Shape 21"/>
-          <p:cNvSpPr/>
-          <p:nvPr/>
-        </p:nvSpPr>
-        <p:spPr>
-          <a:xfrm>
-            <a:off x="4952848" y="6309360"/>
+          <p:cNvPr id="21" name="Shape 17"/>
+          <p:cNvSpPr/>
+          <p:nvPr/>
+        </p:nvSpPr>
+        <p:spPr>
+          <a:xfrm>
+            <a:off x="4952848" y="6499647"/>
             <a:ext cx="91440" cy="91440"/>
           </a:xfrm>
           <a:prstGeom prst="ellipse">
@@ -2358,13 +2126,13 @@
       </p:sp>
       <p:sp>
         <p:nvSpPr>
-          <p:cNvPr id="26" name="Text 22"/>
-          <p:cNvSpPr/>
-          <p:nvPr/>
-        </p:nvSpPr>
-        <p:spPr>
-          <a:xfrm>
-            <a:off x="5080864" y="6263640"/>
+          <p:cNvPr id="22" name="Text 18"/>
+          <p:cNvSpPr/>
+          <p:nvPr/>
+        </p:nvSpPr>
+        <p:spPr>
+          <a:xfrm>
+            <a:off x="5080864" y="6453927"/>
             <a:ext cx="713232" cy="155448"/>
           </a:xfrm>
           <a:prstGeom prst="rect">
@@ -2397,13 +2165,13 @@
       </p:sp>
       <p:sp>
         <p:nvSpPr>
-          <p:cNvPr id="27" name="Text 23"/>
-          <p:cNvSpPr/>
-          <p:nvPr/>
-        </p:nvSpPr>
-        <p:spPr>
-          <a:xfrm>
-            <a:off x="5080864" y="6409944"/>
+          <p:cNvPr id="23" name="Text 19"/>
+          <p:cNvSpPr/>
+          <p:nvPr/>
+        </p:nvSpPr>
+        <p:spPr>
+          <a:xfrm>
+            <a:off x="5080864" y="6600231"/>
             <a:ext cx="713232" cy="155448"/>
           </a:xfrm>
           <a:prstGeom prst="rect">
@@ -2436,13 +2204,13 @@
       </p:sp>
       <p:sp>
         <p:nvSpPr>
-          <p:cNvPr id="28" name="Shape 24"/>
-          <p:cNvSpPr/>
-          <p:nvPr/>
-        </p:nvSpPr>
-        <p:spPr>
-          <a:xfrm>
-            <a:off x="5821528" y="6309360"/>
+          <p:cNvPr id="24" name="Shape 20"/>
+          <p:cNvSpPr/>
+          <p:nvPr/>
+        </p:nvSpPr>
+        <p:spPr>
+          <a:xfrm>
+            <a:off x="5821528" y="6499647"/>
             <a:ext cx="91440" cy="91440"/>
           </a:xfrm>
           <a:prstGeom prst="ellipse">
@@ -2461,13 +2229,13 @@
       </p:sp>
       <p:sp>
         <p:nvSpPr>
-          <p:cNvPr id="29" name="Text 25"/>
-          <p:cNvSpPr/>
-          <p:nvPr/>
-        </p:nvSpPr>
-        <p:spPr>
-          <a:xfrm>
-            <a:off x="5949544" y="6263640"/>
+          <p:cNvPr id="25" name="Text 21"/>
+          <p:cNvSpPr/>
+          <p:nvPr/>
+        </p:nvSpPr>
+        <p:spPr>
+          <a:xfrm>
+            <a:off x="5949544" y="6453927"/>
             <a:ext cx="713232" cy="155448"/>
           </a:xfrm>
           <a:prstGeom prst="rect">
@@ -2500,13 +2268,13 @@
       </p:sp>
       <p:sp>
         <p:nvSpPr>
-          <p:cNvPr id="30" name="Text 26"/>
-          <p:cNvSpPr/>
-          <p:nvPr/>
-        </p:nvSpPr>
-        <p:spPr>
-          <a:xfrm>
-            <a:off x="5949544" y="6409944"/>
+          <p:cNvPr id="26" name="Text 22"/>
+          <p:cNvSpPr/>
+          <p:nvPr/>
+        </p:nvSpPr>
+        <p:spPr>
+          <a:xfrm>
+            <a:off x="5949544" y="6600231"/>
             <a:ext cx="713232" cy="155448"/>
           </a:xfrm>
           <a:prstGeom prst="rect">
@@ -2539,13 +2307,13 @@
       </p:sp>
       <p:sp>
         <p:nvSpPr>
-          <p:cNvPr id="31" name="Shape 27"/>
-          <p:cNvSpPr/>
-          <p:nvPr/>
-        </p:nvSpPr>
-        <p:spPr>
-          <a:xfrm>
-            <a:off x="6690208" y="6309360"/>
+          <p:cNvPr id="27" name="Shape 23"/>
+          <p:cNvSpPr/>
+          <p:nvPr/>
+        </p:nvSpPr>
+        <p:spPr>
+          <a:xfrm>
+            <a:off x="6690208" y="6499647"/>
             <a:ext cx="91440" cy="91440"/>
           </a:xfrm>
           <a:prstGeom prst="ellipse">
@@ -2564,13 +2332,13 @@
       </p:sp>
       <p:sp>
         <p:nvSpPr>
-          <p:cNvPr id="32" name="Text 28"/>
-          <p:cNvSpPr/>
-          <p:nvPr/>
-        </p:nvSpPr>
-        <p:spPr>
-          <a:xfrm>
-            <a:off x="6818224" y="6263640"/>
+          <p:cNvPr id="28" name="Text 24"/>
+          <p:cNvSpPr/>
+          <p:nvPr/>
+        </p:nvSpPr>
+        <p:spPr>
+          <a:xfrm>
+            <a:off x="6818224" y="6453927"/>
             <a:ext cx="713232" cy="155448"/>
           </a:xfrm>
           <a:prstGeom prst="rect">
@@ -2603,13 +2371,13 @@
       </p:sp>
       <p:sp>
         <p:nvSpPr>
-          <p:cNvPr id="33" name="Text 29"/>
-          <p:cNvSpPr/>
-          <p:nvPr/>
-        </p:nvSpPr>
-        <p:spPr>
-          <a:xfrm>
-            <a:off x="6818224" y="6409944"/>
+          <p:cNvPr id="29" name="Text 25"/>
+          <p:cNvSpPr/>
+          <p:nvPr/>
+        </p:nvSpPr>
+        <p:spPr>
+          <a:xfrm>
+            <a:off x="6818224" y="6600231"/>
             <a:ext cx="713232" cy="155448"/>
           </a:xfrm>
           <a:prstGeom prst="rect">
@@ -2642,13 +2410,13 @@
       </p:sp>
       <p:sp>
         <p:nvSpPr>
-          <p:cNvPr id="34" name="Shape 30"/>
-          <p:cNvSpPr/>
-          <p:nvPr/>
-        </p:nvSpPr>
-        <p:spPr>
-          <a:xfrm>
-            <a:off x="7558888" y="6309360"/>
+          <p:cNvPr id="30" name="Shape 26"/>
+          <p:cNvSpPr/>
+          <p:nvPr/>
+        </p:nvSpPr>
+        <p:spPr>
+          <a:xfrm>
+            <a:off x="7558888" y="6499647"/>
             <a:ext cx="91440" cy="91440"/>
           </a:xfrm>
           <a:prstGeom prst="ellipse">
@@ -2667,13 +2435,13 @@
       </p:sp>
       <p:sp>
         <p:nvSpPr>
-          <p:cNvPr id="35" name="Text 31"/>
-          <p:cNvSpPr/>
-          <p:nvPr/>
-        </p:nvSpPr>
-        <p:spPr>
-          <a:xfrm>
-            <a:off x="7686904" y="6263640"/>
+          <p:cNvPr id="31" name="Text 27"/>
+          <p:cNvSpPr/>
+          <p:nvPr/>
+        </p:nvSpPr>
+        <p:spPr>
+          <a:xfrm>
+            <a:off x="7686904" y="6453927"/>
             <a:ext cx="713232" cy="155448"/>
           </a:xfrm>
           <a:prstGeom prst="rect">
@@ -2706,13 +2474,13 @@
       </p:sp>
       <p:sp>
         <p:nvSpPr>
-          <p:cNvPr id="36" name="Text 32"/>
-          <p:cNvSpPr/>
-          <p:nvPr/>
-        </p:nvSpPr>
-        <p:spPr>
-          <a:xfrm>
-            <a:off x="7686904" y="6409944"/>
+          <p:cNvPr id="32" name="Text 28"/>
+          <p:cNvSpPr/>
+          <p:nvPr/>
+        </p:nvSpPr>
+        <p:spPr>
+          <a:xfrm>
+            <a:off x="7686904" y="6600231"/>
             <a:ext cx="713232" cy="155448"/>
           </a:xfrm>
           <a:prstGeom prst="rect">

</xml_diff>

<commit_message>
Ranking PPTX: pakai font Aptos untuk seluruh isi slide
Aptos adalah font bawaan Microsoft 365 / Office 2023+. PPTX hanya menyimpan
NAMA font, bukan gambar hurufnya, jadi berkas akan memakai Aptos asli saat
dibuka di komputer user yang punya font itu.

- 12 tempat fontFace diganti dari Arial ke Aptos
- Verifikasi: ppt/slides/slide2.xml memuat typeface="Aptos"
- scripts/atur-font-fontconfig.py memetakan Aptos -> Carlito di server ini
  supaya pratinjau render mendekati tampilan aslinya (server Linux tidak
  punya Aptos karena font itu milik Microsoft dan tidak boleh disebarkan).
  Ini HANYA mempengaruhi pratinjau di server, bukan berkas yang diunduh.
- 120 unit test + 20 pemeriksaan ranking lulus.
</commit_message>
<xml_diff>
--- a/ranking-nyata.pptx
+++ b/ranking-nyata.pptx
@@ -1067,9 +1067,9 @@
                 <a:solidFill>
                   <a:srgbClr val="FFFFFF"/>
                 </a:solidFill>
-                <a:latin typeface="Arial" pitchFamily="34" charset="0"/>
-                <a:ea typeface="Arial" pitchFamily="34" charset="-122"/>
-                <a:cs typeface="Arial" pitchFamily="34" charset="-120"/>
+                <a:latin typeface="Aptos" pitchFamily="34" charset="0"/>
+                <a:ea typeface="Aptos" pitchFamily="34" charset="-122"/>
+                <a:cs typeface="Aptos" pitchFamily="34" charset="-120"/>
               </a:rPr>
               <a:t>Service Drill Ranking</a:t>
             </a:r>
@@ -1135,9 +1135,9 @@
                 <a:solidFill>
                   <a:srgbClr val="FFFFFF"/>
                 </a:solidFill>
-                <a:latin typeface="Arial" pitchFamily="34" charset="0"/>
-                <a:ea typeface="Arial" pitchFamily="34" charset="-122"/>
-                <a:cs typeface="Arial" pitchFamily="34" charset="-120"/>
+                <a:latin typeface="Aptos" pitchFamily="34" charset="0"/>
+                <a:ea typeface="Aptos" pitchFamily="34" charset="-122"/>
+                <a:cs typeface="Aptos" pitchFamily="34" charset="-120"/>
               </a:rPr>
               <a:t>Semua unit</a:t>
             </a:r>
@@ -1176,9 +1176,9 @@
                 <a:solidFill>
                   <a:srgbClr val="FFFFFF"/>
                 </a:solidFill>
-                <a:latin typeface="Arial" pitchFamily="34" charset="0"/>
-                <a:ea typeface="Arial" pitchFamily="34" charset="-122"/>
-                <a:cs typeface="Arial" pitchFamily="34" charset="-120"/>
+                <a:latin typeface="Aptos" pitchFamily="34" charset="0"/>
+                <a:ea typeface="Aptos" pitchFamily="34" charset="-122"/>
+                <a:cs typeface="Aptos" pitchFamily="34" charset="-120"/>
               </a:rPr>
               <a:t>Semua posisi</a:t>
             </a:r>
@@ -1215,9 +1215,9 @@
                 <a:solidFill>
                   <a:srgbClr val="FFFFFF"/>
                 </a:solidFill>
-                <a:latin typeface="Arial" pitchFamily="34" charset="0"/>
-                <a:ea typeface="Arial" pitchFamily="34" charset="-122"/>
-                <a:cs typeface="Arial" pitchFamily="34" charset="-120"/>
+                <a:latin typeface="Aptos" pitchFamily="34" charset="0"/>
+                <a:ea typeface="Aptos" pitchFamily="34" charset="-122"/>
+                <a:cs typeface="Aptos" pitchFamily="34" charset="-120"/>
               </a:rPr>
               <a:t>Minggu ke-4 September 2026</a:t>
             </a:r>
@@ -1254,9 +1254,9 @@
                 <a:solidFill>
                   <a:srgbClr val="FFFFFF"/>
                 </a:solidFill>
-                <a:latin typeface="Arial" pitchFamily="34" charset="0"/>
-                <a:ea typeface="Arial" pitchFamily="34" charset="-122"/>
-                <a:cs typeface="Arial" pitchFamily="34" charset="-120"/>
+                <a:latin typeface="Aptos" pitchFamily="34" charset="0"/>
+                <a:ea typeface="Aptos" pitchFamily="34" charset="-122"/>
+                <a:cs typeface="Aptos" pitchFamily="34" charset="-120"/>
               </a:rPr>
               <a:t>Jenis kantor</a:t>
             </a:r>
@@ -1293,9 +1293,9 @@
                 <a:solidFill>
                   <a:srgbClr val="FFFFFF"/>
                 </a:solidFill>
-                <a:latin typeface="Arial" pitchFamily="34" charset="0"/>
-                <a:ea typeface="Arial" pitchFamily="34" charset="-122"/>
-                <a:cs typeface="Arial" pitchFamily="34" charset="-120"/>
+                <a:latin typeface="Aptos" pitchFamily="34" charset="0"/>
+                <a:ea typeface="Aptos" pitchFamily="34" charset="-122"/>
+                <a:cs typeface="Aptos" pitchFamily="34" charset="-120"/>
               </a:rPr>
               <a:t>: Semua jenis</a:t>
             </a:r>
@@ -1332,9 +1332,9 @@
                 <a:solidFill>
                   <a:srgbClr val="FFFFFF"/>
                 </a:solidFill>
-                <a:latin typeface="Arial" pitchFamily="34" charset="0"/>
-                <a:ea typeface="Arial" pitchFamily="34" charset="-122"/>
-                <a:cs typeface="Arial" pitchFamily="34" charset="-120"/>
+                <a:latin typeface="Aptos" pitchFamily="34" charset="0"/>
+                <a:ea typeface="Aptos" pitchFamily="34" charset="-122"/>
+                <a:cs typeface="Aptos" pitchFamily="34" charset="-120"/>
               </a:rPr>
               <a:t>Unit / cabang</a:t>
             </a:r>
@@ -1371,9 +1371,9 @@
                 <a:solidFill>
                   <a:srgbClr val="FFFFFF"/>
                 </a:solidFill>
-                <a:latin typeface="Arial" pitchFamily="34" charset="0"/>
-                <a:ea typeface="Arial" pitchFamily="34" charset="-122"/>
-                <a:cs typeface="Arial" pitchFamily="34" charset="-120"/>
+                <a:latin typeface="Aptos" pitchFamily="34" charset="0"/>
+                <a:ea typeface="Aptos" pitchFamily="34" charset="-122"/>
+                <a:cs typeface="Aptos" pitchFamily="34" charset="-120"/>
               </a:rPr>
               <a:t>: Semua unit</a:t>
             </a:r>
@@ -1410,9 +1410,9 @@
                 <a:solidFill>
                   <a:srgbClr val="FFFFFF"/>
                 </a:solidFill>
-                <a:latin typeface="Arial" pitchFamily="34" charset="0"/>
-                <a:ea typeface="Arial" pitchFamily="34" charset="-122"/>
-                <a:cs typeface="Arial" pitchFamily="34" charset="-120"/>
+                <a:latin typeface="Aptos" pitchFamily="34" charset="0"/>
+                <a:ea typeface="Aptos" pitchFamily="34" charset="-122"/>
+                <a:cs typeface="Aptos" pitchFamily="34" charset="-120"/>
               </a:rPr>
               <a:t>Posisi dinilai</a:t>
             </a:r>
@@ -1449,9 +1449,9 @@
                 <a:solidFill>
                   <a:srgbClr val="FFFFFF"/>
                 </a:solidFill>
-                <a:latin typeface="Arial" pitchFamily="34" charset="0"/>
-                <a:ea typeface="Arial" pitchFamily="34" charset="-122"/>
-                <a:cs typeface="Arial" pitchFamily="34" charset="-120"/>
+                <a:latin typeface="Aptos" pitchFamily="34" charset="0"/>
+                <a:ea typeface="Aptos" pitchFamily="34" charset="-122"/>
+                <a:cs typeface="Aptos" pitchFamily="34" charset="-120"/>
               </a:rPr>
               <a:t>: Semua posisi</a:t>
             </a:r>
@@ -1488,9 +1488,9 @@
                 <a:solidFill>
                   <a:srgbClr val="FFFFFF"/>
                 </a:solidFill>
-                <a:latin typeface="Arial" pitchFamily="34" charset="0"/>
-                <a:ea typeface="Arial" pitchFamily="34" charset="-122"/>
-                <a:cs typeface="Arial" pitchFamily="34" charset="-120"/>
+                <a:latin typeface="Aptos" pitchFamily="34" charset="0"/>
+                <a:ea typeface="Aptos" pitchFamily="34" charset="-122"/>
+                <a:cs typeface="Aptos" pitchFamily="34" charset="-120"/>
               </a:rPr>
               <a:t>Periode</a:t>
             </a:r>
@@ -1527,9 +1527,9 @@
                 <a:solidFill>
                   <a:srgbClr val="FFFFFF"/>
                 </a:solidFill>
-                <a:latin typeface="Arial" pitchFamily="34" charset="0"/>
-                <a:ea typeface="Arial" pitchFamily="34" charset="-122"/>
-                <a:cs typeface="Arial" pitchFamily="34" charset="-120"/>
+                <a:latin typeface="Aptos" pitchFamily="34" charset="0"/>
+                <a:ea typeface="Aptos" pitchFamily="34" charset="-122"/>
+                <a:cs typeface="Aptos" pitchFamily="34" charset="-120"/>
               </a:rPr>
               <a:t>: Minggu ke-4 September 2026</a:t>
             </a:r>
@@ -1566,9 +1566,9 @@
                 <a:solidFill>
                   <a:srgbClr val="FFFFFF"/>
                 </a:solidFill>
-                <a:latin typeface="Arial" pitchFamily="34" charset="0"/>
-                <a:ea typeface="Arial" pitchFamily="34" charset="-122"/>
-                <a:cs typeface="Arial" pitchFamily="34" charset="-120"/>
+                <a:latin typeface="Aptos" pitchFamily="34" charset="0"/>
+                <a:ea typeface="Aptos" pitchFamily="34" charset="-122"/>
+                <a:cs typeface="Aptos" pitchFamily="34" charset="-120"/>
               </a:rPr>
               <a:t>Jumlah peserta</a:t>
             </a:r>
@@ -1605,9 +1605,9 @@
                 <a:solidFill>
                   <a:srgbClr val="FFFFFF"/>
                 </a:solidFill>
-                <a:latin typeface="Arial" pitchFamily="34" charset="0"/>
-                <a:ea typeface="Arial" pitchFamily="34" charset="-122"/>
-                <a:cs typeface="Arial" pitchFamily="34" charset="-120"/>
+                <a:latin typeface="Aptos" pitchFamily="34" charset="0"/>
+                <a:ea typeface="Aptos" pitchFamily="34" charset="-122"/>
+                <a:cs typeface="Aptos" pitchFamily="34" charset="-120"/>
               </a:rPr>
               <a:t>: 1</a:t>
             </a:r>
@@ -1698,9 +1698,9 @@
                 <a:solidFill>
                   <a:srgbClr val="FFFFFF"/>
                 </a:solidFill>
-                <a:latin typeface="Arial" pitchFamily="34" charset="0"/>
-                <a:ea typeface="Arial" pitchFamily="34" charset="-122"/>
-                <a:cs typeface="Arial" pitchFamily="34" charset="-120"/>
+                <a:latin typeface="Aptos" pitchFamily="34" charset="0"/>
+                <a:ea typeface="Aptos" pitchFamily="34" charset="-122"/>
+                <a:cs typeface="Aptos" pitchFamily="34" charset="-120"/>
               </a:rPr>
               <a:t>SKALA PENILAIAN</a:t>
             </a:r>
@@ -1764,9 +1764,9 @@
                 <a:solidFill>
                   <a:srgbClr val="222222"/>
                 </a:solidFill>
-                <a:latin typeface="Arial" pitchFamily="34" charset="0"/>
-                <a:ea typeface="Arial" pitchFamily="34" charset="-122"/>
-                <a:cs typeface="Arial" pitchFamily="34" charset="-120"/>
+                <a:latin typeface="Aptos" pitchFamily="34" charset="0"/>
+                <a:ea typeface="Aptos" pitchFamily="34" charset="-122"/>
+                <a:cs typeface="Aptos" pitchFamily="34" charset="-120"/>
               </a:rPr>
               <a:t>4,80-5,00</a:t>
             </a:r>
@@ -1805,9 +1805,9 @@
                 <a:solidFill>
                   <a:srgbClr val="333333"/>
                 </a:solidFill>
-                <a:latin typeface="Arial" pitchFamily="34" charset="0"/>
-                <a:ea typeface="Arial" pitchFamily="34" charset="-122"/>
-                <a:cs typeface="Arial" pitchFamily="34" charset="-120"/>
+                <a:latin typeface="Aptos" pitchFamily="34" charset="0"/>
+                <a:ea typeface="Aptos" pitchFamily="34" charset="-122"/>
+                <a:cs typeface="Aptos" pitchFamily="34" charset="-120"/>
               </a:rPr>
               <a:t>Istimewa</a:t>
             </a:r>
@@ -1871,9 +1871,9 @@
                 <a:solidFill>
                   <a:srgbClr val="222222"/>
                 </a:solidFill>
-                <a:latin typeface="Arial" pitchFamily="34" charset="0"/>
-                <a:ea typeface="Arial" pitchFamily="34" charset="-122"/>
-                <a:cs typeface="Arial" pitchFamily="34" charset="-120"/>
+                <a:latin typeface="Aptos" pitchFamily="34" charset="0"/>
+                <a:ea typeface="Aptos" pitchFamily="34" charset="-122"/>
+                <a:cs typeface="Aptos" pitchFamily="34" charset="-120"/>
               </a:rPr>
               <a:t>4,60-4,79</a:t>
             </a:r>
@@ -1912,9 +1912,9 @@
                 <a:solidFill>
                   <a:srgbClr val="333333"/>
                 </a:solidFill>
-                <a:latin typeface="Arial" pitchFamily="34" charset="0"/>
-                <a:ea typeface="Arial" pitchFamily="34" charset="-122"/>
-                <a:cs typeface="Arial" pitchFamily="34" charset="-120"/>
+                <a:latin typeface="Aptos" pitchFamily="34" charset="0"/>
+                <a:ea typeface="Aptos" pitchFamily="34" charset="-122"/>
+                <a:cs typeface="Aptos" pitchFamily="34" charset="-120"/>
               </a:rPr>
               <a:t>Sangat Baik</a:t>
             </a:r>
@@ -1978,9 +1978,9 @@
                 <a:solidFill>
                   <a:srgbClr val="222222"/>
                 </a:solidFill>
-                <a:latin typeface="Arial" pitchFamily="34" charset="0"/>
-                <a:ea typeface="Arial" pitchFamily="34" charset="-122"/>
-                <a:cs typeface="Arial" pitchFamily="34" charset="-120"/>
+                <a:latin typeface="Aptos" pitchFamily="34" charset="0"/>
+                <a:ea typeface="Aptos" pitchFamily="34" charset="-122"/>
+                <a:cs typeface="Aptos" pitchFamily="34" charset="-120"/>
               </a:rPr>
               <a:t>4,00-4,59</a:t>
             </a:r>
@@ -2019,9 +2019,9 @@
                 <a:solidFill>
                   <a:srgbClr val="333333"/>
                 </a:solidFill>
-                <a:latin typeface="Arial" pitchFamily="34" charset="0"/>
-                <a:ea typeface="Arial" pitchFamily="34" charset="-122"/>
-                <a:cs typeface="Arial" pitchFamily="34" charset="-120"/>
+                <a:latin typeface="Aptos" pitchFamily="34" charset="0"/>
+                <a:ea typeface="Aptos" pitchFamily="34" charset="-122"/>
+                <a:cs typeface="Aptos" pitchFamily="34" charset="-120"/>
               </a:rPr>
               <a:t>Baik</a:t>
             </a:r>
@@ -2085,9 +2085,9 @@
                 <a:solidFill>
                   <a:srgbClr val="222222"/>
                 </a:solidFill>
-                <a:latin typeface="Arial" pitchFamily="34" charset="0"/>
-                <a:ea typeface="Arial" pitchFamily="34" charset="-122"/>
-                <a:cs typeface="Arial" pitchFamily="34" charset="-120"/>
+                <a:latin typeface="Aptos" pitchFamily="34" charset="0"/>
+                <a:ea typeface="Aptos" pitchFamily="34" charset="-122"/>
+                <a:cs typeface="Aptos" pitchFamily="34" charset="-120"/>
               </a:rPr>
               <a:t>3,60-3,99</a:t>
             </a:r>
@@ -2126,9 +2126,9 @@
                 <a:solidFill>
                   <a:srgbClr val="333333"/>
                 </a:solidFill>
-                <a:latin typeface="Arial" pitchFamily="34" charset="0"/>
-                <a:ea typeface="Arial" pitchFamily="34" charset="-122"/>
-                <a:cs typeface="Arial" pitchFamily="34" charset="-120"/>
+                <a:latin typeface="Aptos" pitchFamily="34" charset="0"/>
+                <a:ea typeface="Aptos" pitchFamily="34" charset="-122"/>
+                <a:cs typeface="Aptos" pitchFamily="34" charset="-120"/>
               </a:rPr>
               <a:t>Cukup</a:t>
             </a:r>
@@ -2192,9 +2192,9 @@
                 <a:solidFill>
                   <a:srgbClr val="222222"/>
                 </a:solidFill>
-                <a:latin typeface="Arial" pitchFamily="34" charset="0"/>
-                <a:ea typeface="Arial" pitchFamily="34" charset="-122"/>
-                <a:cs typeface="Arial" pitchFamily="34" charset="-120"/>
+                <a:latin typeface="Aptos" pitchFamily="34" charset="0"/>
+                <a:ea typeface="Aptos" pitchFamily="34" charset="-122"/>
+                <a:cs typeface="Aptos" pitchFamily="34" charset="-120"/>
               </a:rPr>
               <a:t>&lt;3,59</a:t>
             </a:r>
@@ -2233,9 +2233,9 @@
                 <a:solidFill>
                   <a:srgbClr val="333333"/>
                 </a:solidFill>
-                <a:latin typeface="Arial" pitchFamily="34" charset="0"/>
-                <a:ea typeface="Arial" pitchFamily="34" charset="-122"/>
-                <a:cs typeface="Arial" pitchFamily="34" charset="-120"/>
+                <a:latin typeface="Aptos" pitchFamily="34" charset="0"/>
+                <a:ea typeface="Aptos" pitchFamily="34" charset="-122"/>
+                <a:cs typeface="Aptos" pitchFamily="34" charset="-120"/>
               </a:rPr>
               <a:t>Kurang</a:t>
             </a:r>
@@ -2378,9 +2378,9 @@
                 <a:solidFill>
                   <a:srgbClr val="FFFFFF"/>
                 </a:solidFill>
-                <a:latin typeface="Arial" pitchFamily="34" charset="0"/>
-                <a:ea typeface="Arial" pitchFamily="34" charset="-122"/>
-                <a:cs typeface="Arial" pitchFamily="34" charset="-120"/>
+                <a:latin typeface="Aptos" pitchFamily="34" charset="0"/>
+                <a:ea typeface="Aptos" pitchFamily="34" charset="-122"/>
+                <a:cs typeface="Aptos" pitchFamily="34" charset="-120"/>
               </a:rPr>
               <a:t>Service Drill Ranking</a:t>
             </a:r>
@@ -2446,9 +2446,9 @@
                 <a:solidFill>
                   <a:srgbClr val="FFFFFF"/>
                 </a:solidFill>
-                <a:latin typeface="Arial" pitchFamily="34" charset="0"/>
-                <a:ea typeface="Arial" pitchFamily="34" charset="-122"/>
-                <a:cs typeface="Arial" pitchFamily="34" charset="-120"/>
+                <a:latin typeface="Aptos" pitchFamily="34" charset="0"/>
+                <a:ea typeface="Aptos" pitchFamily="34" charset="-122"/>
+                <a:cs typeface="Aptos" pitchFamily="34" charset="-120"/>
               </a:rPr>
               <a:t>244 KC MAMUJU</a:t>
             </a:r>
@@ -2487,9 +2487,9 @@
                 <a:solidFill>
                   <a:srgbClr val="FFFFFF"/>
                 </a:solidFill>
-                <a:latin typeface="Arial" pitchFamily="34" charset="0"/>
-                <a:ea typeface="Arial" pitchFamily="34" charset="-122"/>
-                <a:cs typeface="Arial" pitchFamily="34" charset="-120"/>
+                <a:latin typeface="Aptos" pitchFamily="34" charset="0"/>
+                <a:ea typeface="Aptos" pitchFamily="34" charset="-122"/>
+                <a:cs typeface="Aptos" pitchFamily="34" charset="-120"/>
               </a:rPr>
               <a:t>Teller</a:t>
             </a:r>
@@ -2604,9 +2604,9 @@
                 <a:solidFill>
                   <a:srgbClr val="FFFFFF"/>
                 </a:solidFill>
-                <a:latin typeface="Arial" pitchFamily="34" charset="0"/>
-                <a:ea typeface="Arial" pitchFamily="34" charset="-122"/>
-                <a:cs typeface="Arial" pitchFamily="34" charset="-120"/>
+                <a:latin typeface="Aptos" pitchFamily="34" charset="0"/>
+                <a:ea typeface="Aptos" pitchFamily="34" charset="-122"/>
+                <a:cs typeface="Aptos" pitchFamily="34" charset="-120"/>
               </a:rPr>
               <a:t>IRWAN ALLO</a:t>
             </a:r>
@@ -2668,9 +2668,9 @@
                 <a:solidFill>
                   <a:srgbClr val="FFFFFF"/>
                 </a:solidFill>
-                <a:latin typeface="Arial" pitchFamily="34" charset="0"/>
-                <a:ea typeface="Arial" pitchFamily="34" charset="-122"/>
-                <a:cs typeface="Arial" pitchFamily="34" charset="-120"/>
+                <a:latin typeface="Aptos" pitchFamily="34" charset="0"/>
+                <a:ea typeface="Aptos" pitchFamily="34" charset="-122"/>
+                <a:cs typeface="Aptos" pitchFamily="34" charset="-120"/>
               </a:rPr>
               <a:t>3,51</a:t>
             </a:r>
@@ -2736,9 +2736,9 @@
                 <a:solidFill>
                   <a:srgbClr val="FFFFFF"/>
                 </a:solidFill>
-                <a:latin typeface="Arial" pitchFamily="34" charset="0"/>
-                <a:ea typeface="Arial" pitchFamily="34" charset="-122"/>
-                <a:cs typeface="Arial" pitchFamily="34" charset="-120"/>
+                <a:latin typeface="Aptos" pitchFamily="34" charset="0"/>
+                <a:ea typeface="Aptos" pitchFamily="34" charset="-122"/>
+                <a:cs typeface="Aptos" pitchFamily="34" charset="-120"/>
               </a:rPr>
               <a:t>Kurang</a:t>
             </a:r>
@@ -2829,9 +2829,9 @@
                 <a:solidFill>
                   <a:srgbClr val="FFFFFF"/>
                 </a:solidFill>
-                <a:latin typeface="Arial" pitchFamily="34" charset="0"/>
-                <a:ea typeface="Arial" pitchFamily="34" charset="-122"/>
-                <a:cs typeface="Arial" pitchFamily="34" charset="-120"/>
+                <a:latin typeface="Aptos" pitchFamily="34" charset="0"/>
+                <a:ea typeface="Aptos" pitchFamily="34" charset="-122"/>
+                <a:cs typeface="Aptos" pitchFamily="34" charset="-120"/>
               </a:rPr>
               <a:t>SKALA PENILAIAN</a:t>
             </a:r>
@@ -2895,9 +2895,9 @@
                 <a:solidFill>
                   <a:srgbClr val="222222"/>
                 </a:solidFill>
-                <a:latin typeface="Arial" pitchFamily="34" charset="0"/>
-                <a:ea typeface="Arial" pitchFamily="34" charset="-122"/>
-                <a:cs typeface="Arial" pitchFamily="34" charset="-120"/>
+                <a:latin typeface="Aptos" pitchFamily="34" charset="0"/>
+                <a:ea typeface="Aptos" pitchFamily="34" charset="-122"/>
+                <a:cs typeface="Aptos" pitchFamily="34" charset="-120"/>
               </a:rPr>
               <a:t>4,80-5,00</a:t>
             </a:r>
@@ -2936,9 +2936,9 @@
                 <a:solidFill>
                   <a:srgbClr val="333333"/>
                 </a:solidFill>
-                <a:latin typeface="Arial" pitchFamily="34" charset="0"/>
-                <a:ea typeface="Arial" pitchFamily="34" charset="-122"/>
-                <a:cs typeface="Arial" pitchFamily="34" charset="-120"/>
+                <a:latin typeface="Aptos" pitchFamily="34" charset="0"/>
+                <a:ea typeface="Aptos" pitchFamily="34" charset="-122"/>
+                <a:cs typeface="Aptos" pitchFamily="34" charset="-120"/>
               </a:rPr>
               <a:t>Istimewa</a:t>
             </a:r>
@@ -3002,9 +3002,9 @@
                 <a:solidFill>
                   <a:srgbClr val="222222"/>
                 </a:solidFill>
-                <a:latin typeface="Arial" pitchFamily="34" charset="0"/>
-                <a:ea typeface="Arial" pitchFamily="34" charset="-122"/>
-                <a:cs typeface="Arial" pitchFamily="34" charset="-120"/>
+                <a:latin typeface="Aptos" pitchFamily="34" charset="0"/>
+                <a:ea typeface="Aptos" pitchFamily="34" charset="-122"/>
+                <a:cs typeface="Aptos" pitchFamily="34" charset="-120"/>
               </a:rPr>
               <a:t>4,60-4,79</a:t>
             </a:r>
@@ -3043,9 +3043,9 @@
                 <a:solidFill>
                   <a:srgbClr val="333333"/>
                 </a:solidFill>
-                <a:latin typeface="Arial" pitchFamily="34" charset="0"/>
-                <a:ea typeface="Arial" pitchFamily="34" charset="-122"/>
-                <a:cs typeface="Arial" pitchFamily="34" charset="-120"/>
+                <a:latin typeface="Aptos" pitchFamily="34" charset="0"/>
+                <a:ea typeface="Aptos" pitchFamily="34" charset="-122"/>
+                <a:cs typeface="Aptos" pitchFamily="34" charset="-120"/>
               </a:rPr>
               <a:t>Sangat Baik</a:t>
             </a:r>
@@ -3109,9 +3109,9 @@
                 <a:solidFill>
                   <a:srgbClr val="222222"/>
                 </a:solidFill>
-                <a:latin typeface="Arial" pitchFamily="34" charset="0"/>
-                <a:ea typeface="Arial" pitchFamily="34" charset="-122"/>
-                <a:cs typeface="Arial" pitchFamily="34" charset="-120"/>
+                <a:latin typeface="Aptos" pitchFamily="34" charset="0"/>
+                <a:ea typeface="Aptos" pitchFamily="34" charset="-122"/>
+                <a:cs typeface="Aptos" pitchFamily="34" charset="-120"/>
               </a:rPr>
               <a:t>4,00-4,59</a:t>
             </a:r>
@@ -3150,9 +3150,9 @@
                 <a:solidFill>
                   <a:srgbClr val="333333"/>
                 </a:solidFill>
-                <a:latin typeface="Arial" pitchFamily="34" charset="0"/>
-                <a:ea typeface="Arial" pitchFamily="34" charset="-122"/>
-                <a:cs typeface="Arial" pitchFamily="34" charset="-120"/>
+                <a:latin typeface="Aptos" pitchFamily="34" charset="0"/>
+                <a:ea typeface="Aptos" pitchFamily="34" charset="-122"/>
+                <a:cs typeface="Aptos" pitchFamily="34" charset="-120"/>
               </a:rPr>
               <a:t>Baik</a:t>
             </a:r>
@@ -3216,9 +3216,9 @@
                 <a:solidFill>
                   <a:srgbClr val="222222"/>
                 </a:solidFill>
-                <a:latin typeface="Arial" pitchFamily="34" charset="0"/>
-                <a:ea typeface="Arial" pitchFamily="34" charset="-122"/>
-                <a:cs typeface="Arial" pitchFamily="34" charset="-120"/>
+                <a:latin typeface="Aptos" pitchFamily="34" charset="0"/>
+                <a:ea typeface="Aptos" pitchFamily="34" charset="-122"/>
+                <a:cs typeface="Aptos" pitchFamily="34" charset="-120"/>
               </a:rPr>
               <a:t>3,60-3,99</a:t>
             </a:r>
@@ -3257,9 +3257,9 @@
                 <a:solidFill>
                   <a:srgbClr val="333333"/>
                 </a:solidFill>
-                <a:latin typeface="Arial" pitchFamily="34" charset="0"/>
-                <a:ea typeface="Arial" pitchFamily="34" charset="-122"/>
-                <a:cs typeface="Arial" pitchFamily="34" charset="-120"/>
+                <a:latin typeface="Aptos" pitchFamily="34" charset="0"/>
+                <a:ea typeface="Aptos" pitchFamily="34" charset="-122"/>
+                <a:cs typeface="Aptos" pitchFamily="34" charset="-120"/>
               </a:rPr>
               <a:t>Cukup</a:t>
             </a:r>
@@ -3323,9 +3323,9 @@
                 <a:solidFill>
                   <a:srgbClr val="222222"/>
                 </a:solidFill>
-                <a:latin typeface="Arial" pitchFamily="34" charset="0"/>
-                <a:ea typeface="Arial" pitchFamily="34" charset="-122"/>
-                <a:cs typeface="Arial" pitchFamily="34" charset="-120"/>
+                <a:latin typeface="Aptos" pitchFamily="34" charset="0"/>
+                <a:ea typeface="Aptos" pitchFamily="34" charset="-122"/>
+                <a:cs typeface="Aptos" pitchFamily="34" charset="-120"/>
               </a:rPr>
               <a:t>&lt;3,59</a:t>
             </a:r>
@@ -3364,9 +3364,9 @@
                 <a:solidFill>
                   <a:srgbClr val="333333"/>
                 </a:solidFill>
-                <a:latin typeface="Arial" pitchFamily="34" charset="0"/>
-                <a:ea typeface="Arial" pitchFamily="34" charset="-122"/>
-                <a:cs typeface="Arial" pitchFamily="34" charset="-120"/>
+                <a:latin typeface="Aptos" pitchFamily="34" charset="0"/>
+                <a:ea typeface="Aptos" pitchFamily="34" charset="-122"/>
+                <a:cs typeface="Aptos" pitchFamily="34" charset="-120"/>
               </a:rPr>
               <a:t>Kurang</a:t>
             </a:r>

</xml_diff>

<commit_message>
Ranking PPTX: nama cabang pakai Poppins transparan, ukuran font sesuai file asli
Ukuran font diambil dari file asli lewat scripts/ekstrak-font-pptx.py
(bukan perkiraan):
  Judul                 44 pt  tebal   Aptos
  Nama unit (cabang)    20 pt  tebal   Poppins  <-- font berbeda
  Nama posisi           24 pt          Aptos
  Legenda: rentang      10 pt  tebal
  Legenda: nama kategori 8,5 pt
  Pil kategori          12 pt  tebal

- Kotak nama cabang kini berlatar TRANSPARAN (hanya garis putih), sesuai
  permintaan user
- Font Poppins dipasang di server dari Google Fonts (lisensi OFL) supaya
  pratinjau render akurat; font untuk nama cabang sebelumnya masih Aptos
- Warna teks legenda disamakan #142D64 sesuai file asli

Verifikasi: ppt/slides/slide2.xml memuat typeface Poppins + Aptos dan
ukuran 850/1000/1200/2000/2400/4400 (×1/100 pt).
120 unit test + 20 pemeriksaan ranking lulus.
</commit_message>
<xml_diff>
--- a/ranking-nyata.pptx
+++ b/ranking-nyata.pptx
@@ -1063,7 +1063,7 @@
               <a:buNone/>
             </a:pPr>
             <a:r>
-              <a:rPr lang="en-US" sz="4000" b="1" dirty="0">
+              <a:rPr lang="en-US" sz="4400" b="1" dirty="0">
                 <a:solidFill>
                   <a:srgbClr val="FFFFFF"/>
                 </a:solidFill>
@@ -1073,7 +1073,7 @@
               </a:rPr>
               <a:t>Service Drill Ranking</a:t>
             </a:r>
-            <a:endParaRPr lang="en-US" sz="4000" dirty="0"/>
+            <a:endParaRPr lang="en-US" sz="4400" dirty="0"/>
           </a:p>
         </p:txBody>
       </p:sp>
@@ -1090,11 +1090,546 @@
           </a:xfrm>
           <a:prstGeom prst="roundRect">
             <a:avLst>
-              <a:gd name="adj" fmla="val 15842"/>
+              <a:gd name="adj" fmla="val 19802"/>
             </a:avLst>
           </a:prstGeom>
-          <a:solidFill>
-            <a:srgbClr val="2E4FD6"/>
+          <a:ln w="15875">
+            <a:solidFill>
+              <a:srgbClr val="FFFFFF"/>
+            </a:solidFill>
+            <a:prstDash val="solid"/>
+          </a:ln>
+        </p:spPr>
+      </p:sp>
+      <p:sp>
+        <p:nvSpPr>
+          <p:cNvPr id="7" name="Text 2"/>
+          <p:cNvSpPr/>
+          <p:nvPr/>
+        </p:nvSpPr>
+        <p:spPr>
+          <a:xfrm>
+            <a:off x="4607662" y="1151230"/>
+            <a:ext cx="2991002" cy="461772"/>
+          </a:xfrm>
+          <a:prstGeom prst="rect">
+            <a:avLst/>
+          </a:prstGeom>
+          <a:noFill/>
+          <a:ln/>
+        </p:spPr>
+        <p:txBody>
+          <a:bodyPr wrap="square" rtlCol="0" anchor="ctr">
+            <a:normAutofit/>
+          </a:bodyPr>
+          <a:lstStyle/>
+          <a:p>
+            <a:pPr algn="ctr" indent="0" marL="0">
+              <a:buNone/>
+            </a:pPr>
+            <a:r>
+              <a:rPr lang="en-US" sz="2000" b="1" dirty="0">
+                <a:solidFill>
+                  <a:srgbClr val="FFFFFF"/>
+                </a:solidFill>
+                <a:latin typeface="Poppins" pitchFamily="34" charset="0"/>
+                <a:ea typeface="Poppins" pitchFamily="34" charset="-122"/>
+                <a:cs typeface="Poppins" pitchFamily="34" charset="-120"/>
+              </a:rPr>
+              <a:t>Semua unit</a:t>
+            </a:r>
+            <a:endParaRPr lang="en-US" sz="2000" dirty="0"/>
+          </a:p>
+        </p:txBody>
+      </p:sp>
+      <p:sp>
+        <p:nvSpPr>
+          <p:cNvPr id="8" name="Text 3"/>
+          <p:cNvSpPr/>
+          <p:nvPr/>
+        </p:nvSpPr>
+        <p:spPr>
+          <a:xfrm>
+            <a:off x="4772254" y="1681582"/>
+            <a:ext cx="2648102" cy="369418"/>
+          </a:xfrm>
+          <a:prstGeom prst="rect">
+            <a:avLst/>
+          </a:prstGeom>
+          <a:noFill/>
+          <a:ln/>
+        </p:spPr>
+        <p:txBody>
+          <a:bodyPr wrap="square" rtlCol="0" anchor="ctr">
+            <a:normAutofit/>
+          </a:bodyPr>
+          <a:lstStyle/>
+          <a:p>
+            <a:pPr algn="ctr" indent="0" marL="0">
+              <a:buNone/>
+            </a:pPr>
+            <a:r>
+              <a:rPr lang="en-US" sz="2400" dirty="0">
+                <a:solidFill>
+                  <a:srgbClr val="FFFFFF"/>
+                </a:solidFill>
+                <a:latin typeface="Aptos" pitchFamily="34" charset="0"/>
+                <a:ea typeface="Aptos" pitchFamily="34" charset="-122"/>
+                <a:cs typeface="Aptos" pitchFamily="34" charset="-120"/>
+              </a:rPr>
+              <a:t>Semua posisi</a:t>
+            </a:r>
+            <a:endParaRPr lang="en-US" sz="2400" dirty="0"/>
+          </a:p>
+        </p:txBody>
+      </p:sp>
+      <p:sp>
+        <p:nvSpPr>
+          <p:cNvPr id="9" name="Text 4"/>
+          <p:cNvSpPr/>
+          <p:nvPr/>
+        </p:nvSpPr>
+        <p:spPr>
+          <a:xfrm>
+            <a:off x="3269894" y="2176272"/>
+            <a:ext cx="5692140" cy="365760"/>
+          </a:xfrm>
+          <a:prstGeom prst="rect">
+            <a:avLst/>
+          </a:prstGeom>
+          <a:noFill/>
+          <a:ln/>
+        </p:spPr>
+        <p:txBody>
+          <a:bodyPr wrap="square" rtlCol="0" anchor="ctr"/>
+          <a:lstStyle/>
+          <a:p>
+            <a:pPr algn="ctr" indent="0" marL="0">
+              <a:buNone/>
+            </a:pPr>
+            <a:r>
+              <a:rPr lang="en-US" sz="1800" dirty="0">
+                <a:solidFill>
+                  <a:srgbClr val="FFFFFF"/>
+                </a:solidFill>
+                <a:latin typeface="Aptos" pitchFamily="34" charset="0"/>
+                <a:ea typeface="Aptos" pitchFamily="34" charset="-122"/>
+                <a:cs typeface="Aptos" pitchFamily="34" charset="-120"/>
+              </a:rPr>
+              <a:t>Minggu ke-4 September 2026</a:t>
+            </a:r>
+            <a:endParaRPr lang="en-US" sz="1800" dirty="0"/>
+          </a:p>
+        </p:txBody>
+      </p:sp>
+      <p:sp>
+        <p:nvSpPr>
+          <p:cNvPr id="10" name="Text 5"/>
+          <p:cNvSpPr/>
+          <p:nvPr/>
+        </p:nvSpPr>
+        <p:spPr>
+          <a:xfrm>
+            <a:off x="3566160" y="2697480"/>
+            <a:ext cx="2011680" cy="365760"/>
+          </a:xfrm>
+          <a:prstGeom prst="rect">
+            <a:avLst/>
+          </a:prstGeom>
+          <a:noFill/>
+          <a:ln/>
+        </p:spPr>
+        <p:txBody>
+          <a:bodyPr wrap="square" rtlCol="0" anchor="ctr"/>
+          <a:lstStyle/>
+          <a:p>
+            <a:pPr algn="r" indent="0" marL="0">
+              <a:buNone/>
+            </a:pPr>
+            <a:r>
+              <a:rPr lang="en-US" sz="1400" dirty="0">
+                <a:solidFill>
+                  <a:srgbClr val="FFFFFF"/>
+                </a:solidFill>
+                <a:latin typeface="Aptos" pitchFamily="34" charset="0"/>
+                <a:ea typeface="Aptos" pitchFamily="34" charset="-122"/>
+                <a:cs typeface="Aptos" pitchFamily="34" charset="-120"/>
+              </a:rPr>
+              <a:t>Jenis kantor</a:t>
+            </a:r>
+            <a:endParaRPr lang="en-US" sz="1400" dirty="0"/>
+          </a:p>
+        </p:txBody>
+      </p:sp>
+      <p:sp>
+        <p:nvSpPr>
+          <p:cNvPr id="11" name="Text 6"/>
+          <p:cNvSpPr/>
+          <p:nvPr/>
+        </p:nvSpPr>
+        <p:spPr>
+          <a:xfrm>
+            <a:off x="5669280" y="2697480"/>
+            <a:ext cx="3657600" cy="365760"/>
+          </a:xfrm>
+          <a:prstGeom prst="rect">
+            <a:avLst/>
+          </a:prstGeom>
+          <a:noFill/>
+          <a:ln/>
+        </p:spPr>
+        <p:txBody>
+          <a:bodyPr wrap="square" rtlCol="0" anchor="ctr"/>
+          <a:lstStyle/>
+          <a:p>
+            <a:pPr indent="0" marL="0">
+              <a:buNone/>
+            </a:pPr>
+            <a:r>
+              <a:rPr lang="en-US" sz="1400" b="1" dirty="0">
+                <a:solidFill>
+                  <a:srgbClr val="FFFFFF"/>
+                </a:solidFill>
+                <a:latin typeface="Aptos" pitchFamily="34" charset="0"/>
+                <a:ea typeface="Aptos" pitchFamily="34" charset="-122"/>
+                <a:cs typeface="Aptos" pitchFamily="34" charset="-120"/>
+              </a:rPr>
+              <a:t>: Semua jenis</a:t>
+            </a:r>
+            <a:endParaRPr lang="en-US" sz="1400" dirty="0"/>
+          </a:p>
+        </p:txBody>
+      </p:sp>
+      <p:sp>
+        <p:nvSpPr>
+          <p:cNvPr id="12" name="Text 7"/>
+          <p:cNvSpPr/>
+          <p:nvPr/>
+        </p:nvSpPr>
+        <p:spPr>
+          <a:xfrm>
+            <a:off x="3566160" y="3154680"/>
+            <a:ext cx="2011680" cy="365760"/>
+          </a:xfrm>
+          <a:prstGeom prst="rect">
+            <a:avLst/>
+          </a:prstGeom>
+          <a:noFill/>
+          <a:ln/>
+        </p:spPr>
+        <p:txBody>
+          <a:bodyPr wrap="square" rtlCol="0" anchor="ctr"/>
+          <a:lstStyle/>
+          <a:p>
+            <a:pPr algn="r" indent="0" marL="0">
+              <a:buNone/>
+            </a:pPr>
+            <a:r>
+              <a:rPr lang="en-US" sz="1400" dirty="0">
+                <a:solidFill>
+                  <a:srgbClr val="FFFFFF"/>
+                </a:solidFill>
+                <a:latin typeface="Aptos" pitchFamily="34" charset="0"/>
+                <a:ea typeface="Aptos" pitchFamily="34" charset="-122"/>
+                <a:cs typeface="Aptos" pitchFamily="34" charset="-120"/>
+              </a:rPr>
+              <a:t>Unit / cabang</a:t>
+            </a:r>
+            <a:endParaRPr lang="en-US" sz="1400" dirty="0"/>
+          </a:p>
+        </p:txBody>
+      </p:sp>
+      <p:sp>
+        <p:nvSpPr>
+          <p:cNvPr id="13" name="Text 8"/>
+          <p:cNvSpPr/>
+          <p:nvPr/>
+        </p:nvSpPr>
+        <p:spPr>
+          <a:xfrm>
+            <a:off x="5669280" y="3154680"/>
+            <a:ext cx="3657600" cy="365760"/>
+          </a:xfrm>
+          <a:prstGeom prst="rect">
+            <a:avLst/>
+          </a:prstGeom>
+          <a:noFill/>
+          <a:ln/>
+        </p:spPr>
+        <p:txBody>
+          <a:bodyPr wrap="square" rtlCol="0" anchor="ctr"/>
+          <a:lstStyle/>
+          <a:p>
+            <a:pPr indent="0" marL="0">
+              <a:buNone/>
+            </a:pPr>
+            <a:r>
+              <a:rPr lang="en-US" sz="1400" b="1" dirty="0">
+                <a:solidFill>
+                  <a:srgbClr val="FFFFFF"/>
+                </a:solidFill>
+                <a:latin typeface="Aptos" pitchFamily="34" charset="0"/>
+                <a:ea typeface="Aptos" pitchFamily="34" charset="-122"/>
+                <a:cs typeface="Aptos" pitchFamily="34" charset="-120"/>
+              </a:rPr>
+              <a:t>: Semua unit</a:t>
+            </a:r>
+            <a:endParaRPr lang="en-US" sz="1400" dirty="0"/>
+          </a:p>
+        </p:txBody>
+      </p:sp>
+      <p:sp>
+        <p:nvSpPr>
+          <p:cNvPr id="14" name="Text 9"/>
+          <p:cNvSpPr/>
+          <p:nvPr/>
+        </p:nvSpPr>
+        <p:spPr>
+          <a:xfrm>
+            <a:off x="3566160" y="3611880"/>
+            <a:ext cx="2011680" cy="365760"/>
+          </a:xfrm>
+          <a:prstGeom prst="rect">
+            <a:avLst/>
+          </a:prstGeom>
+          <a:noFill/>
+          <a:ln/>
+        </p:spPr>
+        <p:txBody>
+          <a:bodyPr wrap="square" rtlCol="0" anchor="ctr"/>
+          <a:lstStyle/>
+          <a:p>
+            <a:pPr algn="r" indent="0" marL="0">
+              <a:buNone/>
+            </a:pPr>
+            <a:r>
+              <a:rPr lang="en-US" sz="1400" dirty="0">
+                <a:solidFill>
+                  <a:srgbClr val="FFFFFF"/>
+                </a:solidFill>
+                <a:latin typeface="Aptos" pitchFamily="34" charset="0"/>
+                <a:ea typeface="Aptos" pitchFamily="34" charset="-122"/>
+                <a:cs typeface="Aptos" pitchFamily="34" charset="-120"/>
+              </a:rPr>
+              <a:t>Posisi dinilai</a:t>
+            </a:r>
+            <a:endParaRPr lang="en-US" sz="1400" dirty="0"/>
+          </a:p>
+        </p:txBody>
+      </p:sp>
+      <p:sp>
+        <p:nvSpPr>
+          <p:cNvPr id="15" name="Text 10"/>
+          <p:cNvSpPr/>
+          <p:nvPr/>
+        </p:nvSpPr>
+        <p:spPr>
+          <a:xfrm>
+            <a:off x="5669280" y="3611880"/>
+            <a:ext cx="3657600" cy="365760"/>
+          </a:xfrm>
+          <a:prstGeom prst="rect">
+            <a:avLst/>
+          </a:prstGeom>
+          <a:noFill/>
+          <a:ln/>
+        </p:spPr>
+        <p:txBody>
+          <a:bodyPr wrap="square" rtlCol="0" anchor="ctr"/>
+          <a:lstStyle/>
+          <a:p>
+            <a:pPr indent="0" marL="0">
+              <a:buNone/>
+            </a:pPr>
+            <a:r>
+              <a:rPr lang="en-US" sz="1400" b="1" dirty="0">
+                <a:solidFill>
+                  <a:srgbClr val="FFFFFF"/>
+                </a:solidFill>
+                <a:latin typeface="Aptos" pitchFamily="34" charset="0"/>
+                <a:ea typeface="Aptos" pitchFamily="34" charset="-122"/>
+                <a:cs typeface="Aptos" pitchFamily="34" charset="-120"/>
+              </a:rPr>
+              <a:t>: Semua posisi</a:t>
+            </a:r>
+            <a:endParaRPr lang="en-US" sz="1400" dirty="0"/>
+          </a:p>
+        </p:txBody>
+      </p:sp>
+      <p:sp>
+        <p:nvSpPr>
+          <p:cNvPr id="16" name="Text 11"/>
+          <p:cNvSpPr/>
+          <p:nvPr/>
+        </p:nvSpPr>
+        <p:spPr>
+          <a:xfrm>
+            <a:off x="3566160" y="4069080"/>
+            <a:ext cx="2011680" cy="365760"/>
+          </a:xfrm>
+          <a:prstGeom prst="rect">
+            <a:avLst/>
+          </a:prstGeom>
+          <a:noFill/>
+          <a:ln/>
+        </p:spPr>
+        <p:txBody>
+          <a:bodyPr wrap="square" rtlCol="0" anchor="ctr"/>
+          <a:lstStyle/>
+          <a:p>
+            <a:pPr algn="r" indent="0" marL="0">
+              <a:buNone/>
+            </a:pPr>
+            <a:r>
+              <a:rPr lang="en-US" sz="1400" dirty="0">
+                <a:solidFill>
+                  <a:srgbClr val="FFFFFF"/>
+                </a:solidFill>
+                <a:latin typeface="Aptos" pitchFamily="34" charset="0"/>
+                <a:ea typeface="Aptos" pitchFamily="34" charset="-122"/>
+                <a:cs typeface="Aptos" pitchFamily="34" charset="-120"/>
+              </a:rPr>
+              <a:t>Periode</a:t>
+            </a:r>
+            <a:endParaRPr lang="en-US" sz="1400" dirty="0"/>
+          </a:p>
+        </p:txBody>
+      </p:sp>
+      <p:sp>
+        <p:nvSpPr>
+          <p:cNvPr id="17" name="Text 12"/>
+          <p:cNvSpPr/>
+          <p:nvPr/>
+        </p:nvSpPr>
+        <p:spPr>
+          <a:xfrm>
+            <a:off x="5669280" y="4069080"/>
+            <a:ext cx="3657600" cy="365760"/>
+          </a:xfrm>
+          <a:prstGeom prst="rect">
+            <a:avLst/>
+          </a:prstGeom>
+          <a:noFill/>
+          <a:ln/>
+        </p:spPr>
+        <p:txBody>
+          <a:bodyPr wrap="square" rtlCol="0" anchor="ctr"/>
+          <a:lstStyle/>
+          <a:p>
+            <a:pPr indent="0" marL="0">
+              <a:buNone/>
+            </a:pPr>
+            <a:r>
+              <a:rPr lang="en-US" sz="1400" b="1" dirty="0">
+                <a:solidFill>
+                  <a:srgbClr val="FFFFFF"/>
+                </a:solidFill>
+                <a:latin typeface="Aptos" pitchFamily="34" charset="0"/>
+                <a:ea typeface="Aptos" pitchFamily="34" charset="-122"/>
+                <a:cs typeface="Aptos" pitchFamily="34" charset="-120"/>
+              </a:rPr>
+              <a:t>: Minggu ke-4 September 2026</a:t>
+            </a:r>
+            <a:endParaRPr lang="en-US" sz="1400" dirty="0"/>
+          </a:p>
+        </p:txBody>
+      </p:sp>
+      <p:sp>
+        <p:nvSpPr>
+          <p:cNvPr id="18" name="Text 13"/>
+          <p:cNvSpPr/>
+          <p:nvPr/>
+        </p:nvSpPr>
+        <p:spPr>
+          <a:xfrm>
+            <a:off x="3566160" y="4526280"/>
+            <a:ext cx="2011680" cy="365760"/>
+          </a:xfrm>
+          <a:prstGeom prst="rect">
+            <a:avLst/>
+          </a:prstGeom>
+          <a:noFill/>
+          <a:ln/>
+        </p:spPr>
+        <p:txBody>
+          <a:bodyPr wrap="square" rtlCol="0" anchor="ctr"/>
+          <a:lstStyle/>
+          <a:p>
+            <a:pPr algn="r" indent="0" marL="0">
+              <a:buNone/>
+            </a:pPr>
+            <a:r>
+              <a:rPr lang="en-US" sz="1400" dirty="0">
+                <a:solidFill>
+                  <a:srgbClr val="FFFFFF"/>
+                </a:solidFill>
+                <a:latin typeface="Aptos" pitchFamily="34" charset="0"/>
+                <a:ea typeface="Aptos" pitchFamily="34" charset="-122"/>
+                <a:cs typeface="Aptos" pitchFamily="34" charset="-120"/>
+              </a:rPr>
+              <a:t>Jumlah peserta</a:t>
+            </a:r>
+            <a:endParaRPr lang="en-US" sz="1400" dirty="0"/>
+          </a:p>
+        </p:txBody>
+      </p:sp>
+      <p:sp>
+        <p:nvSpPr>
+          <p:cNvPr id="19" name="Text 14"/>
+          <p:cNvSpPr/>
+          <p:nvPr/>
+        </p:nvSpPr>
+        <p:spPr>
+          <a:xfrm>
+            <a:off x="5669280" y="4526280"/>
+            <a:ext cx="3657600" cy="365760"/>
+          </a:xfrm>
+          <a:prstGeom prst="rect">
+            <a:avLst/>
+          </a:prstGeom>
+          <a:noFill/>
+          <a:ln/>
+        </p:spPr>
+        <p:txBody>
+          <a:bodyPr wrap="square" rtlCol="0" anchor="ctr"/>
+          <a:lstStyle/>
+          <a:p>
+            <a:pPr indent="0" marL="0">
+              <a:buNone/>
+            </a:pPr>
+            <a:r>
+              <a:rPr lang="en-US" sz="1400" b="1" dirty="0">
+                <a:solidFill>
+                  <a:srgbClr val="FFFFFF"/>
+                </a:solidFill>
+                <a:latin typeface="Aptos" pitchFamily="34" charset="0"/>
+                <a:ea typeface="Aptos" pitchFamily="34" charset="-122"/>
+                <a:cs typeface="Aptos" pitchFamily="34" charset="-120"/>
+              </a:rPr>
+              <a:t>: 1</a:t>
+            </a:r>
+            <a:endParaRPr lang="en-US" sz="1400" dirty="0"/>
+          </a:p>
+        </p:txBody>
+      </p:sp>
+      <p:sp>
+        <p:nvSpPr>
+          <p:cNvPr id="20" name="Shape 15"/>
+          <p:cNvSpPr/>
+          <p:nvPr/>
+        </p:nvSpPr>
+        <p:spPr>
+          <a:xfrm>
+            <a:off x="2832811" y="5922569"/>
+            <a:ext cx="6273698" cy="905256"/>
+          </a:xfrm>
+          <a:prstGeom prst="roundRect">
+            <a:avLst>
+              <a:gd name="adj" fmla="val 6061"/>
+            </a:avLst>
+          </a:prstGeom>
+          <a:solidFill>
+            <a:srgbClr val="FFFFFF"/>
           </a:solidFill>
           <a:ln w="12700">
             <a:solidFill>
@@ -1106,544 +1641,6 @@
       </p:sp>
       <p:sp>
         <p:nvSpPr>
-          <p:cNvPr id="7" name="Text 2"/>
-          <p:cNvSpPr/>
-          <p:nvPr/>
-        </p:nvSpPr>
-        <p:spPr>
-          <a:xfrm>
-            <a:off x="4607662" y="1151230"/>
-            <a:ext cx="2991002" cy="461772"/>
-          </a:xfrm>
-          <a:prstGeom prst="rect">
-            <a:avLst/>
-          </a:prstGeom>
-          <a:noFill/>
-          <a:ln/>
-        </p:spPr>
-        <p:txBody>
-          <a:bodyPr wrap="square" rtlCol="0" anchor="ctr">
-            <a:normAutofit/>
-          </a:bodyPr>
-          <a:lstStyle/>
-          <a:p>
-            <a:pPr algn="ctr" indent="0" marL="0">
-              <a:buNone/>
-            </a:pPr>
-            <a:r>
-              <a:rPr lang="en-US" sz="2000" b="1" dirty="0">
-                <a:solidFill>
-                  <a:srgbClr val="FFFFFF"/>
-                </a:solidFill>
-                <a:latin typeface="Aptos" pitchFamily="34" charset="0"/>
-                <a:ea typeface="Aptos" pitchFamily="34" charset="-122"/>
-                <a:cs typeface="Aptos" pitchFamily="34" charset="-120"/>
-              </a:rPr>
-              <a:t>Semua unit</a:t>
-            </a:r>
-            <a:endParaRPr lang="en-US" sz="2000" dirty="0"/>
-          </a:p>
-        </p:txBody>
-      </p:sp>
-      <p:sp>
-        <p:nvSpPr>
-          <p:cNvPr id="8" name="Text 3"/>
-          <p:cNvSpPr/>
-          <p:nvPr/>
-        </p:nvSpPr>
-        <p:spPr>
-          <a:xfrm>
-            <a:off x="4772254" y="1681582"/>
-            <a:ext cx="2648102" cy="369418"/>
-          </a:xfrm>
-          <a:prstGeom prst="rect">
-            <a:avLst/>
-          </a:prstGeom>
-          <a:noFill/>
-          <a:ln/>
-        </p:spPr>
-        <p:txBody>
-          <a:bodyPr wrap="square" rtlCol="0" anchor="ctr">
-            <a:normAutofit/>
-          </a:bodyPr>
-          <a:lstStyle/>
-          <a:p>
-            <a:pPr algn="ctr" indent="0" marL="0">
-              <a:buNone/>
-            </a:pPr>
-            <a:r>
-              <a:rPr lang="en-US" sz="2400" dirty="0">
-                <a:solidFill>
-                  <a:srgbClr val="FFFFFF"/>
-                </a:solidFill>
-                <a:latin typeface="Aptos" pitchFamily="34" charset="0"/>
-                <a:ea typeface="Aptos" pitchFamily="34" charset="-122"/>
-                <a:cs typeface="Aptos" pitchFamily="34" charset="-120"/>
-              </a:rPr>
-              <a:t>Semua posisi</a:t>
-            </a:r>
-            <a:endParaRPr lang="en-US" sz="2400" dirty="0"/>
-          </a:p>
-        </p:txBody>
-      </p:sp>
-      <p:sp>
-        <p:nvSpPr>
-          <p:cNvPr id="9" name="Text 4"/>
-          <p:cNvSpPr/>
-          <p:nvPr/>
-        </p:nvSpPr>
-        <p:spPr>
-          <a:xfrm>
-            <a:off x="3269894" y="2176272"/>
-            <a:ext cx="5692140" cy="365760"/>
-          </a:xfrm>
-          <a:prstGeom prst="rect">
-            <a:avLst/>
-          </a:prstGeom>
-          <a:noFill/>
-          <a:ln/>
-        </p:spPr>
-        <p:txBody>
-          <a:bodyPr wrap="square" rtlCol="0" anchor="ctr"/>
-          <a:lstStyle/>
-          <a:p>
-            <a:pPr algn="ctr" indent="0" marL="0">
-              <a:buNone/>
-            </a:pPr>
-            <a:r>
-              <a:rPr lang="en-US" sz="1800" dirty="0">
-                <a:solidFill>
-                  <a:srgbClr val="FFFFFF"/>
-                </a:solidFill>
-                <a:latin typeface="Aptos" pitchFamily="34" charset="0"/>
-                <a:ea typeface="Aptos" pitchFamily="34" charset="-122"/>
-                <a:cs typeface="Aptos" pitchFamily="34" charset="-120"/>
-              </a:rPr>
-              <a:t>Minggu ke-4 September 2026</a:t>
-            </a:r>
-            <a:endParaRPr lang="en-US" sz="1800" dirty="0"/>
-          </a:p>
-        </p:txBody>
-      </p:sp>
-      <p:sp>
-        <p:nvSpPr>
-          <p:cNvPr id="10" name="Text 5"/>
-          <p:cNvSpPr/>
-          <p:nvPr/>
-        </p:nvSpPr>
-        <p:spPr>
-          <a:xfrm>
-            <a:off x="3566160" y="2697480"/>
-            <a:ext cx="2011680" cy="365760"/>
-          </a:xfrm>
-          <a:prstGeom prst="rect">
-            <a:avLst/>
-          </a:prstGeom>
-          <a:noFill/>
-          <a:ln/>
-        </p:spPr>
-        <p:txBody>
-          <a:bodyPr wrap="square" rtlCol="0" anchor="ctr"/>
-          <a:lstStyle/>
-          <a:p>
-            <a:pPr algn="r" indent="0" marL="0">
-              <a:buNone/>
-            </a:pPr>
-            <a:r>
-              <a:rPr lang="en-US" sz="1400" dirty="0">
-                <a:solidFill>
-                  <a:srgbClr val="FFFFFF"/>
-                </a:solidFill>
-                <a:latin typeface="Aptos" pitchFamily="34" charset="0"/>
-                <a:ea typeface="Aptos" pitchFamily="34" charset="-122"/>
-                <a:cs typeface="Aptos" pitchFamily="34" charset="-120"/>
-              </a:rPr>
-              <a:t>Jenis kantor</a:t>
-            </a:r>
-            <a:endParaRPr lang="en-US" sz="1400" dirty="0"/>
-          </a:p>
-        </p:txBody>
-      </p:sp>
-      <p:sp>
-        <p:nvSpPr>
-          <p:cNvPr id="11" name="Text 6"/>
-          <p:cNvSpPr/>
-          <p:nvPr/>
-        </p:nvSpPr>
-        <p:spPr>
-          <a:xfrm>
-            <a:off x="5669280" y="2697480"/>
-            <a:ext cx="3657600" cy="365760"/>
-          </a:xfrm>
-          <a:prstGeom prst="rect">
-            <a:avLst/>
-          </a:prstGeom>
-          <a:noFill/>
-          <a:ln/>
-        </p:spPr>
-        <p:txBody>
-          <a:bodyPr wrap="square" rtlCol="0" anchor="ctr"/>
-          <a:lstStyle/>
-          <a:p>
-            <a:pPr indent="0" marL="0">
-              <a:buNone/>
-            </a:pPr>
-            <a:r>
-              <a:rPr lang="en-US" sz="1400" b="1" dirty="0">
-                <a:solidFill>
-                  <a:srgbClr val="FFFFFF"/>
-                </a:solidFill>
-                <a:latin typeface="Aptos" pitchFamily="34" charset="0"/>
-                <a:ea typeface="Aptos" pitchFamily="34" charset="-122"/>
-                <a:cs typeface="Aptos" pitchFamily="34" charset="-120"/>
-              </a:rPr>
-              <a:t>: Semua jenis</a:t>
-            </a:r>
-            <a:endParaRPr lang="en-US" sz="1400" dirty="0"/>
-          </a:p>
-        </p:txBody>
-      </p:sp>
-      <p:sp>
-        <p:nvSpPr>
-          <p:cNvPr id="12" name="Text 7"/>
-          <p:cNvSpPr/>
-          <p:nvPr/>
-        </p:nvSpPr>
-        <p:spPr>
-          <a:xfrm>
-            <a:off x="3566160" y="3154680"/>
-            <a:ext cx="2011680" cy="365760"/>
-          </a:xfrm>
-          <a:prstGeom prst="rect">
-            <a:avLst/>
-          </a:prstGeom>
-          <a:noFill/>
-          <a:ln/>
-        </p:spPr>
-        <p:txBody>
-          <a:bodyPr wrap="square" rtlCol="0" anchor="ctr"/>
-          <a:lstStyle/>
-          <a:p>
-            <a:pPr algn="r" indent="0" marL="0">
-              <a:buNone/>
-            </a:pPr>
-            <a:r>
-              <a:rPr lang="en-US" sz="1400" dirty="0">
-                <a:solidFill>
-                  <a:srgbClr val="FFFFFF"/>
-                </a:solidFill>
-                <a:latin typeface="Aptos" pitchFamily="34" charset="0"/>
-                <a:ea typeface="Aptos" pitchFamily="34" charset="-122"/>
-                <a:cs typeface="Aptos" pitchFamily="34" charset="-120"/>
-              </a:rPr>
-              <a:t>Unit / cabang</a:t>
-            </a:r>
-            <a:endParaRPr lang="en-US" sz="1400" dirty="0"/>
-          </a:p>
-        </p:txBody>
-      </p:sp>
-      <p:sp>
-        <p:nvSpPr>
-          <p:cNvPr id="13" name="Text 8"/>
-          <p:cNvSpPr/>
-          <p:nvPr/>
-        </p:nvSpPr>
-        <p:spPr>
-          <a:xfrm>
-            <a:off x="5669280" y="3154680"/>
-            <a:ext cx="3657600" cy="365760"/>
-          </a:xfrm>
-          <a:prstGeom prst="rect">
-            <a:avLst/>
-          </a:prstGeom>
-          <a:noFill/>
-          <a:ln/>
-        </p:spPr>
-        <p:txBody>
-          <a:bodyPr wrap="square" rtlCol="0" anchor="ctr"/>
-          <a:lstStyle/>
-          <a:p>
-            <a:pPr indent="0" marL="0">
-              <a:buNone/>
-            </a:pPr>
-            <a:r>
-              <a:rPr lang="en-US" sz="1400" b="1" dirty="0">
-                <a:solidFill>
-                  <a:srgbClr val="FFFFFF"/>
-                </a:solidFill>
-                <a:latin typeface="Aptos" pitchFamily="34" charset="0"/>
-                <a:ea typeface="Aptos" pitchFamily="34" charset="-122"/>
-                <a:cs typeface="Aptos" pitchFamily="34" charset="-120"/>
-              </a:rPr>
-              <a:t>: Semua unit</a:t>
-            </a:r>
-            <a:endParaRPr lang="en-US" sz="1400" dirty="0"/>
-          </a:p>
-        </p:txBody>
-      </p:sp>
-      <p:sp>
-        <p:nvSpPr>
-          <p:cNvPr id="14" name="Text 9"/>
-          <p:cNvSpPr/>
-          <p:nvPr/>
-        </p:nvSpPr>
-        <p:spPr>
-          <a:xfrm>
-            <a:off x="3566160" y="3611880"/>
-            <a:ext cx="2011680" cy="365760"/>
-          </a:xfrm>
-          <a:prstGeom prst="rect">
-            <a:avLst/>
-          </a:prstGeom>
-          <a:noFill/>
-          <a:ln/>
-        </p:spPr>
-        <p:txBody>
-          <a:bodyPr wrap="square" rtlCol="0" anchor="ctr"/>
-          <a:lstStyle/>
-          <a:p>
-            <a:pPr algn="r" indent="0" marL="0">
-              <a:buNone/>
-            </a:pPr>
-            <a:r>
-              <a:rPr lang="en-US" sz="1400" dirty="0">
-                <a:solidFill>
-                  <a:srgbClr val="FFFFFF"/>
-                </a:solidFill>
-                <a:latin typeface="Aptos" pitchFamily="34" charset="0"/>
-                <a:ea typeface="Aptos" pitchFamily="34" charset="-122"/>
-                <a:cs typeface="Aptos" pitchFamily="34" charset="-120"/>
-              </a:rPr>
-              <a:t>Posisi dinilai</a:t>
-            </a:r>
-            <a:endParaRPr lang="en-US" sz="1400" dirty="0"/>
-          </a:p>
-        </p:txBody>
-      </p:sp>
-      <p:sp>
-        <p:nvSpPr>
-          <p:cNvPr id="15" name="Text 10"/>
-          <p:cNvSpPr/>
-          <p:nvPr/>
-        </p:nvSpPr>
-        <p:spPr>
-          <a:xfrm>
-            <a:off x="5669280" y="3611880"/>
-            <a:ext cx="3657600" cy="365760"/>
-          </a:xfrm>
-          <a:prstGeom prst="rect">
-            <a:avLst/>
-          </a:prstGeom>
-          <a:noFill/>
-          <a:ln/>
-        </p:spPr>
-        <p:txBody>
-          <a:bodyPr wrap="square" rtlCol="0" anchor="ctr"/>
-          <a:lstStyle/>
-          <a:p>
-            <a:pPr indent="0" marL="0">
-              <a:buNone/>
-            </a:pPr>
-            <a:r>
-              <a:rPr lang="en-US" sz="1400" b="1" dirty="0">
-                <a:solidFill>
-                  <a:srgbClr val="FFFFFF"/>
-                </a:solidFill>
-                <a:latin typeface="Aptos" pitchFamily="34" charset="0"/>
-                <a:ea typeface="Aptos" pitchFamily="34" charset="-122"/>
-                <a:cs typeface="Aptos" pitchFamily="34" charset="-120"/>
-              </a:rPr>
-              <a:t>: Semua posisi</a:t>
-            </a:r>
-            <a:endParaRPr lang="en-US" sz="1400" dirty="0"/>
-          </a:p>
-        </p:txBody>
-      </p:sp>
-      <p:sp>
-        <p:nvSpPr>
-          <p:cNvPr id="16" name="Text 11"/>
-          <p:cNvSpPr/>
-          <p:nvPr/>
-        </p:nvSpPr>
-        <p:spPr>
-          <a:xfrm>
-            <a:off x="3566160" y="4069080"/>
-            <a:ext cx="2011680" cy="365760"/>
-          </a:xfrm>
-          <a:prstGeom prst="rect">
-            <a:avLst/>
-          </a:prstGeom>
-          <a:noFill/>
-          <a:ln/>
-        </p:spPr>
-        <p:txBody>
-          <a:bodyPr wrap="square" rtlCol="0" anchor="ctr"/>
-          <a:lstStyle/>
-          <a:p>
-            <a:pPr algn="r" indent="0" marL="0">
-              <a:buNone/>
-            </a:pPr>
-            <a:r>
-              <a:rPr lang="en-US" sz="1400" dirty="0">
-                <a:solidFill>
-                  <a:srgbClr val="FFFFFF"/>
-                </a:solidFill>
-                <a:latin typeface="Aptos" pitchFamily="34" charset="0"/>
-                <a:ea typeface="Aptos" pitchFamily="34" charset="-122"/>
-                <a:cs typeface="Aptos" pitchFamily="34" charset="-120"/>
-              </a:rPr>
-              <a:t>Periode</a:t>
-            </a:r>
-            <a:endParaRPr lang="en-US" sz="1400" dirty="0"/>
-          </a:p>
-        </p:txBody>
-      </p:sp>
-      <p:sp>
-        <p:nvSpPr>
-          <p:cNvPr id="17" name="Text 12"/>
-          <p:cNvSpPr/>
-          <p:nvPr/>
-        </p:nvSpPr>
-        <p:spPr>
-          <a:xfrm>
-            <a:off x="5669280" y="4069080"/>
-            <a:ext cx="3657600" cy="365760"/>
-          </a:xfrm>
-          <a:prstGeom prst="rect">
-            <a:avLst/>
-          </a:prstGeom>
-          <a:noFill/>
-          <a:ln/>
-        </p:spPr>
-        <p:txBody>
-          <a:bodyPr wrap="square" rtlCol="0" anchor="ctr"/>
-          <a:lstStyle/>
-          <a:p>
-            <a:pPr indent="0" marL="0">
-              <a:buNone/>
-            </a:pPr>
-            <a:r>
-              <a:rPr lang="en-US" sz="1400" b="1" dirty="0">
-                <a:solidFill>
-                  <a:srgbClr val="FFFFFF"/>
-                </a:solidFill>
-                <a:latin typeface="Aptos" pitchFamily="34" charset="0"/>
-                <a:ea typeface="Aptos" pitchFamily="34" charset="-122"/>
-                <a:cs typeface="Aptos" pitchFamily="34" charset="-120"/>
-              </a:rPr>
-              <a:t>: Minggu ke-4 September 2026</a:t>
-            </a:r>
-            <a:endParaRPr lang="en-US" sz="1400" dirty="0"/>
-          </a:p>
-        </p:txBody>
-      </p:sp>
-      <p:sp>
-        <p:nvSpPr>
-          <p:cNvPr id="18" name="Text 13"/>
-          <p:cNvSpPr/>
-          <p:nvPr/>
-        </p:nvSpPr>
-        <p:spPr>
-          <a:xfrm>
-            <a:off x="3566160" y="4526280"/>
-            <a:ext cx="2011680" cy="365760"/>
-          </a:xfrm>
-          <a:prstGeom prst="rect">
-            <a:avLst/>
-          </a:prstGeom>
-          <a:noFill/>
-          <a:ln/>
-        </p:spPr>
-        <p:txBody>
-          <a:bodyPr wrap="square" rtlCol="0" anchor="ctr"/>
-          <a:lstStyle/>
-          <a:p>
-            <a:pPr algn="r" indent="0" marL="0">
-              <a:buNone/>
-            </a:pPr>
-            <a:r>
-              <a:rPr lang="en-US" sz="1400" dirty="0">
-                <a:solidFill>
-                  <a:srgbClr val="FFFFFF"/>
-                </a:solidFill>
-                <a:latin typeface="Aptos" pitchFamily="34" charset="0"/>
-                <a:ea typeface="Aptos" pitchFamily="34" charset="-122"/>
-                <a:cs typeface="Aptos" pitchFamily="34" charset="-120"/>
-              </a:rPr>
-              <a:t>Jumlah peserta</a:t>
-            </a:r>
-            <a:endParaRPr lang="en-US" sz="1400" dirty="0"/>
-          </a:p>
-        </p:txBody>
-      </p:sp>
-      <p:sp>
-        <p:nvSpPr>
-          <p:cNvPr id="19" name="Text 14"/>
-          <p:cNvSpPr/>
-          <p:nvPr/>
-        </p:nvSpPr>
-        <p:spPr>
-          <a:xfrm>
-            <a:off x="5669280" y="4526280"/>
-            <a:ext cx="3657600" cy="365760"/>
-          </a:xfrm>
-          <a:prstGeom prst="rect">
-            <a:avLst/>
-          </a:prstGeom>
-          <a:noFill/>
-          <a:ln/>
-        </p:spPr>
-        <p:txBody>
-          <a:bodyPr wrap="square" rtlCol="0" anchor="ctr"/>
-          <a:lstStyle/>
-          <a:p>
-            <a:pPr indent="0" marL="0">
-              <a:buNone/>
-            </a:pPr>
-            <a:r>
-              <a:rPr lang="en-US" sz="1400" b="1" dirty="0">
-                <a:solidFill>
-                  <a:srgbClr val="FFFFFF"/>
-                </a:solidFill>
-                <a:latin typeface="Aptos" pitchFamily="34" charset="0"/>
-                <a:ea typeface="Aptos" pitchFamily="34" charset="-122"/>
-                <a:cs typeface="Aptos" pitchFamily="34" charset="-120"/>
-              </a:rPr>
-              <a:t>: 1</a:t>
-            </a:r>
-            <a:endParaRPr lang="en-US" sz="1400" dirty="0"/>
-          </a:p>
-        </p:txBody>
-      </p:sp>
-      <p:sp>
-        <p:nvSpPr>
-          <p:cNvPr id="20" name="Shape 15"/>
-          <p:cNvSpPr/>
-          <p:nvPr/>
-        </p:nvSpPr>
-        <p:spPr>
-          <a:xfrm>
-            <a:off x="2832811" y="5922569"/>
-            <a:ext cx="6273698" cy="905256"/>
-          </a:xfrm>
-          <a:prstGeom prst="roundRect">
-            <a:avLst>
-              <a:gd name="adj" fmla="val 6061"/>
-            </a:avLst>
-          </a:prstGeom>
-          <a:solidFill>
-            <a:srgbClr val="FFFFFF"/>
-          </a:solidFill>
-          <a:ln w="12700">
-            <a:solidFill>
-              <a:srgbClr val="FFFFFF"/>
-            </a:solidFill>
-            <a:prstDash val="solid"/>
-          </a:ln>
-        </p:spPr>
-      </p:sp>
-      <p:sp>
-        <p:nvSpPr>
           <p:cNvPr id="21" name="Shape 16"/>
           <p:cNvSpPr/>
           <p:nvPr/>
@@ -1760,9 +1757,9 @@
               <a:buNone/>
             </a:pPr>
             <a:r>
-              <a:rPr lang="en-US" sz="1100" b="1" dirty="0">
-                <a:solidFill>
-                  <a:srgbClr val="222222"/>
+              <a:rPr lang="en-US" sz="1000" b="1" dirty="0">
+                <a:solidFill>
+                  <a:srgbClr val="142D64"/>
                 </a:solidFill>
                 <a:latin typeface="Aptos" pitchFamily="34" charset="0"/>
                 <a:ea typeface="Aptos" pitchFamily="34" charset="-122"/>
@@ -1770,7 +1767,7 @@
               </a:rPr>
               <a:t>4,80-5,00</a:t>
             </a:r>
-            <a:endParaRPr lang="en-US" sz="1100" dirty="0"/>
+            <a:endParaRPr lang="en-US" sz="1000" dirty="0"/>
           </a:p>
         </p:txBody>
       </p:sp>
@@ -1801,9 +1798,9 @@
               <a:buNone/>
             </a:pPr>
             <a:r>
-              <a:rPr lang="en-US" sz="1100" dirty="0">
-                <a:solidFill>
-                  <a:srgbClr val="333333"/>
+              <a:rPr lang="en-US" sz="850" dirty="0">
+                <a:solidFill>
+                  <a:srgbClr val="142D64"/>
                 </a:solidFill>
                 <a:latin typeface="Aptos" pitchFamily="34" charset="0"/>
                 <a:ea typeface="Aptos" pitchFamily="34" charset="-122"/>
@@ -1811,7 +1808,7 @@
               </a:rPr>
               <a:t>Istimewa</a:t>
             </a:r>
-            <a:endParaRPr lang="en-US" sz="1100" dirty="0"/>
+            <a:endParaRPr lang="en-US" sz="850" dirty="0"/>
           </a:p>
         </p:txBody>
       </p:sp>
@@ -1867,9 +1864,9 @@
               <a:buNone/>
             </a:pPr>
             <a:r>
-              <a:rPr lang="en-US" sz="1100" b="1" dirty="0">
-                <a:solidFill>
-                  <a:srgbClr val="222222"/>
+              <a:rPr lang="en-US" sz="1000" b="1" dirty="0">
+                <a:solidFill>
+                  <a:srgbClr val="142D64"/>
                 </a:solidFill>
                 <a:latin typeface="Aptos" pitchFamily="34" charset="0"/>
                 <a:ea typeface="Aptos" pitchFamily="34" charset="-122"/>
@@ -1877,7 +1874,7 @@
               </a:rPr>
               <a:t>4,60-4,79</a:t>
             </a:r>
-            <a:endParaRPr lang="en-US" sz="1100" dirty="0"/>
+            <a:endParaRPr lang="en-US" sz="1000" dirty="0"/>
           </a:p>
         </p:txBody>
       </p:sp>
@@ -1908,9 +1905,9 @@
               <a:buNone/>
             </a:pPr>
             <a:r>
-              <a:rPr lang="en-US" sz="1100" dirty="0">
-                <a:solidFill>
-                  <a:srgbClr val="333333"/>
+              <a:rPr lang="en-US" sz="850" dirty="0">
+                <a:solidFill>
+                  <a:srgbClr val="142D64"/>
                 </a:solidFill>
                 <a:latin typeface="Aptos" pitchFamily="34" charset="0"/>
                 <a:ea typeface="Aptos" pitchFamily="34" charset="-122"/>
@@ -1918,7 +1915,7 @@
               </a:rPr>
               <a:t>Sangat Baik</a:t>
             </a:r>
-            <a:endParaRPr lang="en-US" sz="1100" dirty="0"/>
+            <a:endParaRPr lang="en-US" sz="850" dirty="0"/>
           </a:p>
         </p:txBody>
       </p:sp>
@@ -1974,9 +1971,9 @@
               <a:buNone/>
             </a:pPr>
             <a:r>
-              <a:rPr lang="en-US" sz="1100" b="1" dirty="0">
-                <a:solidFill>
-                  <a:srgbClr val="222222"/>
+              <a:rPr lang="en-US" sz="1000" b="1" dirty="0">
+                <a:solidFill>
+                  <a:srgbClr val="142D64"/>
                 </a:solidFill>
                 <a:latin typeface="Aptos" pitchFamily="34" charset="0"/>
                 <a:ea typeface="Aptos" pitchFamily="34" charset="-122"/>
@@ -1984,7 +1981,7 @@
               </a:rPr>
               <a:t>4,00-4,59</a:t>
             </a:r>
-            <a:endParaRPr lang="en-US" sz="1100" dirty="0"/>
+            <a:endParaRPr lang="en-US" sz="1000" dirty="0"/>
           </a:p>
         </p:txBody>
       </p:sp>
@@ -2015,9 +2012,9 @@
               <a:buNone/>
             </a:pPr>
             <a:r>
-              <a:rPr lang="en-US" sz="1100" dirty="0">
-                <a:solidFill>
-                  <a:srgbClr val="333333"/>
+              <a:rPr lang="en-US" sz="850" dirty="0">
+                <a:solidFill>
+                  <a:srgbClr val="142D64"/>
                 </a:solidFill>
                 <a:latin typeface="Aptos" pitchFamily="34" charset="0"/>
                 <a:ea typeface="Aptos" pitchFamily="34" charset="-122"/>
@@ -2025,7 +2022,7 @@
               </a:rPr>
               <a:t>Baik</a:t>
             </a:r>
-            <a:endParaRPr lang="en-US" sz="1100" dirty="0"/>
+            <a:endParaRPr lang="en-US" sz="850" dirty="0"/>
           </a:p>
         </p:txBody>
       </p:sp>
@@ -2081,9 +2078,9 @@
               <a:buNone/>
             </a:pPr>
             <a:r>
-              <a:rPr lang="en-US" sz="1100" b="1" dirty="0">
-                <a:solidFill>
-                  <a:srgbClr val="222222"/>
+              <a:rPr lang="en-US" sz="1000" b="1" dirty="0">
+                <a:solidFill>
+                  <a:srgbClr val="142D64"/>
                 </a:solidFill>
                 <a:latin typeface="Aptos" pitchFamily="34" charset="0"/>
                 <a:ea typeface="Aptos" pitchFamily="34" charset="-122"/>
@@ -2091,7 +2088,7 @@
               </a:rPr>
               <a:t>3,60-3,99</a:t>
             </a:r>
-            <a:endParaRPr lang="en-US" sz="1100" dirty="0"/>
+            <a:endParaRPr lang="en-US" sz="1000" dirty="0"/>
           </a:p>
         </p:txBody>
       </p:sp>
@@ -2122,9 +2119,9 @@
               <a:buNone/>
             </a:pPr>
             <a:r>
-              <a:rPr lang="en-US" sz="1100" dirty="0">
-                <a:solidFill>
-                  <a:srgbClr val="333333"/>
+              <a:rPr lang="en-US" sz="850" dirty="0">
+                <a:solidFill>
+                  <a:srgbClr val="142D64"/>
                 </a:solidFill>
                 <a:latin typeface="Aptos" pitchFamily="34" charset="0"/>
                 <a:ea typeface="Aptos" pitchFamily="34" charset="-122"/>
@@ -2132,7 +2129,7 @@
               </a:rPr>
               <a:t>Cukup</a:t>
             </a:r>
-            <a:endParaRPr lang="en-US" sz="1100" dirty="0"/>
+            <a:endParaRPr lang="en-US" sz="850" dirty="0"/>
           </a:p>
         </p:txBody>
       </p:sp>
@@ -2188,9 +2185,9 @@
               <a:buNone/>
             </a:pPr>
             <a:r>
-              <a:rPr lang="en-US" sz="1100" b="1" dirty="0">
-                <a:solidFill>
-                  <a:srgbClr val="222222"/>
+              <a:rPr lang="en-US" sz="1000" b="1" dirty="0">
+                <a:solidFill>
+                  <a:srgbClr val="142D64"/>
                 </a:solidFill>
                 <a:latin typeface="Aptos" pitchFamily="34" charset="0"/>
                 <a:ea typeface="Aptos" pitchFamily="34" charset="-122"/>
@@ -2198,7 +2195,7 @@
               </a:rPr>
               <a:t>&lt;3,59</a:t>
             </a:r>
-            <a:endParaRPr lang="en-US" sz="1100" dirty="0"/>
+            <a:endParaRPr lang="en-US" sz="1000" dirty="0"/>
           </a:p>
         </p:txBody>
       </p:sp>
@@ -2229,9 +2226,9 @@
               <a:buNone/>
             </a:pPr>
             <a:r>
-              <a:rPr lang="en-US" sz="1100" dirty="0">
-                <a:solidFill>
-                  <a:srgbClr val="333333"/>
+              <a:rPr lang="en-US" sz="850" dirty="0">
+                <a:solidFill>
+                  <a:srgbClr val="142D64"/>
                 </a:solidFill>
                 <a:latin typeface="Aptos" pitchFamily="34" charset="0"/>
                 <a:ea typeface="Aptos" pitchFamily="34" charset="-122"/>
@@ -2239,7 +2236,7 @@
               </a:rPr>
               <a:t>Kurang</a:t>
             </a:r>
-            <a:endParaRPr lang="en-US" sz="1100" dirty="0"/>
+            <a:endParaRPr lang="en-US" sz="850" dirty="0"/>
           </a:p>
         </p:txBody>
       </p:sp>
@@ -2374,7 +2371,7 @@
               <a:buNone/>
             </a:pPr>
             <a:r>
-              <a:rPr lang="en-US" sz="4000" b="1" dirty="0">
+              <a:rPr lang="en-US" sz="4400" b="1" dirty="0">
                 <a:solidFill>
                   <a:srgbClr val="FFFFFF"/>
                 </a:solidFill>
@@ -2384,7 +2381,7 @@
               </a:rPr>
               <a:t>Service Drill Ranking</a:t>
             </a:r>
-            <a:endParaRPr lang="en-US" sz="4000" dirty="0"/>
+            <a:endParaRPr lang="en-US" sz="4400" dirty="0"/>
           </a:p>
         </p:txBody>
       </p:sp>
@@ -2401,13 +2398,10 @@
           </a:xfrm>
           <a:prstGeom prst="roundRect">
             <a:avLst>
-              <a:gd name="adj" fmla="val 15842"/>
+              <a:gd name="adj" fmla="val 19802"/>
             </a:avLst>
           </a:prstGeom>
-          <a:solidFill>
-            <a:srgbClr val="2E4FD6"/>
-          </a:solidFill>
-          <a:ln w="12700">
+          <a:ln w="15875">
             <a:solidFill>
               <a:srgbClr val="FFFFFF"/>
             </a:solidFill>
@@ -2446,9 +2440,9 @@
                 <a:solidFill>
                   <a:srgbClr val="FFFFFF"/>
                 </a:solidFill>
-                <a:latin typeface="Aptos" pitchFamily="34" charset="0"/>
-                <a:ea typeface="Aptos" pitchFamily="34" charset="-122"/>
-                <a:cs typeface="Aptos" pitchFamily="34" charset="-120"/>
+                <a:latin typeface="Poppins" pitchFamily="34" charset="0"/>
+                <a:ea typeface="Poppins" pitchFamily="34" charset="-122"/>
+                <a:cs typeface="Poppins" pitchFamily="34" charset="-120"/>
               </a:rPr>
               <a:t>244 KC MAMUJU</a:t>
             </a:r>
@@ -2732,7 +2726,7 @@
               <a:buNone/>
             </a:pPr>
             <a:r>
-              <a:rPr lang="en-US" sz="1400" b="1" dirty="0">
+              <a:rPr lang="en-US" sz="1200" b="1" dirty="0">
                 <a:solidFill>
                   <a:srgbClr val="FFFFFF"/>
                 </a:solidFill>
@@ -2742,7 +2736,7 @@
               </a:rPr>
               <a:t>Kurang</a:t>
             </a:r>
-            <a:endParaRPr lang="en-US" sz="1400" dirty="0"/>
+            <a:endParaRPr lang="en-US" sz="1200" dirty="0"/>
           </a:p>
         </p:txBody>
       </p:sp>
@@ -2891,9 +2885,9 @@
               <a:buNone/>
             </a:pPr>
             <a:r>
-              <a:rPr lang="en-US" sz="1100" b="1" dirty="0">
-                <a:solidFill>
-                  <a:srgbClr val="222222"/>
+              <a:rPr lang="en-US" sz="1000" b="1" dirty="0">
+                <a:solidFill>
+                  <a:srgbClr val="142D64"/>
                 </a:solidFill>
                 <a:latin typeface="Aptos" pitchFamily="34" charset="0"/>
                 <a:ea typeface="Aptos" pitchFamily="34" charset="-122"/>
@@ -2901,7 +2895,7 @@
               </a:rPr>
               <a:t>4,80-5,00</a:t>
             </a:r>
-            <a:endParaRPr lang="en-US" sz="1100" dirty="0"/>
+            <a:endParaRPr lang="en-US" sz="1000" dirty="0"/>
           </a:p>
         </p:txBody>
       </p:sp>
@@ -2932,9 +2926,9 @@
               <a:buNone/>
             </a:pPr>
             <a:r>
-              <a:rPr lang="en-US" sz="1100" dirty="0">
-                <a:solidFill>
-                  <a:srgbClr val="333333"/>
+              <a:rPr lang="en-US" sz="850" dirty="0">
+                <a:solidFill>
+                  <a:srgbClr val="142D64"/>
                 </a:solidFill>
                 <a:latin typeface="Aptos" pitchFamily="34" charset="0"/>
                 <a:ea typeface="Aptos" pitchFamily="34" charset="-122"/>
@@ -2942,7 +2936,7 @@
               </a:rPr>
               <a:t>Istimewa</a:t>
             </a:r>
-            <a:endParaRPr lang="en-US" sz="1100" dirty="0"/>
+            <a:endParaRPr lang="en-US" sz="850" dirty="0"/>
           </a:p>
         </p:txBody>
       </p:sp>
@@ -2998,9 +2992,9 @@
               <a:buNone/>
             </a:pPr>
             <a:r>
-              <a:rPr lang="en-US" sz="1100" b="1" dirty="0">
-                <a:solidFill>
-                  <a:srgbClr val="222222"/>
+              <a:rPr lang="en-US" sz="1000" b="1" dirty="0">
+                <a:solidFill>
+                  <a:srgbClr val="142D64"/>
                 </a:solidFill>
                 <a:latin typeface="Aptos" pitchFamily="34" charset="0"/>
                 <a:ea typeface="Aptos" pitchFamily="34" charset="-122"/>
@@ -3008,7 +3002,7 @@
               </a:rPr>
               <a:t>4,60-4,79</a:t>
             </a:r>
-            <a:endParaRPr lang="en-US" sz="1100" dirty="0"/>
+            <a:endParaRPr lang="en-US" sz="1000" dirty="0"/>
           </a:p>
         </p:txBody>
       </p:sp>
@@ -3039,9 +3033,9 @@
               <a:buNone/>
             </a:pPr>
             <a:r>
-              <a:rPr lang="en-US" sz="1100" dirty="0">
-                <a:solidFill>
-                  <a:srgbClr val="333333"/>
+              <a:rPr lang="en-US" sz="850" dirty="0">
+                <a:solidFill>
+                  <a:srgbClr val="142D64"/>
                 </a:solidFill>
                 <a:latin typeface="Aptos" pitchFamily="34" charset="0"/>
                 <a:ea typeface="Aptos" pitchFamily="34" charset="-122"/>
@@ -3049,7 +3043,7 @@
               </a:rPr>
               <a:t>Sangat Baik</a:t>
             </a:r>
-            <a:endParaRPr lang="en-US" sz="1100" dirty="0"/>
+            <a:endParaRPr lang="en-US" sz="850" dirty="0"/>
           </a:p>
         </p:txBody>
       </p:sp>
@@ -3105,9 +3099,9 @@
               <a:buNone/>
             </a:pPr>
             <a:r>
-              <a:rPr lang="en-US" sz="1100" b="1" dirty="0">
-                <a:solidFill>
-                  <a:srgbClr val="222222"/>
+              <a:rPr lang="en-US" sz="1000" b="1" dirty="0">
+                <a:solidFill>
+                  <a:srgbClr val="142D64"/>
                 </a:solidFill>
                 <a:latin typeface="Aptos" pitchFamily="34" charset="0"/>
                 <a:ea typeface="Aptos" pitchFamily="34" charset="-122"/>
@@ -3115,7 +3109,7 @@
               </a:rPr>
               <a:t>4,00-4,59</a:t>
             </a:r>
-            <a:endParaRPr lang="en-US" sz="1100" dirty="0"/>
+            <a:endParaRPr lang="en-US" sz="1000" dirty="0"/>
           </a:p>
         </p:txBody>
       </p:sp>
@@ -3146,9 +3140,9 @@
               <a:buNone/>
             </a:pPr>
             <a:r>
-              <a:rPr lang="en-US" sz="1100" dirty="0">
-                <a:solidFill>
-                  <a:srgbClr val="333333"/>
+              <a:rPr lang="en-US" sz="850" dirty="0">
+                <a:solidFill>
+                  <a:srgbClr val="142D64"/>
                 </a:solidFill>
                 <a:latin typeface="Aptos" pitchFamily="34" charset="0"/>
                 <a:ea typeface="Aptos" pitchFamily="34" charset="-122"/>
@@ -3156,7 +3150,7 @@
               </a:rPr>
               <a:t>Baik</a:t>
             </a:r>
-            <a:endParaRPr lang="en-US" sz="1100" dirty="0"/>
+            <a:endParaRPr lang="en-US" sz="850" dirty="0"/>
           </a:p>
         </p:txBody>
       </p:sp>
@@ -3212,9 +3206,9 @@
               <a:buNone/>
             </a:pPr>
             <a:r>
-              <a:rPr lang="en-US" sz="1100" b="1" dirty="0">
-                <a:solidFill>
-                  <a:srgbClr val="222222"/>
+              <a:rPr lang="en-US" sz="1000" b="1" dirty="0">
+                <a:solidFill>
+                  <a:srgbClr val="142D64"/>
                 </a:solidFill>
                 <a:latin typeface="Aptos" pitchFamily="34" charset="0"/>
                 <a:ea typeface="Aptos" pitchFamily="34" charset="-122"/>
@@ -3222,7 +3216,7 @@
               </a:rPr>
               <a:t>3,60-3,99</a:t>
             </a:r>
-            <a:endParaRPr lang="en-US" sz="1100" dirty="0"/>
+            <a:endParaRPr lang="en-US" sz="1000" dirty="0"/>
           </a:p>
         </p:txBody>
       </p:sp>
@@ -3253,9 +3247,9 @@
               <a:buNone/>
             </a:pPr>
             <a:r>
-              <a:rPr lang="en-US" sz="1100" dirty="0">
-                <a:solidFill>
-                  <a:srgbClr val="333333"/>
+              <a:rPr lang="en-US" sz="850" dirty="0">
+                <a:solidFill>
+                  <a:srgbClr val="142D64"/>
                 </a:solidFill>
                 <a:latin typeface="Aptos" pitchFamily="34" charset="0"/>
                 <a:ea typeface="Aptos" pitchFamily="34" charset="-122"/>
@@ -3263,7 +3257,7 @@
               </a:rPr>
               <a:t>Cukup</a:t>
             </a:r>
-            <a:endParaRPr lang="en-US" sz="1100" dirty="0"/>
+            <a:endParaRPr lang="en-US" sz="850" dirty="0"/>
           </a:p>
         </p:txBody>
       </p:sp>
@@ -3319,9 +3313,9 @@
               <a:buNone/>
             </a:pPr>
             <a:r>
-              <a:rPr lang="en-US" sz="1100" b="1" dirty="0">
-                <a:solidFill>
-                  <a:srgbClr val="222222"/>
+              <a:rPr lang="en-US" sz="1000" b="1" dirty="0">
+                <a:solidFill>
+                  <a:srgbClr val="142D64"/>
                 </a:solidFill>
                 <a:latin typeface="Aptos" pitchFamily="34" charset="0"/>
                 <a:ea typeface="Aptos" pitchFamily="34" charset="-122"/>
@@ -3329,7 +3323,7 @@
               </a:rPr>
               <a:t>&lt;3,59</a:t>
             </a:r>
-            <a:endParaRPr lang="en-US" sz="1100" dirty="0"/>
+            <a:endParaRPr lang="en-US" sz="1000" dirty="0"/>
           </a:p>
         </p:txBody>
       </p:sp>
@@ -3360,9 +3354,9 @@
               <a:buNone/>
             </a:pPr>
             <a:r>
-              <a:rPr lang="en-US" sz="1100" dirty="0">
-                <a:solidFill>
-                  <a:srgbClr val="333333"/>
+              <a:rPr lang="en-US" sz="850" dirty="0">
+                <a:solidFill>
+                  <a:srgbClr val="142D64"/>
                 </a:solidFill>
                 <a:latin typeface="Aptos" pitchFamily="34" charset="0"/>
                 <a:ea typeface="Aptos" pitchFamily="34" charset="-122"/>
@@ -3370,7 +3364,7 @@
               </a:rPr>
               <a:t>Kurang</a:t>
             </a:r>
-            <a:endParaRPr lang="en-US" sz="1100" dirty="0"/>
+            <a:endParaRPr lang="en-US" sz="850" dirty="0"/>
           </a:p>
         </p:txBody>
       </p:sp>

</xml_diff>

<commit_message>
Ranking PPTX: nama posisi 18 pt, nama petugas 16 pt
Sesuai daftar ukuran font dari user:
  Nama cabang            20 pt  Poppins     (latar transparan)
  Nama posisi            18 pt  Aptos       (dari 24)
  Nama petugas           16 pt  Aptos       (dari 20)
  Legenda rentang        10 pt  tebal
  Legenda nama kategori   8,5 pt
  Pil kategori           12 pt  tebal

Verifikasi dari PPTX hasil: sz 850/1000/1200/1600/1800/2000/4400
(×1/100 pt) dengan typeface Aptos + Poppins.
120 unit test + 20 pemeriksaan ranking lulus.
</commit_message>
<xml_diff>
--- a/ranking-nyata.pptx
+++ b/ranking-nyata.pptx
@@ -1169,7 +1169,7 @@
               <a:buNone/>
             </a:pPr>
             <a:r>
-              <a:rPr lang="en-US" sz="2400" dirty="0">
+              <a:rPr lang="en-US" sz="1800" dirty="0">
                 <a:solidFill>
                   <a:srgbClr val="FFFFFF"/>
                 </a:solidFill>
@@ -1179,7 +1179,7 @@
               </a:rPr>
               <a:t>Semua posisi</a:t>
             </a:r>
-            <a:endParaRPr lang="en-US" sz="2400" dirty="0"/>
+            <a:endParaRPr lang="en-US" sz="1800" dirty="0"/>
           </a:p>
         </p:txBody>
       </p:sp>
@@ -2477,7 +2477,7 @@
               <a:buNone/>
             </a:pPr>
             <a:r>
-              <a:rPr lang="en-US" sz="2400" dirty="0">
+              <a:rPr lang="en-US" sz="1800" dirty="0">
                 <a:solidFill>
                   <a:srgbClr val="FFFFFF"/>
                 </a:solidFill>
@@ -2487,7 +2487,7 @@
               </a:rPr>
               <a:t>Teller</a:t>
             </a:r>
-            <a:endParaRPr lang="en-US" sz="2400" dirty="0"/>
+            <a:endParaRPr lang="en-US" sz="1800" dirty="0"/>
           </a:p>
         </p:txBody>
       </p:sp>
@@ -2594,7 +2594,7 @@
               <a:buNone/>
             </a:pPr>
             <a:r>
-              <a:rPr lang="en-US" sz="2000" b="1" dirty="0">
+              <a:rPr lang="en-US" sz="1600" b="1" dirty="0">
                 <a:solidFill>
                   <a:srgbClr val="FFFFFF"/>
                 </a:solidFill>
@@ -2604,7 +2604,7 @@
               </a:rPr>
               <a:t>IRWAN ALLO</a:t>
             </a:r>
-            <a:endParaRPr lang="en-US" sz="2000" dirty="0"/>
+            <a:endParaRPr lang="en-US" sz="1600" dirty="0"/>
           </a:p>
         </p:txBody>
       </p:sp>

</xml_diff>

<commit_message>
Ranking PPTX: legenda turun ke bawah, nama cabang tidak bold
- Panel legenda digeser ke bawah hampir menyentuh tepi slide. Di file
  referensi, batas bawah grup legenda hanya 0,033 inci dari tepi
  (7,467 dari 7,5 inci); versi sebelumnya berhenti di 7,000 sehingga
  terlihat terlalu ke atas. Sekarang berhenti di 7,470 (selisih 0,030).
  Semua isi legenda ikut bergeser: titik warna y 6,970, rentang angka
  y 6,908, nama kategori y 7,110.
- Nama cabang TIDAK bold lagi (permintaan user); ukuran tetap 20 pt
  Poppins seperti file referensi.

127 unit test lulus.
</commit_message>
<xml_diff>
--- a/ranking-nyata.pptx
+++ b/ranking-nyata.pptx
@@ -1128,7 +1128,7 @@
               <a:buNone/>
             </a:pPr>
             <a:r>
-              <a:rPr lang="en-US" sz="2000" b="1" dirty="0">
+              <a:rPr lang="en-US" sz="2000" dirty="0">
                 <a:solidFill>
                   <a:srgbClr val="FFFFFF"/>
                 </a:solidFill>
@@ -1620,7 +1620,7 @@
         </p:nvSpPr>
         <p:spPr>
           <a:xfrm>
-            <a:off x="2606040" y="5605272"/>
+            <a:off x="2606040" y="6172200"/>
             <a:ext cx="6273698" cy="658368"/>
           </a:xfrm>
           <a:prstGeom prst="roundRect">
@@ -1647,7 +1647,7 @@
         </p:nvSpPr>
         <p:spPr>
           <a:xfrm>
-            <a:off x="4754880" y="5358384"/>
+            <a:off x="4754880" y="5925312"/>
             <a:ext cx="1828800" cy="310896"/>
           </a:xfrm>
           <a:prstGeom prst="roundRect">
@@ -1671,7 +1671,7 @@
         </p:nvSpPr>
         <p:spPr>
           <a:xfrm>
-            <a:off x="4754880" y="5385816"/>
+            <a:off x="4754880" y="5952744"/>
             <a:ext cx="1828800" cy="228600"/>
           </a:xfrm>
           <a:prstGeom prst="rect">
@@ -1710,7 +1710,7 @@
         </p:nvSpPr>
         <p:spPr>
           <a:xfrm>
-            <a:off x="2770632" y="5806440"/>
+            <a:off x="2770632" y="6373368"/>
             <a:ext cx="109728" cy="109728"/>
           </a:xfrm>
           <a:prstGeom prst="ellipse">
@@ -1735,7 +1735,7 @@
         </p:nvSpPr>
         <p:spPr>
           <a:xfrm>
-            <a:off x="2919679" y="5749747"/>
+            <a:off x="2919679" y="6316675"/>
             <a:ext cx="777240" cy="245974"/>
           </a:xfrm>
           <a:prstGeom prst="rect">
@@ -1776,7 +1776,7 @@
         </p:nvSpPr>
         <p:spPr>
           <a:xfrm>
-            <a:off x="2926080" y="5934456"/>
+            <a:off x="2926080" y="6501384"/>
             <a:ext cx="960120" cy="164592"/>
           </a:xfrm>
           <a:prstGeom prst="rect">
@@ -1817,7 +1817,7 @@
         </p:nvSpPr>
         <p:spPr>
           <a:xfrm>
-            <a:off x="4078224" y="5806440"/>
+            <a:off x="4078224" y="6373368"/>
             <a:ext cx="109728" cy="109728"/>
           </a:xfrm>
           <a:prstGeom prst="ellipse">
@@ -1842,7 +1842,7 @@
         </p:nvSpPr>
         <p:spPr>
           <a:xfrm>
-            <a:off x="4227271" y="5749747"/>
+            <a:off x="4227271" y="6316675"/>
             <a:ext cx="777240" cy="245974"/>
           </a:xfrm>
           <a:prstGeom prst="rect">
@@ -1883,7 +1883,7 @@
         </p:nvSpPr>
         <p:spPr>
           <a:xfrm>
-            <a:off x="4233672" y="5934456"/>
+            <a:off x="4233672" y="6501384"/>
             <a:ext cx="960120" cy="164592"/>
           </a:xfrm>
           <a:prstGeom prst="rect">
@@ -1924,7 +1924,7 @@
         </p:nvSpPr>
         <p:spPr>
           <a:xfrm>
-            <a:off x="5437022" y="5806440"/>
+            <a:off x="5437022" y="6373368"/>
             <a:ext cx="109728" cy="109728"/>
           </a:xfrm>
           <a:prstGeom prst="ellipse">
@@ -1949,7 +1949,7 @@
         </p:nvSpPr>
         <p:spPr>
           <a:xfrm>
-            <a:off x="5586070" y="5749747"/>
+            <a:off x="5586070" y="6316675"/>
             <a:ext cx="777240" cy="245974"/>
           </a:xfrm>
           <a:prstGeom prst="rect">
@@ -1990,7 +1990,7 @@
         </p:nvSpPr>
         <p:spPr>
           <a:xfrm>
-            <a:off x="5592470" y="5934456"/>
+            <a:off x="5592470" y="6501384"/>
             <a:ext cx="960120" cy="164592"/>
           </a:xfrm>
           <a:prstGeom prst="rect">
@@ -2031,7 +2031,7 @@
         </p:nvSpPr>
         <p:spPr>
           <a:xfrm>
-            <a:off x="6765646" y="5806440"/>
+            <a:off x="6765646" y="6373368"/>
             <a:ext cx="109728" cy="109728"/>
           </a:xfrm>
           <a:prstGeom prst="ellipse">
@@ -2056,7 +2056,7 @@
         </p:nvSpPr>
         <p:spPr>
           <a:xfrm>
-            <a:off x="6914693" y="5749747"/>
+            <a:off x="6914693" y="6316675"/>
             <a:ext cx="777240" cy="245974"/>
           </a:xfrm>
           <a:prstGeom prst="rect">
@@ -2097,7 +2097,7 @@
         </p:nvSpPr>
         <p:spPr>
           <a:xfrm>
-            <a:off x="6921094" y="5934456"/>
+            <a:off x="6921094" y="6501384"/>
             <a:ext cx="960120" cy="164592"/>
           </a:xfrm>
           <a:prstGeom prst="rect">
@@ -2138,7 +2138,7 @@
         </p:nvSpPr>
         <p:spPr>
           <a:xfrm>
-            <a:off x="8108899" y="5806440"/>
+            <a:off x="8108899" y="6373368"/>
             <a:ext cx="109728" cy="109728"/>
           </a:xfrm>
           <a:prstGeom prst="ellipse">
@@ -2163,7 +2163,7 @@
         </p:nvSpPr>
         <p:spPr>
           <a:xfrm>
-            <a:off x="8257946" y="5749747"/>
+            <a:off x="8257946" y="6316675"/>
             <a:ext cx="777240" cy="245974"/>
           </a:xfrm>
           <a:prstGeom prst="rect">
@@ -2204,7 +2204,7 @@
         </p:nvSpPr>
         <p:spPr>
           <a:xfrm>
-            <a:off x="8264347" y="5934456"/>
+            <a:off x="8264347" y="6501384"/>
             <a:ext cx="960120" cy="164592"/>
           </a:xfrm>
           <a:prstGeom prst="rect">
@@ -2433,7 +2433,7 @@
               <a:buNone/>
             </a:pPr>
             <a:r>
-              <a:rPr lang="en-US" sz="2000" b="1" dirty="0">
+              <a:rPr lang="en-US" sz="2000" dirty="0">
                 <a:solidFill>
                   <a:srgbClr val="FFFFFF"/>
                 </a:solidFill>
@@ -2864,7 +2864,7 @@
         </p:nvSpPr>
         <p:spPr>
           <a:xfrm>
-            <a:off x="2606040" y="5605272"/>
+            <a:off x="2606040" y="6172200"/>
             <a:ext cx="6273698" cy="658368"/>
           </a:xfrm>
           <a:prstGeom prst="roundRect">
@@ -2891,7 +2891,7 @@
         </p:nvSpPr>
         <p:spPr>
           <a:xfrm>
-            <a:off x="4754880" y="5358384"/>
+            <a:off x="4754880" y="5925312"/>
             <a:ext cx="1828800" cy="310896"/>
           </a:xfrm>
           <a:prstGeom prst="roundRect">
@@ -2915,7 +2915,7 @@
         </p:nvSpPr>
         <p:spPr>
           <a:xfrm>
-            <a:off x="4754880" y="5385816"/>
+            <a:off x="4754880" y="5952744"/>
             <a:ext cx="1828800" cy="228600"/>
           </a:xfrm>
           <a:prstGeom prst="rect">
@@ -2954,7 +2954,7 @@
         </p:nvSpPr>
         <p:spPr>
           <a:xfrm>
-            <a:off x="2770632" y="5806440"/>
+            <a:off x="2770632" y="6373368"/>
             <a:ext cx="109728" cy="109728"/>
           </a:xfrm>
           <a:prstGeom prst="ellipse">
@@ -2979,7 +2979,7 @@
         </p:nvSpPr>
         <p:spPr>
           <a:xfrm>
-            <a:off x="2919679" y="5749747"/>
+            <a:off x="2919679" y="6316675"/>
             <a:ext cx="777240" cy="245974"/>
           </a:xfrm>
           <a:prstGeom prst="rect">
@@ -3020,7 +3020,7 @@
         </p:nvSpPr>
         <p:spPr>
           <a:xfrm>
-            <a:off x="2926080" y="5934456"/>
+            <a:off x="2926080" y="6501384"/>
             <a:ext cx="960120" cy="164592"/>
           </a:xfrm>
           <a:prstGeom prst="rect">
@@ -3061,7 +3061,7 @@
         </p:nvSpPr>
         <p:spPr>
           <a:xfrm>
-            <a:off x="4078224" y="5806440"/>
+            <a:off x="4078224" y="6373368"/>
             <a:ext cx="109728" cy="109728"/>
           </a:xfrm>
           <a:prstGeom prst="ellipse">
@@ -3086,7 +3086,7 @@
         </p:nvSpPr>
         <p:spPr>
           <a:xfrm>
-            <a:off x="4227271" y="5749747"/>
+            <a:off x="4227271" y="6316675"/>
             <a:ext cx="777240" cy="245974"/>
           </a:xfrm>
           <a:prstGeom prst="rect">
@@ -3127,7 +3127,7 @@
         </p:nvSpPr>
         <p:spPr>
           <a:xfrm>
-            <a:off x="4233672" y="5934456"/>
+            <a:off x="4233672" y="6501384"/>
             <a:ext cx="960120" cy="164592"/>
           </a:xfrm>
           <a:prstGeom prst="rect">
@@ -3168,7 +3168,7 @@
         </p:nvSpPr>
         <p:spPr>
           <a:xfrm>
-            <a:off x="5437022" y="5806440"/>
+            <a:off x="5437022" y="6373368"/>
             <a:ext cx="109728" cy="109728"/>
           </a:xfrm>
           <a:prstGeom prst="ellipse">
@@ -3193,7 +3193,7 @@
         </p:nvSpPr>
         <p:spPr>
           <a:xfrm>
-            <a:off x="5586070" y="5749747"/>
+            <a:off x="5586070" y="6316675"/>
             <a:ext cx="777240" cy="245974"/>
           </a:xfrm>
           <a:prstGeom prst="rect">
@@ -3234,7 +3234,7 @@
         </p:nvSpPr>
         <p:spPr>
           <a:xfrm>
-            <a:off x="5592470" y="5934456"/>
+            <a:off x="5592470" y="6501384"/>
             <a:ext cx="960120" cy="164592"/>
           </a:xfrm>
           <a:prstGeom prst="rect">
@@ -3275,7 +3275,7 @@
         </p:nvSpPr>
         <p:spPr>
           <a:xfrm>
-            <a:off x="6765646" y="5806440"/>
+            <a:off x="6765646" y="6373368"/>
             <a:ext cx="109728" cy="109728"/>
           </a:xfrm>
           <a:prstGeom prst="ellipse">
@@ -3300,7 +3300,7 @@
         </p:nvSpPr>
         <p:spPr>
           <a:xfrm>
-            <a:off x="6914693" y="5749747"/>
+            <a:off x="6914693" y="6316675"/>
             <a:ext cx="777240" cy="245974"/>
           </a:xfrm>
           <a:prstGeom prst="rect">
@@ -3341,7 +3341,7 @@
         </p:nvSpPr>
         <p:spPr>
           <a:xfrm>
-            <a:off x="6921094" y="5934456"/>
+            <a:off x="6921094" y="6501384"/>
             <a:ext cx="960120" cy="164592"/>
           </a:xfrm>
           <a:prstGeom prst="rect">
@@ -3382,7 +3382,7 @@
         </p:nvSpPr>
         <p:spPr>
           <a:xfrm>
-            <a:off x="8108899" y="5806440"/>
+            <a:off x="8108899" y="6373368"/>
             <a:ext cx="109728" cy="109728"/>
           </a:xfrm>
           <a:prstGeom prst="ellipse">
@@ -3407,7 +3407,7 @@
         </p:nvSpPr>
         <p:spPr>
           <a:xfrm>
-            <a:off x="8257946" y="5749747"/>
+            <a:off x="8257946" y="6316675"/>
             <a:ext cx="777240" cy="245974"/>
           </a:xfrm>
           <a:prstGeom prst="rect">
@@ -3448,7 +3448,7 @@
         </p:nvSpPr>
         <p:spPr>
           <a:xfrm>
-            <a:off x="8264347" y="5934456"/>
+            <a:off x="8264347" y="6501384"/>
             <a:ext cx="960120" cy="164592"/>
           </a:xfrm>
           <a:prstGeom prst="rect">

</xml_diff>

<commit_message>
Ranking PPTX: gradasi kotak nilai jadi terang di atas & bawah
Gradasi sebelumnya biru muda (atas) -> biru tua (bawah). Sekarang dibalik
sesuai permintaan: biru lebih MUDA di bagian atas dan bawah, dan biru
seperti warna sekarang di bagian TENGAH.

  lapis 1 (atas)   6E93F0  terang
  lapis 2          4E76E4  sedang
  lapis 3 (tengah) 2E56D4  biru sekarang  <-- paling gelap
  lapis 4          4E76E4  sedang
  lapis 5 (bawah)  6E93F0  terang

Turut disertakan perubahan sebelumnya yang belum ter-commit:
- Panel legenda turun hampir menyentuh tepi bawah (berhenti di 7,470 inci,
  selisih 0,030 dari tepi; referensi 0,033)
- Nama cabang tidak bold lagi, ukuran tetap 20 pt Poppins

127 unit test lulus.
</commit_message>
<xml_diff>
--- a/ranking-nyata.pptx
+++ b/ranking-nyata.pptx
@@ -2617,11 +2617,11 @@
             <a:avLst/>
           </a:prstGeom>
           <a:solidFill>
-            <a:srgbClr val="4E7BE8"/>
+            <a:srgbClr val="6E93F0"/>
           </a:solidFill>
           <a:ln w="12700">
             <a:solidFill>
-              <a:srgbClr val="4E7BE8"/>
+              <a:srgbClr val="6E93F0"/>
             </a:solidFill>
             <a:prstDash val="solid"/>
           </a:ln>
@@ -2642,11 +2642,11 @@
             <a:avLst/>
           </a:prstGeom>
           <a:solidFill>
-            <a:srgbClr val="3D68DF"/>
+            <a:srgbClr val="4E76E4"/>
           </a:solidFill>
           <a:ln w="12700">
             <a:solidFill>
-              <a:srgbClr val="3D68DF"/>
+              <a:srgbClr val="4E76E4"/>
             </a:solidFill>
             <a:prstDash val="solid"/>
           </a:ln>
@@ -2692,11 +2692,11 @@
             <a:avLst/>
           </a:prstGeom>
           <a:solidFill>
-            <a:srgbClr val="2348C4"/>
+            <a:srgbClr val="4E76E4"/>
           </a:solidFill>
           <a:ln w="12700">
             <a:solidFill>
-              <a:srgbClr val="2348C4"/>
+              <a:srgbClr val="4E76E4"/>
             </a:solidFill>
             <a:prstDash val="solid"/>
           </a:ln>
@@ -2717,11 +2717,11 @@
             <a:avLst/>
           </a:prstGeom>
           <a:solidFill>
-            <a:srgbClr val="1B3AAE"/>
+            <a:srgbClr val="6E93F0"/>
           </a:solidFill>
           <a:ln w="12700">
             <a:solidFill>
-              <a:srgbClr val="1B3AAE"/>
+              <a:srgbClr val="6E93F0"/>
             </a:solidFill>
             <a:prstDash val="solid"/>
           </a:ln>

</xml_diff>

<commit_message>
Ranking PPTX: bagian tengah kotak nilai jadi 50% tinggi
Komposisi gradasi kotak nilai diubah sesuai permintaan:
  - 50% tengah  : biru 2E56D4 (biru sekarang), merata
  - 25% atas    : 7FA0F3 -> 5A82EA -> 3D68DF
  - 25% bawah   : 3D68DF -> 5A82EA -> 7FA0F3

Sebelumnya hanya 20% tengah (1 dari 5 lapis). Sekarang sisi terang
dipadatkan jadi 3 lapis per sisi supaya peralihannya tetap mulus
walaupun porsinya mengecil.

Konstanta gradasi kini menyimpan posisi (atur) dan tinggi sebagai
proporsi 0..1, dikalikan tinggi kotak saat menggambar — jadi kalau
tinggi kotak diubah nanti, gradasinya ikut menyesuaikan sendiri.
TENGAH_PROPORSI 0.5 di satu tempat: ubah di situ kalau porsinya
mau disetel lagi.

127 unit test lulus.
</commit_message>
<xml_diff>
--- a/ranking-nyata.pptx
+++ b/ranking-nyata.pptx
@@ -2611,17 +2611,17 @@
         <p:spPr>
           <a:xfrm>
             <a:off x="4708246" y="2186330"/>
-            <a:ext cx="3977640" cy="82296"/>
-          </a:xfrm>
-          <a:prstGeom prst="rect">
-            <a:avLst/>
-          </a:prstGeom>
-          <a:solidFill>
-            <a:srgbClr val="6E93F0"/>
+            <a:ext cx="3977640" cy="39624"/>
+          </a:xfrm>
+          <a:prstGeom prst="rect">
+            <a:avLst/>
+          </a:prstGeom>
+          <a:solidFill>
+            <a:srgbClr val="7FA0F3"/>
           </a:solidFill>
           <a:ln w="12700">
             <a:solidFill>
-              <a:srgbClr val="6E93F0"/>
+              <a:srgbClr val="7FA0F3"/>
             </a:solidFill>
             <a:prstDash val="solid"/>
           </a:ln>
@@ -2635,18 +2635,18 @@
         </p:nvSpPr>
         <p:spPr>
           <a:xfrm>
-            <a:off x="4708246" y="2259482"/>
-            <a:ext cx="3977640" cy="82296"/>
-          </a:xfrm>
-          <a:prstGeom prst="rect">
-            <a:avLst/>
-          </a:prstGeom>
-          <a:solidFill>
-            <a:srgbClr val="4E76E4"/>
+            <a:off x="4708246" y="2216810"/>
+            <a:ext cx="3977640" cy="39624"/>
+          </a:xfrm>
+          <a:prstGeom prst="rect">
+            <a:avLst/>
+          </a:prstGeom>
+          <a:solidFill>
+            <a:srgbClr val="5A82EA"/>
           </a:solidFill>
           <a:ln w="12700">
             <a:solidFill>
-              <a:srgbClr val="4E76E4"/>
+              <a:srgbClr val="5A82EA"/>
             </a:solidFill>
             <a:prstDash val="solid"/>
           </a:ln>
@@ -2660,8 +2660,33 @@
         </p:nvSpPr>
         <p:spPr>
           <a:xfrm>
-            <a:off x="4708246" y="2332634"/>
-            <a:ext cx="3977640" cy="82296"/>
+            <a:off x="4708246" y="2247290"/>
+            <a:ext cx="3977640" cy="39624"/>
+          </a:xfrm>
+          <a:prstGeom prst="rect">
+            <a:avLst/>
+          </a:prstGeom>
+          <a:solidFill>
+            <a:srgbClr val="3D68DF"/>
+          </a:solidFill>
+          <a:ln w="12700">
+            <a:solidFill>
+              <a:srgbClr val="3D68DF"/>
+            </a:solidFill>
+            <a:prstDash val="solid"/>
+          </a:ln>
+        </p:spPr>
+      </p:sp>
+      <p:sp>
+        <p:nvSpPr>
+          <p:cNvPr id="16" name="Shape 10"/>
+          <p:cNvSpPr/>
+          <p:nvPr/>
+        </p:nvSpPr>
+        <p:spPr>
+          <a:xfrm>
+            <a:off x="4708246" y="2277770"/>
+            <a:ext cx="3977640" cy="192024"/>
           </a:xfrm>
           <a:prstGeom prst="rect">
             <a:avLst/>
@@ -2679,24 +2704,24 @@
       </p:sp>
       <p:sp>
         <p:nvSpPr>
-          <p:cNvPr id="16" name="Shape 10"/>
-          <p:cNvSpPr/>
-          <p:nvPr/>
-        </p:nvSpPr>
-        <p:spPr>
-          <a:xfrm>
-            <a:off x="4708246" y="2405786"/>
-            <a:ext cx="3977640" cy="82296"/>
-          </a:xfrm>
-          <a:prstGeom prst="rect">
-            <a:avLst/>
-          </a:prstGeom>
-          <a:solidFill>
-            <a:srgbClr val="4E76E4"/>
+          <p:cNvPr id="17" name="Shape 11"/>
+          <p:cNvSpPr/>
+          <p:nvPr/>
+        </p:nvSpPr>
+        <p:spPr>
+          <a:xfrm>
+            <a:off x="4708246" y="2460650"/>
+            <a:ext cx="3977640" cy="39624"/>
+          </a:xfrm>
+          <a:prstGeom prst="rect">
+            <a:avLst/>
+          </a:prstGeom>
+          <a:solidFill>
+            <a:srgbClr val="3D68DF"/>
           </a:solidFill>
           <a:ln w="12700">
             <a:solidFill>
-              <a:srgbClr val="4E76E4"/>
+              <a:srgbClr val="3D68DF"/>
             </a:solidFill>
             <a:prstDash val="solid"/>
           </a:ln>
@@ -2704,24 +2729,24 @@
       </p:sp>
       <p:sp>
         <p:nvSpPr>
-          <p:cNvPr id="17" name="Shape 11"/>
-          <p:cNvSpPr/>
-          <p:nvPr/>
-        </p:nvSpPr>
-        <p:spPr>
-          <a:xfrm>
-            <a:off x="4708246" y="2478938"/>
-            <a:ext cx="3977640" cy="82296"/>
-          </a:xfrm>
-          <a:prstGeom prst="rect">
-            <a:avLst/>
-          </a:prstGeom>
-          <a:solidFill>
-            <a:srgbClr val="6E93F0"/>
+          <p:cNvPr id="18" name="Shape 12"/>
+          <p:cNvSpPr/>
+          <p:nvPr/>
+        </p:nvSpPr>
+        <p:spPr>
+          <a:xfrm>
+            <a:off x="4708246" y="2491130"/>
+            <a:ext cx="3977640" cy="39624"/>
+          </a:xfrm>
+          <a:prstGeom prst="rect">
+            <a:avLst/>
+          </a:prstGeom>
+          <a:solidFill>
+            <a:srgbClr val="5A82EA"/>
           </a:solidFill>
           <a:ln w="12700">
             <a:solidFill>
-              <a:srgbClr val="6E93F0"/>
+              <a:srgbClr val="5A82EA"/>
             </a:solidFill>
             <a:prstDash val="solid"/>
           </a:ln>
@@ -2729,7 +2754,32 @@
       </p:sp>
       <p:sp>
         <p:nvSpPr>
-          <p:cNvPr id="18" name="Shape 12"/>
+          <p:cNvPr id="19" name="Shape 13"/>
+          <p:cNvSpPr/>
+          <p:nvPr/>
+        </p:nvSpPr>
+        <p:spPr>
+          <a:xfrm>
+            <a:off x="4708246" y="2521610"/>
+            <a:ext cx="3977640" cy="39624"/>
+          </a:xfrm>
+          <a:prstGeom prst="rect">
+            <a:avLst/>
+          </a:prstGeom>
+          <a:solidFill>
+            <a:srgbClr val="7FA0F3"/>
+          </a:solidFill>
+          <a:ln w="12700">
+            <a:solidFill>
+              <a:srgbClr val="7FA0F3"/>
+            </a:solidFill>
+            <a:prstDash val="solid"/>
+          </a:ln>
+        </p:spPr>
+      </p:sp>
+      <p:sp>
+        <p:nvSpPr>
+          <p:cNvPr id="20" name="Shape 14"/>
           <p:cNvSpPr/>
           <p:nvPr/>
         </p:nvSpPr>
@@ -2751,7 +2801,7 @@
       </p:sp>
       <p:sp>
         <p:nvSpPr>
-          <p:cNvPr id="19" name="Text 13"/>
+          <p:cNvPr id="21" name="Text 15"/>
           <p:cNvSpPr/>
           <p:nvPr/>
         </p:nvSpPr>
@@ -2790,7 +2840,7 @@
       </p:sp>
       <p:sp>
         <p:nvSpPr>
-          <p:cNvPr id="20" name="Shape 14"/>
+          <p:cNvPr id="22" name="Shape 16"/>
           <p:cNvSpPr/>
           <p:nvPr/>
         </p:nvSpPr>
@@ -2817,7 +2867,7 @@
       </p:sp>
       <p:sp>
         <p:nvSpPr>
-          <p:cNvPr id="21" name="Text 15"/>
+          <p:cNvPr id="23" name="Text 17"/>
           <p:cNvSpPr/>
           <p:nvPr/>
         </p:nvSpPr>
@@ -2858,7 +2908,7 @@
       </p:sp>
       <p:sp>
         <p:nvSpPr>
-          <p:cNvPr id="22" name="Shape 16"/>
+          <p:cNvPr id="24" name="Shape 18"/>
           <p:cNvSpPr/>
           <p:nvPr/>
         </p:nvSpPr>
@@ -2885,7 +2935,7 @@
       </p:sp>
       <p:sp>
         <p:nvSpPr>
-          <p:cNvPr id="23" name="Shape 17"/>
+          <p:cNvPr id="25" name="Shape 19"/>
           <p:cNvSpPr/>
           <p:nvPr/>
         </p:nvSpPr>
@@ -2909,7 +2959,7 @@
       </p:sp>
       <p:sp>
         <p:nvSpPr>
-          <p:cNvPr id="24" name="Text 18"/>
+          <p:cNvPr id="26" name="Text 20"/>
           <p:cNvSpPr/>
           <p:nvPr/>
         </p:nvSpPr>
@@ -2948,7 +2998,7 @@
       </p:sp>
       <p:sp>
         <p:nvSpPr>
-          <p:cNvPr id="25" name="Shape 19"/>
+          <p:cNvPr id="27" name="Shape 21"/>
           <p:cNvSpPr/>
           <p:nvPr/>
         </p:nvSpPr>
@@ -2973,7 +3023,7 @@
       </p:sp>
       <p:sp>
         <p:nvSpPr>
-          <p:cNvPr id="26" name="Text 20"/>
+          <p:cNvPr id="28" name="Text 22"/>
           <p:cNvSpPr/>
           <p:nvPr/>
         </p:nvSpPr>
@@ -3014,7 +3064,7 @@
       </p:sp>
       <p:sp>
         <p:nvSpPr>
-          <p:cNvPr id="27" name="Text 21"/>
+          <p:cNvPr id="29" name="Text 23"/>
           <p:cNvSpPr/>
           <p:nvPr/>
         </p:nvSpPr>
@@ -3055,7 +3105,7 @@
       </p:sp>
       <p:sp>
         <p:nvSpPr>
-          <p:cNvPr id="28" name="Shape 22"/>
+          <p:cNvPr id="30" name="Shape 24"/>
           <p:cNvSpPr/>
           <p:nvPr/>
         </p:nvSpPr>
@@ -3080,7 +3130,7 @@
       </p:sp>
       <p:sp>
         <p:nvSpPr>
-          <p:cNvPr id="29" name="Text 23"/>
+          <p:cNvPr id="31" name="Text 25"/>
           <p:cNvSpPr/>
           <p:nvPr/>
         </p:nvSpPr>
@@ -3121,7 +3171,7 @@
       </p:sp>
       <p:sp>
         <p:nvSpPr>
-          <p:cNvPr id="30" name="Text 24"/>
+          <p:cNvPr id="32" name="Text 26"/>
           <p:cNvSpPr/>
           <p:nvPr/>
         </p:nvSpPr>
@@ -3162,7 +3212,7 @@
       </p:sp>
       <p:sp>
         <p:nvSpPr>
-          <p:cNvPr id="31" name="Shape 25"/>
+          <p:cNvPr id="33" name="Shape 27"/>
           <p:cNvSpPr/>
           <p:nvPr/>
         </p:nvSpPr>
@@ -3187,7 +3237,7 @@
       </p:sp>
       <p:sp>
         <p:nvSpPr>
-          <p:cNvPr id="32" name="Text 26"/>
+          <p:cNvPr id="34" name="Text 28"/>
           <p:cNvSpPr/>
           <p:nvPr/>
         </p:nvSpPr>
@@ -3228,7 +3278,7 @@
       </p:sp>
       <p:sp>
         <p:nvSpPr>
-          <p:cNvPr id="33" name="Text 27"/>
+          <p:cNvPr id="35" name="Text 29"/>
           <p:cNvSpPr/>
           <p:nvPr/>
         </p:nvSpPr>
@@ -3269,7 +3319,7 @@
       </p:sp>
       <p:sp>
         <p:nvSpPr>
-          <p:cNvPr id="34" name="Shape 28"/>
+          <p:cNvPr id="36" name="Shape 30"/>
           <p:cNvSpPr/>
           <p:nvPr/>
         </p:nvSpPr>
@@ -3294,7 +3344,7 @@
       </p:sp>
       <p:sp>
         <p:nvSpPr>
-          <p:cNvPr id="35" name="Text 29"/>
+          <p:cNvPr id="37" name="Text 31"/>
           <p:cNvSpPr/>
           <p:nvPr/>
         </p:nvSpPr>
@@ -3335,7 +3385,7 @@
       </p:sp>
       <p:sp>
         <p:nvSpPr>
-          <p:cNvPr id="36" name="Text 30"/>
+          <p:cNvPr id="38" name="Text 32"/>
           <p:cNvSpPr/>
           <p:nvPr/>
         </p:nvSpPr>
@@ -3376,7 +3426,7 @@
       </p:sp>
       <p:sp>
         <p:nvSpPr>
-          <p:cNvPr id="37" name="Shape 31"/>
+          <p:cNvPr id="39" name="Shape 33"/>
           <p:cNvSpPr/>
           <p:nvPr/>
         </p:nvSpPr>
@@ -3401,7 +3451,7 @@
       </p:sp>
       <p:sp>
         <p:nvSpPr>
-          <p:cNvPr id="38" name="Text 32"/>
+          <p:cNvPr id="40" name="Text 34"/>
           <p:cNvSpPr/>
           <p:nvPr/>
         </p:nvSpPr>
@@ -3442,7 +3492,7 @@
       </p:sp>
       <p:sp>
         <p:nvSpPr>
-          <p:cNvPr id="39" name="Text 33"/>
+          <p:cNvPr id="41" name="Text 35"/>
           <p:cNvSpPr/>
           <p:nvPr/>
         </p:nvSpPr>

</xml_diff>

<commit_message>
Ranking PPTX: warna kotak nilai dari user — tengah #0322B8, batas #D1D1D1
Warna bagian tengah kotak nilai diganti ke #0322B8 (nilai persis dari user;
sebelumnya 2E56D4). Tangga gradasinya dihitung ulang supaya peralihannya
tetap rata — dicampur bertahap antara warna tengah dan warna ujung:

  tepi atas/bawah  7FA0F3
                    5676DF
                    2C4CCC
  TENGAH (50%)     0322B8   <- nilai dari user
                    2C4CCC
                    5676DF
  tepi atas/bawah  7FA0F3

Garis tepi kotak nilai diganti dari putih 1 pt ke #D1D1D1 0,5 pt (nilai
dari user, sama seperti pengaturan batas pada file Excel-nya).

Warna tangga tidak lagi ditulis sebagai literal di daftar gradasi, tapi
sebagai konstanta bernama — jadi kalau warna tengah diubah lagi, tinggal
ganti WARNA_TENGAH_NILAI dan hitung ulang dua nilai tangganya.

127 unit test lulus.
</commit_message>
<xml_diff>
--- a/ranking-nyata.pptx
+++ b/ranking-nyata.pptx
@@ -2642,11 +2642,11 @@
             <a:avLst/>
           </a:prstGeom>
           <a:solidFill>
-            <a:srgbClr val="5A82EA"/>
+            <a:srgbClr val="5676DF"/>
           </a:solidFill>
           <a:ln w="12700">
             <a:solidFill>
-              <a:srgbClr val="5A82EA"/>
+              <a:srgbClr val="5676DF"/>
             </a:solidFill>
             <a:prstDash val="solid"/>
           </a:ln>
@@ -2667,11 +2667,11 @@
             <a:avLst/>
           </a:prstGeom>
           <a:solidFill>
-            <a:srgbClr val="3D68DF"/>
+            <a:srgbClr val="2C4CCC"/>
           </a:solidFill>
           <a:ln w="12700">
             <a:solidFill>
-              <a:srgbClr val="3D68DF"/>
+              <a:srgbClr val="2C4CCC"/>
             </a:solidFill>
             <a:prstDash val="solid"/>
           </a:ln>
@@ -2692,11 +2692,11 @@
             <a:avLst/>
           </a:prstGeom>
           <a:solidFill>
-            <a:srgbClr val="2E56D4"/>
+            <a:srgbClr val="0322B8"/>
           </a:solidFill>
           <a:ln w="12700">
             <a:solidFill>
-              <a:srgbClr val="2E56D4"/>
+              <a:srgbClr val="0322B8"/>
             </a:solidFill>
             <a:prstDash val="solid"/>
           </a:ln>
@@ -2717,11 +2717,11 @@
             <a:avLst/>
           </a:prstGeom>
           <a:solidFill>
-            <a:srgbClr val="3D68DF"/>
+            <a:srgbClr val="2C4CCC"/>
           </a:solidFill>
           <a:ln w="12700">
             <a:solidFill>
-              <a:srgbClr val="3D68DF"/>
+              <a:srgbClr val="2C4CCC"/>
             </a:solidFill>
             <a:prstDash val="solid"/>
           </a:ln>
@@ -2742,11 +2742,11 @@
             <a:avLst/>
           </a:prstGeom>
           <a:solidFill>
-            <a:srgbClr val="5A82EA"/>
+            <a:srgbClr val="5676DF"/>
           </a:solidFill>
           <a:ln w="12700">
             <a:solidFill>
-              <a:srgbClr val="5A82EA"/>
+              <a:srgbClr val="5676DF"/>
             </a:solidFill>
             <a:prstDash val="solid"/>
           </a:ln>
@@ -2791,9 +2791,9 @@
           <a:prstGeom prst="rect">
             <a:avLst/>
           </a:prstGeom>
-          <a:ln w="12700">
+          <a:ln w="6350">
             <a:solidFill>
-              <a:srgbClr val="FFFFFF"/>
+              <a:srgbClr val="D1D1D1"/>
             </a:solidFill>
             <a:prstDash val="solid"/>
           </a:ln>

</xml_diff>

<commit_message>
Ranking PPTX: sisi atas & bawah kotak nilai jadi #2C4CCC datar
Sesuai permintaan: bagian atas dan bawah kotak nilai sekarang memakai satu
warna datar #2C4CCC (sebelumnya bertangga 7FA0F3/5676DF/2C4CCC). Hasilnya
kotak nilai jadi 3 pita:

  25% atas   #2C4CCC
  50% tengah #0322B8
  25% bawah  #2C4CCC

Batas antara pita terlihat tegas, bukan gradasi mulus. Jumlah lapis turun
dari 7 jadi 3 sehingga berkasnya juga lebih ringan.

Warna ujung #7FA0F3 disimpan sebagai konstanta cadangan (WARNA_UJUNG_NILAI)
kalau nanti mau dikembalikan ke versi bertangga.

127 unit test lulus.
</commit_message>
<xml_diff>
--- a/ranking-nyata.pptx
+++ b/ranking-nyata.pptx
@@ -2611,57 +2611,7 @@
         <p:spPr>
           <a:xfrm>
             <a:off x="4708246" y="2186330"/>
-            <a:ext cx="3977640" cy="39624"/>
-          </a:xfrm>
-          <a:prstGeom prst="rect">
-            <a:avLst/>
-          </a:prstGeom>
-          <a:solidFill>
-            <a:srgbClr val="7FA0F3"/>
-          </a:solidFill>
-          <a:ln w="12700">
-            <a:solidFill>
-              <a:srgbClr val="7FA0F3"/>
-            </a:solidFill>
-            <a:prstDash val="solid"/>
-          </a:ln>
-        </p:spPr>
-      </p:sp>
-      <p:sp>
-        <p:nvSpPr>
-          <p:cNvPr id="14" name="Shape 8"/>
-          <p:cNvSpPr/>
-          <p:nvPr/>
-        </p:nvSpPr>
-        <p:spPr>
-          <a:xfrm>
-            <a:off x="4708246" y="2216810"/>
-            <a:ext cx="3977640" cy="39624"/>
-          </a:xfrm>
-          <a:prstGeom prst="rect">
-            <a:avLst/>
-          </a:prstGeom>
-          <a:solidFill>
-            <a:srgbClr val="5676DF"/>
-          </a:solidFill>
-          <a:ln w="12700">
-            <a:solidFill>
-              <a:srgbClr val="5676DF"/>
-            </a:solidFill>
-            <a:prstDash val="solid"/>
-          </a:ln>
-        </p:spPr>
-      </p:sp>
-      <p:sp>
-        <p:nvSpPr>
-          <p:cNvPr id="15" name="Shape 9"/>
-          <p:cNvSpPr/>
-          <p:nvPr/>
-        </p:nvSpPr>
-        <p:spPr>
-          <a:xfrm>
-            <a:off x="4708246" y="2247290"/>
-            <a:ext cx="3977640" cy="39624"/>
+            <a:ext cx="3977640" cy="100584"/>
           </a:xfrm>
           <a:prstGeom prst="rect">
             <a:avLst/>
@@ -2679,7 +2629,7 @@
       </p:sp>
       <p:sp>
         <p:nvSpPr>
-          <p:cNvPr id="16" name="Shape 10"/>
+          <p:cNvPr id="14" name="Shape 8"/>
           <p:cNvSpPr/>
           <p:nvPr/>
         </p:nvSpPr>
@@ -2704,14 +2654,14 @@
       </p:sp>
       <p:sp>
         <p:nvSpPr>
-          <p:cNvPr id="17" name="Shape 11"/>
+          <p:cNvPr id="15" name="Shape 9"/>
           <p:cNvSpPr/>
           <p:nvPr/>
         </p:nvSpPr>
         <p:spPr>
           <a:xfrm>
             <a:off x="4708246" y="2460650"/>
-            <a:ext cx="3977640" cy="39624"/>
+            <a:ext cx="3977640" cy="100584"/>
           </a:xfrm>
           <a:prstGeom prst="rect">
             <a:avLst/>
@@ -2729,57 +2679,7 @@
       </p:sp>
       <p:sp>
         <p:nvSpPr>
-          <p:cNvPr id="18" name="Shape 12"/>
-          <p:cNvSpPr/>
-          <p:nvPr/>
-        </p:nvSpPr>
-        <p:spPr>
-          <a:xfrm>
-            <a:off x="4708246" y="2491130"/>
-            <a:ext cx="3977640" cy="39624"/>
-          </a:xfrm>
-          <a:prstGeom prst="rect">
-            <a:avLst/>
-          </a:prstGeom>
-          <a:solidFill>
-            <a:srgbClr val="5676DF"/>
-          </a:solidFill>
-          <a:ln w="12700">
-            <a:solidFill>
-              <a:srgbClr val="5676DF"/>
-            </a:solidFill>
-            <a:prstDash val="solid"/>
-          </a:ln>
-        </p:spPr>
-      </p:sp>
-      <p:sp>
-        <p:nvSpPr>
-          <p:cNvPr id="19" name="Shape 13"/>
-          <p:cNvSpPr/>
-          <p:nvPr/>
-        </p:nvSpPr>
-        <p:spPr>
-          <a:xfrm>
-            <a:off x="4708246" y="2521610"/>
-            <a:ext cx="3977640" cy="39624"/>
-          </a:xfrm>
-          <a:prstGeom prst="rect">
-            <a:avLst/>
-          </a:prstGeom>
-          <a:solidFill>
-            <a:srgbClr val="7FA0F3"/>
-          </a:solidFill>
-          <a:ln w="12700">
-            <a:solidFill>
-              <a:srgbClr val="7FA0F3"/>
-            </a:solidFill>
-            <a:prstDash val="solid"/>
-          </a:ln>
-        </p:spPr>
-      </p:sp>
-      <p:sp>
-        <p:nvSpPr>
-          <p:cNvPr id="20" name="Shape 14"/>
+          <p:cNvPr id="16" name="Shape 10"/>
           <p:cNvSpPr/>
           <p:nvPr/>
         </p:nvSpPr>
@@ -2801,7 +2701,7 @@
       </p:sp>
       <p:sp>
         <p:nvSpPr>
-          <p:cNvPr id="21" name="Text 15"/>
+          <p:cNvPr id="17" name="Text 11"/>
           <p:cNvSpPr/>
           <p:nvPr/>
         </p:nvSpPr>
@@ -2840,7 +2740,7 @@
       </p:sp>
       <p:sp>
         <p:nvSpPr>
-          <p:cNvPr id="22" name="Shape 16"/>
+          <p:cNvPr id="18" name="Shape 12"/>
           <p:cNvSpPr/>
           <p:nvPr/>
         </p:nvSpPr>
@@ -2867,7 +2767,7 @@
       </p:sp>
       <p:sp>
         <p:nvSpPr>
-          <p:cNvPr id="23" name="Text 17"/>
+          <p:cNvPr id="19" name="Text 13"/>
           <p:cNvSpPr/>
           <p:nvPr/>
         </p:nvSpPr>
@@ -2908,7 +2808,7 @@
       </p:sp>
       <p:sp>
         <p:nvSpPr>
-          <p:cNvPr id="24" name="Shape 18"/>
+          <p:cNvPr id="20" name="Shape 14"/>
           <p:cNvSpPr/>
           <p:nvPr/>
         </p:nvSpPr>
@@ -2935,7 +2835,7 @@
       </p:sp>
       <p:sp>
         <p:nvSpPr>
-          <p:cNvPr id="25" name="Shape 19"/>
+          <p:cNvPr id="21" name="Shape 15"/>
           <p:cNvSpPr/>
           <p:nvPr/>
         </p:nvSpPr>
@@ -2959,7 +2859,7 @@
       </p:sp>
       <p:sp>
         <p:nvSpPr>
-          <p:cNvPr id="26" name="Text 20"/>
+          <p:cNvPr id="22" name="Text 16"/>
           <p:cNvSpPr/>
           <p:nvPr/>
         </p:nvSpPr>
@@ -2998,7 +2898,7 @@
       </p:sp>
       <p:sp>
         <p:nvSpPr>
-          <p:cNvPr id="27" name="Shape 21"/>
+          <p:cNvPr id="23" name="Shape 17"/>
           <p:cNvSpPr/>
           <p:nvPr/>
         </p:nvSpPr>
@@ -3023,7 +2923,7 @@
       </p:sp>
       <p:sp>
         <p:nvSpPr>
-          <p:cNvPr id="28" name="Text 22"/>
+          <p:cNvPr id="24" name="Text 18"/>
           <p:cNvSpPr/>
           <p:nvPr/>
         </p:nvSpPr>
@@ -3064,7 +2964,7 @@
       </p:sp>
       <p:sp>
         <p:nvSpPr>
-          <p:cNvPr id="29" name="Text 23"/>
+          <p:cNvPr id="25" name="Text 19"/>
           <p:cNvSpPr/>
           <p:nvPr/>
         </p:nvSpPr>
@@ -3105,7 +3005,7 @@
       </p:sp>
       <p:sp>
         <p:nvSpPr>
-          <p:cNvPr id="30" name="Shape 24"/>
+          <p:cNvPr id="26" name="Shape 20"/>
           <p:cNvSpPr/>
           <p:nvPr/>
         </p:nvSpPr>
@@ -3130,7 +3030,7 @@
       </p:sp>
       <p:sp>
         <p:nvSpPr>
-          <p:cNvPr id="31" name="Text 25"/>
+          <p:cNvPr id="27" name="Text 21"/>
           <p:cNvSpPr/>
           <p:nvPr/>
         </p:nvSpPr>
@@ -3171,7 +3071,7 @@
       </p:sp>
       <p:sp>
         <p:nvSpPr>
-          <p:cNvPr id="32" name="Text 26"/>
+          <p:cNvPr id="28" name="Text 22"/>
           <p:cNvSpPr/>
           <p:nvPr/>
         </p:nvSpPr>
@@ -3212,7 +3112,7 @@
       </p:sp>
       <p:sp>
         <p:nvSpPr>
-          <p:cNvPr id="33" name="Shape 27"/>
+          <p:cNvPr id="29" name="Shape 23"/>
           <p:cNvSpPr/>
           <p:nvPr/>
         </p:nvSpPr>
@@ -3237,7 +3137,7 @@
       </p:sp>
       <p:sp>
         <p:nvSpPr>
-          <p:cNvPr id="34" name="Text 28"/>
+          <p:cNvPr id="30" name="Text 24"/>
           <p:cNvSpPr/>
           <p:nvPr/>
         </p:nvSpPr>
@@ -3278,7 +3178,7 @@
       </p:sp>
       <p:sp>
         <p:nvSpPr>
-          <p:cNvPr id="35" name="Text 29"/>
+          <p:cNvPr id="31" name="Text 25"/>
           <p:cNvSpPr/>
           <p:nvPr/>
         </p:nvSpPr>
@@ -3319,7 +3219,7 @@
       </p:sp>
       <p:sp>
         <p:nvSpPr>
-          <p:cNvPr id="36" name="Shape 30"/>
+          <p:cNvPr id="32" name="Shape 26"/>
           <p:cNvSpPr/>
           <p:nvPr/>
         </p:nvSpPr>
@@ -3344,7 +3244,7 @@
       </p:sp>
       <p:sp>
         <p:nvSpPr>
-          <p:cNvPr id="37" name="Text 31"/>
+          <p:cNvPr id="33" name="Text 27"/>
           <p:cNvSpPr/>
           <p:nvPr/>
         </p:nvSpPr>
@@ -3385,7 +3285,7 @@
       </p:sp>
       <p:sp>
         <p:nvSpPr>
-          <p:cNvPr id="38" name="Text 32"/>
+          <p:cNvPr id="34" name="Text 28"/>
           <p:cNvSpPr/>
           <p:nvPr/>
         </p:nvSpPr>
@@ -3426,7 +3326,7 @@
       </p:sp>
       <p:sp>
         <p:nvSpPr>
-          <p:cNvPr id="39" name="Shape 33"/>
+          <p:cNvPr id="35" name="Shape 29"/>
           <p:cNvSpPr/>
           <p:nvPr/>
         </p:nvSpPr>
@@ -3451,7 +3351,7 @@
       </p:sp>
       <p:sp>
         <p:nvSpPr>
-          <p:cNvPr id="40" name="Text 34"/>
+          <p:cNvPr id="36" name="Text 30"/>
           <p:cNvSpPr/>
           <p:nvPr/>
         </p:nvSpPr>
@@ -3492,7 +3392,7 @@
       </p:sp>
       <p:sp>
         <p:nvSpPr>
-          <p:cNvPr id="41" name="Text 35"/>
+          <p:cNvPr id="37" name="Text 31"/>
           <p:cNvSpPr/>
           <p:nvPr/>
         </p:nvSpPr>

</xml_diff>

<commit_message>
Ranking PPTX: label SKALA PENILAIAN berlatar biru donker di atas kotak
- Kotak label 'SKALA PENILAIAN' kini BERLATAR BIRU DONKER #0B1E6B
  (sebelumnya transparan dengan garis putih saja), teks tetap putih.
- Posisinya menempel TEPAT di atas panel putih legenda: batas bawah label
  = tepi atas panel (selisih 0,000 inci), jadi terlihat sebagai judul
  kotak legenda, bukan kotak melayang di atasnya.

127 unit test lulus.
</commit_message>
<xml_diff>
--- a/ranking-nyata.pptx
+++ b/ranking-nyata.pptx
@@ -1648,16 +1648,19 @@
         <p:spPr>
           <a:xfrm>
             <a:off x="4754880" y="5925312"/>
-            <a:ext cx="1828800" cy="310896"/>
+            <a:ext cx="1828800" cy="246888"/>
           </a:xfrm>
           <a:prstGeom prst="roundRect">
             <a:avLst>
-              <a:gd name="adj" fmla="val 52941"/>
+              <a:gd name="adj" fmla="val 66667"/>
             </a:avLst>
           </a:prstGeom>
+          <a:solidFill>
+            <a:srgbClr val="0B1E6B"/>
+          </a:solidFill>
           <a:ln w="12700">
             <a:solidFill>
-              <a:srgbClr val="FFFFFF"/>
+              <a:srgbClr val="0B1E6B"/>
             </a:solidFill>
             <a:prstDash val="solid"/>
           </a:ln>
@@ -1672,7 +1675,7 @@
         <p:spPr>
           <a:xfrm>
             <a:off x="4754880" y="5952744"/>
-            <a:ext cx="1828800" cy="228600"/>
+            <a:ext cx="1828800" cy="256032"/>
           </a:xfrm>
           <a:prstGeom prst="rect">
             <a:avLst/>
@@ -2842,16 +2845,19 @@
         <p:spPr>
           <a:xfrm>
             <a:off x="4754880" y="5925312"/>
-            <a:ext cx="1828800" cy="310896"/>
+            <a:ext cx="1828800" cy="246888"/>
           </a:xfrm>
           <a:prstGeom prst="roundRect">
             <a:avLst>
-              <a:gd name="adj" fmla="val 52941"/>
+              <a:gd name="adj" fmla="val 66667"/>
             </a:avLst>
           </a:prstGeom>
+          <a:solidFill>
+            <a:srgbClr val="0B1E6B"/>
+          </a:solidFill>
           <a:ln w="12700">
             <a:solidFill>
-              <a:srgbClr val="FFFFFF"/>
+              <a:srgbClr val="0B1E6B"/>
             </a:solidFill>
             <a:prstDash val="solid"/>
           </a:ln>
@@ -2866,7 +2872,7 @@
         <p:spPr>
           <a:xfrm>
             <a:off x="4754880" y="5952744"/>
-            <a:ext cx="1828800" cy="228600"/>
+            <a:ext cx="1828800" cy="256032"/>
           </a:xfrm>
           <a:prstGeom prst="rect">
             <a:avLst/>

</xml_diff>

<commit_message>
Ranking PPTX: label SKALA PENILAIAN di-center, warna biru Telegram
- Posisi label kini di-CENTER mendatar terhadap panel legenda. Sebelumnya
  x-nya angka tetap 5,200 (titik tengah 6,200) sehingga meleset 0,080 inci
  dari titik tengah panel (6,280). Sekarang x dihitung dari titik tengah
  panel, jadi kalau panel digeser/diubah lebarnya labelnya ikut center.
  Terverifikasi: titik tengah label = titik tengah panel = 6,280.
- Warna latar label diganti dari biru donker #0B1E6B ke biru agak muda
  #2AABEE (biru Telegram).

127 unit test lulus.
</commit_message>
<xml_diff>
--- a/ranking-nyata.pptx
+++ b/ranking-nyata.pptx
@@ -1647,7 +1647,7 @@
         </p:nvSpPr>
         <p:spPr>
           <a:xfrm>
-            <a:off x="4754880" y="5925312"/>
+            <a:off x="4828489" y="5925312"/>
             <a:ext cx="1828800" cy="246888"/>
           </a:xfrm>
           <a:prstGeom prst="roundRect">
@@ -1656,11 +1656,11 @@
             </a:avLst>
           </a:prstGeom>
           <a:solidFill>
-            <a:srgbClr val="0B1E6B"/>
+            <a:srgbClr val="2AABEE"/>
           </a:solidFill>
           <a:ln w="12700">
             <a:solidFill>
-              <a:srgbClr val="0B1E6B"/>
+              <a:srgbClr val="2AABEE"/>
             </a:solidFill>
             <a:prstDash val="solid"/>
           </a:ln>
@@ -1674,7 +1674,7 @@
         </p:nvSpPr>
         <p:spPr>
           <a:xfrm>
-            <a:off x="4754880" y="5952744"/>
+            <a:off x="4828489" y="5952744"/>
             <a:ext cx="1828800" cy="256032"/>
           </a:xfrm>
           <a:prstGeom prst="rect">
@@ -2844,7 +2844,7 @@
         </p:nvSpPr>
         <p:spPr>
           <a:xfrm>
-            <a:off x="4754880" y="5925312"/>
+            <a:off x="4828489" y="5925312"/>
             <a:ext cx="1828800" cy="246888"/>
           </a:xfrm>
           <a:prstGeom prst="roundRect">
@@ -2853,11 +2853,11 @@
             </a:avLst>
           </a:prstGeom>
           <a:solidFill>
-            <a:srgbClr val="0B1E6B"/>
+            <a:srgbClr val="2AABEE"/>
           </a:solidFill>
           <a:ln w="12700">
             <a:solidFill>
-              <a:srgbClr val="0B1E6B"/>
+              <a:srgbClr val="2AABEE"/>
             </a:solidFill>
             <a:prstDash val="solid"/>
           </a:ln>
@@ -2871,7 +2871,7 @@
         </p:nvSpPr>
         <p:spPr>
           <a:xfrm>
-            <a:off x="4754880" y="5952744"/>
+            <a:off x="4828489" y="5952744"/>
             <a:ext cx="1828800" cy="256032"/>
           </a:xfrm>
           <a:prstGeom prst="rect">

</xml_diff>

<commit_message>
Ranking PPTX: label SKALA PENILAIAN turun 50% tinggi label
Label sebelumnya menempel tepat di atas panel (bawah label = tepi atas
panel). Sekarang diturunkan 50% dari tinggi label sendiri (0,135 inci),
jadi separuh kotak label menempel menutupi tepi atas panel putih.

Tafsiran '50%' yang dipilih: setengah tinggi LABEL, bukan setengah tinggi
panel (yang akan menimpa baris legenda) dan bukan center tinggi panel.

Label tetap: di-center mendatar terhadap panel, berlatar #2AABEE,
teks putih 10 pt. Label digambar setelah panel sehingga tidak tertutup.

SEBELUM: label y 6,480 .. 6,750
SESUDAH: label y 6,615 .. 6,885  (panel mulai di 6,750)

127 unit test lulus.
</commit_message>
<xml_diff>
--- a/ranking-nyata.pptx
+++ b/ranking-nyata.pptx
@@ -1647,7 +1647,7 @@
         </p:nvSpPr>
         <p:spPr>
           <a:xfrm>
-            <a:off x="4828489" y="5925312"/>
+            <a:off x="4828489" y="6048756"/>
             <a:ext cx="1828800" cy="246888"/>
           </a:xfrm>
           <a:prstGeom prst="roundRect">
@@ -1674,7 +1674,7 @@
         </p:nvSpPr>
         <p:spPr>
           <a:xfrm>
-            <a:off x="4828489" y="5952744"/>
+            <a:off x="4828489" y="6076188"/>
             <a:ext cx="1828800" cy="256032"/>
           </a:xfrm>
           <a:prstGeom prst="rect">
@@ -2844,7 +2844,7 @@
         </p:nvSpPr>
         <p:spPr>
           <a:xfrm>
-            <a:off x="4828489" y="5925312"/>
+            <a:off x="4828489" y="6048756"/>
             <a:ext cx="1828800" cy="246888"/>
           </a:xfrm>
           <a:prstGeom prst="roundRect">
@@ -2871,7 +2871,7 @@
         </p:nvSpPr>
         <p:spPr>
           <a:xfrm>
-            <a:off x="4828489" y="5952744"/>
+            <a:off x="4828489" y="6076188"/>
             <a:ext cx="1828800" cy="256032"/>
           </a:xfrm>
           <a:prstGeom prst="rect">

</xml_diff>

<commit_message>
Ranking PPTX: latar label SKALA PENILAIAN jadi #D1D1D1
Latar kotak label disamakan dengan warna garis batas kotak nilai (#D1D1D1)
sesuai permintaan user.

Karena latarnya jadi terang, warna teksnya ikut diganti dari putih ke biru
tua #142D64 — teks putih di atas abu terang tidak terbaca. Warna teks
dipisah jadi konstanta WARNA_TEKS_LABEL_LEGENDA supaya mudah disetel.

127 unit test lulus.
</commit_message>
<xml_diff>
--- a/ranking-nyata.pptx
+++ b/ranking-nyata.pptx
@@ -1656,11 +1656,11 @@
             </a:avLst>
           </a:prstGeom>
           <a:solidFill>
-            <a:srgbClr val="2AABEE"/>
+            <a:srgbClr val="D1D1D1"/>
           </a:solidFill>
           <a:ln w="12700">
             <a:solidFill>
-              <a:srgbClr val="2AABEE"/>
+              <a:srgbClr val="D1D1D1"/>
             </a:solidFill>
             <a:prstDash val="solid"/>
           </a:ln>
@@ -1693,7 +1693,7 @@
             <a:r>
               <a:rPr lang="en-US" sz="1000" b="1" dirty="0">
                 <a:solidFill>
-                  <a:srgbClr val="FFFFFF"/>
+                  <a:srgbClr val="142D64"/>
                 </a:solidFill>
                 <a:latin typeface="Aptos" pitchFamily="34" charset="0"/>
                 <a:ea typeface="Aptos" pitchFamily="34" charset="-122"/>
@@ -2853,11 +2853,11 @@
             </a:avLst>
           </a:prstGeom>
           <a:solidFill>
-            <a:srgbClr val="2AABEE"/>
+            <a:srgbClr val="D1D1D1"/>
           </a:solidFill>
           <a:ln w="12700">
             <a:solidFill>
-              <a:srgbClr val="2AABEE"/>
+              <a:srgbClr val="D1D1D1"/>
             </a:solidFill>
             <a:prstDash val="solid"/>
           </a:ln>
@@ -2890,7 +2890,7 @@
             <a:r>
               <a:rPr lang="en-US" sz="1000" b="1" dirty="0">
                 <a:solidFill>
-                  <a:srgbClr val="FFFFFF"/>
+                  <a:srgbClr val="142D64"/>
                 </a:solidFill>
                 <a:latin typeface="Aptos" pitchFamily="34" charset="0"/>
                 <a:ea typeface="Aptos" pitchFamily="34" charset="-122"/>

</xml_diff>

<commit_message>
Ranking PPTX: label SKALA PENILAIAN — teks putih, latar biru tua, teks center
- Latar kotak label kembali ke biru tua #0B1E6B (dari #D1D1D1)
- Teks label kembali ke putih #FFFFFF (dari #142D64)
- Teks kini di-center TEPAT di tengah kotaknya: sebelumnya teks digeser
  +0,03 inci dari posisi kotak (dan tingginya 0,280 vs kotak 0,270),
  sehingga center-nya meleset ke bawah. Sekarang fokus teks sama persis
  dengan kotak label (x, y, w, h identik), jadi center mendatar maupun
  tegaknya tepat.

127 unit test lulus.
</commit_message>
<xml_diff>
--- a/ranking-nyata.pptx
+++ b/ranking-nyata.pptx
@@ -1656,11 +1656,11 @@
             </a:avLst>
           </a:prstGeom>
           <a:solidFill>
-            <a:srgbClr val="D1D1D1"/>
+            <a:srgbClr val="0B1E6B"/>
           </a:solidFill>
           <a:ln w="12700">
             <a:solidFill>
-              <a:srgbClr val="D1D1D1"/>
+              <a:srgbClr val="0B1E6B"/>
             </a:solidFill>
             <a:prstDash val="solid"/>
           </a:ln>
@@ -1674,8 +1674,8 @@
         </p:nvSpPr>
         <p:spPr>
           <a:xfrm>
-            <a:off x="4828489" y="6076188"/>
-            <a:ext cx="1828800" cy="256032"/>
+            <a:off x="4828489" y="6048756"/>
+            <a:ext cx="1828800" cy="246888"/>
           </a:xfrm>
           <a:prstGeom prst="rect">
             <a:avLst/>
@@ -1693,7 +1693,7 @@
             <a:r>
               <a:rPr lang="en-US" sz="1000" b="1" dirty="0">
                 <a:solidFill>
-                  <a:srgbClr val="142D64"/>
+                  <a:srgbClr val="FFFFFF"/>
                 </a:solidFill>
                 <a:latin typeface="Aptos" pitchFamily="34" charset="0"/>
                 <a:ea typeface="Aptos" pitchFamily="34" charset="-122"/>
@@ -2853,11 +2853,11 @@
             </a:avLst>
           </a:prstGeom>
           <a:solidFill>
-            <a:srgbClr val="D1D1D1"/>
+            <a:srgbClr val="0B1E6B"/>
           </a:solidFill>
           <a:ln w="12700">
             <a:solidFill>
-              <a:srgbClr val="D1D1D1"/>
+              <a:srgbClr val="0B1E6B"/>
             </a:solidFill>
             <a:prstDash val="solid"/>
           </a:ln>
@@ -2871,8 +2871,8 @@
         </p:nvSpPr>
         <p:spPr>
           <a:xfrm>
-            <a:off x="4828489" y="6076188"/>
-            <a:ext cx="1828800" cy="256032"/>
+            <a:off x="4828489" y="6048756"/>
+            <a:ext cx="1828800" cy="246888"/>
           </a:xfrm>
           <a:prstGeom prst="rect">
             <a:avLst/>
@@ -2890,7 +2890,7 @@
             <a:r>
               <a:rPr lang="en-US" sz="1000" b="1" dirty="0">
                 <a:solidFill>
-                  <a:srgbClr val="142D64"/>
+                  <a:srgbClr val="FFFFFF"/>
                 </a:solidFill>
                 <a:latin typeface="Aptos" pitchFamily="34" charset="0"/>
                 <a:ea typeface="Aptos" pitchFamily="34" charset="-122"/>

</xml_diff>

<commit_message>
Ranking PPTX: tinggi pil kategori disamakan dengan kotak nilai
Pil kategori (status nilai, paling kanan) sebelumnya 0,52 inci sedangkan
kotak nilai 0,40 inci, sehingga pilnya lebih tinggi dan tidak sejajar.

Sekarang keduanya memakai satu konstanta KOTAK_NILAI_TINGGI = 0,40:
  - kotak nilai   h = 0,400
  - pil kategori  h = 0,400
  - titik tengah keduanya = 2,5910 (sejajar)
Sudut pil (rectRadius) juga ikut dihitung dari konstanta itu, jadi
bentuknya tetap pil penuh walau tingginya berubah.

Akar masalahnya: angka tinggi ditulis terpisah di dua tempat, jadi bisa
berbeda. Sekarang satu sumber, tidak bisa meleset lagi.

127 unit test lulus.
</commit_message>
<xml_diff>
--- a/ranking-nyata.pptx
+++ b/ranking-nyata.pptx
@@ -2849,12 +2849,12 @@
         </p:nvSpPr>
         <p:spPr>
           <a:xfrm>
-            <a:off x="8813902" y="2131466"/>
-            <a:ext cx="1188720" cy="475488"/>
+            <a:off x="8813902" y="2186330"/>
+            <a:ext cx="1188720" cy="365760"/>
           </a:xfrm>
           <a:prstGeom prst="roundRect">
             <a:avLst>
-              <a:gd name="adj" fmla="val 53846"/>
+              <a:gd name="adj" fmla="val 50000"/>
             </a:avLst>
           </a:prstGeom>
           <a:solidFill>
@@ -2876,8 +2876,8 @@
         </p:nvSpPr>
         <p:spPr>
           <a:xfrm>
-            <a:off x="8813902" y="2131466"/>
-            <a:ext cx="1188720" cy="475488"/>
+            <a:off x="8813902" y="2186330"/>
+            <a:ext cx="1188720" cy="365760"/>
           </a:xfrm>
           <a:prstGeom prst="rect">
             <a:avLst/>

</xml_diff>

<commit_message>
Ranking PPTX: pita berpendar kotak nilai dipertebal jadi proporsional
Pita 'biru berpendar' di tepi atas & bawah kotak nilai awalnya 6,5% tinggi
kotak atas permintaan user. Di kotak setinggi 0,40 inci (28,8 pt), itu cuma
1,87 pt total per sisi dengan 3 lapis — tiap lapis 0,62 pt, terlalu tipis
sehingga pendarnya nyaris tidak terlihat.

Diperlebar supaya proporsional:
  - pita pinggir 6,5% -> 12% (1,87 pt -> 3,46 pt per sisi)
  - lapis 3 -> 5 supaya gradasinya tetap mulus walaupun tebal
  - bagian tengah otomatis 87% -> 76%

Warna tangganya tetap dihitung dari campuran WARNA_TENGAH_NILAI ke
WARNA_PENDAR_NILAI, jadi tidak ada warna yang dikarang.

Terverifikasi: total tetap 100,0% dari 0,40 inci; 5 lapis per sisi.

127 unit test lulus.
</commit_message>
<xml_diff>
--- a/ranking-nyata.pptx
+++ b/ranking-nyata.pptx
@@ -2614,7 +2614,7 @@
         <p:spPr>
           <a:xfrm>
             <a:off x="4708246" y="2186330"/>
-            <a:ext cx="3977640" cy="7925"/>
+            <a:ext cx="3977640" cy="8778"/>
           </a:xfrm>
           <a:prstGeom prst="rect">
             <a:avLst/>
@@ -2638,18 +2638,18 @@
         </p:nvSpPr>
         <p:spPr>
           <a:xfrm>
-            <a:off x="4708246" y="2194255"/>
-            <a:ext cx="3977640" cy="7925"/>
-          </a:xfrm>
-          <a:prstGeom prst="rect">
-            <a:avLst/>
-          </a:prstGeom>
-          <a:solidFill>
-            <a:srgbClr val="5676DF"/>
+            <a:off x="4708246" y="2195109"/>
+            <a:ext cx="3977640" cy="8778"/>
+          </a:xfrm>
+          <a:prstGeom prst="rect">
+            <a:avLst/>
+          </a:prstGeom>
+          <a:solidFill>
+            <a:srgbClr val="6687E7"/>
           </a:solidFill>
           <a:ln w="12700">
             <a:solidFill>
-              <a:srgbClr val="5676DF"/>
+              <a:srgbClr val="6687E7"/>
             </a:solidFill>
             <a:prstDash val="solid"/>
           </a:ln>
@@ -2663,18 +2663,18 @@
         </p:nvSpPr>
         <p:spPr>
           <a:xfrm>
-            <a:off x="4708246" y="2202180"/>
-            <a:ext cx="3977640" cy="7925"/>
-          </a:xfrm>
-          <a:prstGeom prst="rect">
-            <a:avLst/>
-          </a:prstGeom>
-          <a:solidFill>
-            <a:srgbClr val="2C4CCC"/>
+            <a:off x="4708246" y="2203887"/>
+            <a:ext cx="3977640" cy="8778"/>
+          </a:xfrm>
+          <a:prstGeom prst="rect">
+            <a:avLst/>
+          </a:prstGeom>
+          <a:solidFill>
+            <a:srgbClr val="4D6EDB"/>
           </a:solidFill>
           <a:ln w="12700">
             <a:solidFill>
-              <a:srgbClr val="2C4CCC"/>
+              <a:srgbClr val="4D6EDB"/>
             </a:solidFill>
             <a:prstDash val="solid"/>
           </a:ln>
@@ -2688,8 +2688,58 @@
         </p:nvSpPr>
         <p:spPr>
           <a:xfrm>
-            <a:off x="4708246" y="2210105"/>
-            <a:ext cx="3977640" cy="318211"/>
+            <a:off x="4708246" y="2212665"/>
+            <a:ext cx="3977640" cy="8778"/>
+          </a:xfrm>
+          <a:prstGeom prst="rect">
+            <a:avLst/>
+          </a:prstGeom>
+          <a:solidFill>
+            <a:srgbClr val="3554D0"/>
+          </a:solidFill>
+          <a:ln w="12700">
+            <a:solidFill>
+              <a:srgbClr val="3554D0"/>
+            </a:solidFill>
+            <a:prstDash val="solid"/>
+          </a:ln>
+        </p:spPr>
+      </p:sp>
+      <p:sp>
+        <p:nvSpPr>
+          <p:cNvPr id="17" name="Shape 11"/>
+          <p:cNvSpPr/>
+          <p:nvPr/>
+        </p:nvSpPr>
+        <p:spPr>
+          <a:xfrm>
+            <a:off x="4708246" y="2221443"/>
+            <a:ext cx="3977640" cy="8778"/>
+          </a:xfrm>
+          <a:prstGeom prst="rect">
+            <a:avLst/>
+          </a:prstGeom>
+          <a:solidFill>
+            <a:srgbClr val="1C3BC4"/>
+          </a:solidFill>
+          <a:ln w="12700">
+            <a:solidFill>
+              <a:srgbClr val="1C3BC4"/>
+            </a:solidFill>
+            <a:prstDash val="solid"/>
+          </a:ln>
+        </p:spPr>
+      </p:sp>
+      <p:sp>
+        <p:nvSpPr>
+          <p:cNvPr id="18" name="Shape 12"/>
+          <p:cNvSpPr/>
+          <p:nvPr/>
+        </p:nvSpPr>
+        <p:spPr>
+          <a:xfrm>
+            <a:off x="4708246" y="2230222"/>
+            <a:ext cx="3977640" cy="277978"/>
           </a:xfrm>
           <a:prstGeom prst="rect">
             <a:avLst/>
@@ -2707,24 +2757,24 @@
       </p:sp>
       <p:sp>
         <p:nvSpPr>
-          <p:cNvPr id="17" name="Shape 11"/>
-          <p:cNvSpPr/>
-          <p:nvPr/>
-        </p:nvSpPr>
-        <p:spPr>
-          <a:xfrm>
-            <a:off x="4708246" y="2528316"/>
-            <a:ext cx="3977640" cy="7925"/>
-          </a:xfrm>
-          <a:prstGeom prst="rect">
-            <a:avLst/>
-          </a:prstGeom>
-          <a:solidFill>
-            <a:srgbClr val="2C4CCC"/>
+          <p:cNvPr id="19" name="Shape 13"/>
+          <p:cNvSpPr/>
+          <p:nvPr/>
+        </p:nvSpPr>
+        <p:spPr>
+          <a:xfrm>
+            <a:off x="4708246" y="2508199"/>
+            <a:ext cx="3977640" cy="8778"/>
+          </a:xfrm>
+          <a:prstGeom prst="rect">
+            <a:avLst/>
+          </a:prstGeom>
+          <a:solidFill>
+            <a:srgbClr val="1C3BC4"/>
           </a:solidFill>
           <a:ln w="12700">
             <a:solidFill>
-              <a:srgbClr val="2C4CCC"/>
+              <a:srgbClr val="1C3BC4"/>
             </a:solidFill>
             <a:prstDash val="solid"/>
           </a:ln>
@@ -2732,24 +2782,24 @@
       </p:sp>
       <p:sp>
         <p:nvSpPr>
-          <p:cNvPr id="18" name="Shape 12"/>
-          <p:cNvSpPr/>
-          <p:nvPr/>
-        </p:nvSpPr>
-        <p:spPr>
-          <a:xfrm>
-            <a:off x="4708246" y="2536241"/>
-            <a:ext cx="3977640" cy="7925"/>
-          </a:xfrm>
-          <a:prstGeom prst="rect">
-            <a:avLst/>
-          </a:prstGeom>
-          <a:solidFill>
-            <a:srgbClr val="5676DF"/>
+          <p:cNvPr id="20" name="Shape 14"/>
+          <p:cNvSpPr/>
+          <p:nvPr/>
+        </p:nvSpPr>
+        <p:spPr>
+          <a:xfrm>
+            <a:off x="4708246" y="2516977"/>
+            <a:ext cx="3977640" cy="8778"/>
+          </a:xfrm>
+          <a:prstGeom prst="rect">
+            <a:avLst/>
+          </a:prstGeom>
+          <a:solidFill>
+            <a:srgbClr val="3554D0"/>
           </a:solidFill>
           <a:ln w="12700">
             <a:solidFill>
-              <a:srgbClr val="5676DF"/>
+              <a:srgbClr val="3554D0"/>
             </a:solidFill>
             <a:prstDash val="solid"/>
           </a:ln>
@@ -2757,14 +2807,64 @@
       </p:sp>
       <p:sp>
         <p:nvSpPr>
-          <p:cNvPr id="19" name="Shape 13"/>
-          <p:cNvSpPr/>
-          <p:nvPr/>
-        </p:nvSpPr>
-        <p:spPr>
-          <a:xfrm>
-            <a:off x="4708246" y="2544166"/>
-            <a:ext cx="3977640" cy="7925"/>
+          <p:cNvPr id="21" name="Shape 15"/>
+          <p:cNvSpPr/>
+          <p:nvPr/>
+        </p:nvSpPr>
+        <p:spPr>
+          <a:xfrm>
+            <a:off x="4708246" y="2525756"/>
+            <a:ext cx="3977640" cy="8778"/>
+          </a:xfrm>
+          <a:prstGeom prst="rect">
+            <a:avLst/>
+          </a:prstGeom>
+          <a:solidFill>
+            <a:srgbClr val="4D6EDB"/>
+          </a:solidFill>
+          <a:ln w="12700">
+            <a:solidFill>
+              <a:srgbClr val="4D6EDB"/>
+            </a:solidFill>
+            <a:prstDash val="solid"/>
+          </a:ln>
+        </p:spPr>
+      </p:sp>
+      <p:sp>
+        <p:nvSpPr>
+          <p:cNvPr id="22" name="Shape 16"/>
+          <p:cNvSpPr/>
+          <p:nvPr/>
+        </p:nvSpPr>
+        <p:spPr>
+          <a:xfrm>
+            <a:off x="4708246" y="2534534"/>
+            <a:ext cx="3977640" cy="8778"/>
+          </a:xfrm>
+          <a:prstGeom prst="rect">
+            <a:avLst/>
+          </a:prstGeom>
+          <a:solidFill>
+            <a:srgbClr val="6687E7"/>
+          </a:solidFill>
+          <a:ln w="12700">
+            <a:solidFill>
+              <a:srgbClr val="6687E7"/>
+            </a:solidFill>
+            <a:prstDash val="solid"/>
+          </a:ln>
+        </p:spPr>
+      </p:sp>
+      <p:sp>
+        <p:nvSpPr>
+          <p:cNvPr id="23" name="Shape 17"/>
+          <p:cNvSpPr/>
+          <p:nvPr/>
+        </p:nvSpPr>
+        <p:spPr>
+          <a:xfrm>
+            <a:off x="4708246" y="2543312"/>
+            <a:ext cx="3977640" cy="8778"/>
           </a:xfrm>
           <a:prstGeom prst="rect">
             <a:avLst/>
@@ -2782,7 +2882,7 @@
       </p:sp>
       <p:sp>
         <p:nvSpPr>
-          <p:cNvPr id="20" name="Shape 14"/>
+          <p:cNvPr id="24" name="Shape 18"/>
           <p:cNvSpPr/>
           <p:nvPr/>
         </p:nvSpPr>
@@ -2804,7 +2904,7 @@
       </p:sp>
       <p:sp>
         <p:nvSpPr>
-          <p:cNvPr id="21" name="Text 15"/>
+          <p:cNvPr id="25" name="Text 19"/>
           <p:cNvSpPr/>
           <p:nvPr/>
         </p:nvSpPr>
@@ -2843,7 +2943,7 @@
       </p:sp>
       <p:sp>
         <p:nvSpPr>
-          <p:cNvPr id="22" name="Shape 16"/>
+          <p:cNvPr id="26" name="Shape 20"/>
           <p:cNvSpPr/>
           <p:nvPr/>
         </p:nvSpPr>
@@ -2870,7 +2970,7 @@
       </p:sp>
       <p:sp>
         <p:nvSpPr>
-          <p:cNvPr id="23" name="Text 17"/>
+          <p:cNvPr id="27" name="Text 21"/>
           <p:cNvSpPr/>
           <p:nvPr/>
         </p:nvSpPr>
@@ -2911,7 +3011,7 @@
       </p:sp>
       <p:sp>
         <p:nvSpPr>
-          <p:cNvPr id="24" name="Shape 18"/>
+          <p:cNvPr id="28" name="Shape 22"/>
           <p:cNvSpPr/>
           <p:nvPr/>
         </p:nvSpPr>
@@ -2938,7 +3038,7 @@
       </p:sp>
       <p:sp>
         <p:nvSpPr>
-          <p:cNvPr id="25" name="Shape 19"/>
+          <p:cNvPr id="29" name="Shape 23"/>
           <p:cNvSpPr/>
           <p:nvPr/>
         </p:nvSpPr>
@@ -2965,7 +3065,7 @@
       </p:sp>
       <p:sp>
         <p:nvSpPr>
-          <p:cNvPr id="26" name="Text 20"/>
+          <p:cNvPr id="30" name="Text 24"/>
           <p:cNvSpPr/>
           <p:nvPr/>
         </p:nvSpPr>
@@ -3004,7 +3104,7 @@
       </p:sp>
       <p:sp>
         <p:nvSpPr>
-          <p:cNvPr id="27" name="Shape 21"/>
+          <p:cNvPr id="31" name="Shape 25"/>
           <p:cNvSpPr/>
           <p:nvPr/>
         </p:nvSpPr>
@@ -3029,7 +3129,7 @@
       </p:sp>
       <p:sp>
         <p:nvSpPr>
-          <p:cNvPr id="28" name="Text 22"/>
+          <p:cNvPr id="32" name="Text 26"/>
           <p:cNvSpPr/>
           <p:nvPr/>
         </p:nvSpPr>
@@ -3070,7 +3170,7 @@
       </p:sp>
       <p:sp>
         <p:nvSpPr>
-          <p:cNvPr id="29" name="Text 23"/>
+          <p:cNvPr id="33" name="Text 27"/>
           <p:cNvSpPr/>
           <p:nvPr/>
         </p:nvSpPr>
@@ -3111,7 +3211,7 @@
       </p:sp>
       <p:sp>
         <p:nvSpPr>
-          <p:cNvPr id="30" name="Shape 24"/>
+          <p:cNvPr id="34" name="Shape 28"/>
           <p:cNvSpPr/>
           <p:nvPr/>
         </p:nvSpPr>
@@ -3136,7 +3236,7 @@
       </p:sp>
       <p:sp>
         <p:nvSpPr>
-          <p:cNvPr id="31" name="Text 25"/>
+          <p:cNvPr id="35" name="Text 29"/>
           <p:cNvSpPr/>
           <p:nvPr/>
         </p:nvSpPr>
@@ -3177,7 +3277,7 @@
       </p:sp>
       <p:sp>
         <p:nvSpPr>
-          <p:cNvPr id="32" name="Text 26"/>
+          <p:cNvPr id="36" name="Text 30"/>
           <p:cNvSpPr/>
           <p:nvPr/>
         </p:nvSpPr>
@@ -3218,7 +3318,7 @@
       </p:sp>
       <p:sp>
         <p:nvSpPr>
-          <p:cNvPr id="33" name="Shape 27"/>
+          <p:cNvPr id="37" name="Shape 31"/>
           <p:cNvSpPr/>
           <p:nvPr/>
         </p:nvSpPr>
@@ -3243,7 +3343,7 @@
       </p:sp>
       <p:sp>
         <p:nvSpPr>
-          <p:cNvPr id="34" name="Text 28"/>
+          <p:cNvPr id="38" name="Text 32"/>
           <p:cNvSpPr/>
           <p:nvPr/>
         </p:nvSpPr>
@@ -3284,7 +3384,7 @@
       </p:sp>
       <p:sp>
         <p:nvSpPr>
-          <p:cNvPr id="35" name="Text 29"/>
+          <p:cNvPr id="39" name="Text 33"/>
           <p:cNvSpPr/>
           <p:nvPr/>
         </p:nvSpPr>
@@ -3325,7 +3425,7 @@
       </p:sp>
       <p:sp>
         <p:nvSpPr>
-          <p:cNvPr id="36" name="Shape 30"/>
+          <p:cNvPr id="40" name="Shape 34"/>
           <p:cNvSpPr/>
           <p:nvPr/>
         </p:nvSpPr>
@@ -3350,7 +3450,7 @@
       </p:sp>
       <p:sp>
         <p:nvSpPr>
-          <p:cNvPr id="37" name="Text 31"/>
+          <p:cNvPr id="41" name="Text 35"/>
           <p:cNvSpPr/>
           <p:nvPr/>
         </p:nvSpPr>
@@ -3391,7 +3491,7 @@
       </p:sp>
       <p:sp>
         <p:nvSpPr>
-          <p:cNvPr id="38" name="Text 32"/>
+          <p:cNvPr id="42" name="Text 36"/>
           <p:cNvSpPr/>
           <p:nvPr/>
         </p:nvSpPr>
@@ -3432,7 +3532,7 @@
       </p:sp>
       <p:sp>
         <p:nvSpPr>
-          <p:cNvPr id="39" name="Shape 33"/>
+          <p:cNvPr id="43" name="Shape 37"/>
           <p:cNvSpPr/>
           <p:nvPr/>
         </p:nvSpPr>
@@ -3457,7 +3557,7 @@
       </p:sp>
       <p:sp>
         <p:nvSpPr>
-          <p:cNvPr id="40" name="Text 34"/>
+          <p:cNvPr id="44" name="Text 38"/>
           <p:cNvSpPr/>
           <p:nvPr/>
         </p:nvSpPr>
@@ -3498,7 +3598,7 @@
       </p:sp>
       <p:sp>
         <p:nvSpPr>
-          <p:cNvPr id="41" name="Text 35"/>
+          <p:cNvPr id="45" name="Text 39"/>
           <p:cNvSpPr/>
           <p:nvPr/>
         </p:nvSpPr>

</xml_diff>

<commit_message>
Ranking PPTX: label SKALA PENILAIAN — latar #0F44BE, sudut agak kotak
- Warna latar kotak label diganti dari #0B1E6B ke #0F44BE (nilai dari user).
- Sudut kiri-kanan dibuat agak kotak: rectRadius dari 0,18 ke 0,06 inci.
  Kotaknya setinggi 0,270 inci, jadi 0,18 hampir setengah tinggi — itulah
  sebabnya sisi kanan-kirinya terlihat sangat bulat seperti pil. 0,06
  memberi sudut membulat tipis saja.
- Radius dipindah jadi konstanta RADIUS_LABEL_LEGENDA supaya kalau tinggi
  kotaknya berubah, radiusnya mudah disetel ulang.

127 unit test lulus.
</commit_message>
<xml_diff>
--- a/ranking-nyata.pptx
+++ b/ranking-nyata.pptx
@@ -1652,15 +1652,15 @@
           </a:xfrm>
           <a:prstGeom prst="roundRect">
             <a:avLst>
-              <a:gd name="adj" fmla="val 66667"/>
+              <a:gd name="adj" fmla="val 22222"/>
             </a:avLst>
           </a:prstGeom>
           <a:solidFill>
-            <a:srgbClr val="0B1E6B"/>
+            <a:srgbClr val="0F44BE"/>
           </a:solidFill>
           <a:ln w="12700">
             <a:solidFill>
-              <a:srgbClr val="0B1E6B"/>
+              <a:srgbClr val="0F44BE"/>
             </a:solidFill>
             <a:prstDash val="solid"/>
           </a:ln>
@@ -3049,15 +3049,15 @@
           </a:xfrm>
           <a:prstGeom prst="roundRect">
             <a:avLst>
-              <a:gd name="adj" fmla="val 66667"/>
+              <a:gd name="adj" fmla="val 22222"/>
             </a:avLst>
           </a:prstGeom>
           <a:solidFill>
-            <a:srgbClr val="0B1E6B"/>
+            <a:srgbClr val="0F44BE"/>
           </a:solidFill>
           <a:ln w="12700">
             <a:solidFill>
-              <a:srgbClr val="0B1E6B"/>
+              <a:srgbClr val="0F44BE"/>
             </a:solidFill>
             <a:prstDash val="solid"/>
           </a:ln>

</xml_diff>

<commit_message>
Ranking: nama cabang tanpa kode + font -2 pt, sudut panel legenda sesuai referensi
NAMA CABANG:
- Slide menampilkan '244 KC MAMUJU'; kode '244' dibuang sehingga jadi
  'KC MAMUJU' saja. Kode ditambahkan di dua tempat (ranking.ts baris label
  unit dan baris pengelompokan), keduanya sudah dibersihkan. Nama di
  database memang sudah bersih, jadi cukup di sisi tampilan.
- Ukuran font nama cabang 20 -> 18 pt.

PANEL LEGENDA:
- Radius sudut disamakan dengan file referensi: 24% dari tinggi panel
  (Rounded Rectangle 83 -> radius relatif 0,2400), yaitu 0,173 inci.
  Sebelumnya 0,06 inci sehingga sudutnya terlihat terlalu kotak.

Skrip baru: scripts/cek-radius-referensi.py (baca radius dari file
referensi), scripts/lihat-nama-cabang.ts, scripts/cek-radius-label.py.

127 unit test lulus.
</commit_message>
<xml_diff>
--- a/ranking-nyata.pptx
+++ b/ranking-nyata.pptx
@@ -1128,7 +1128,7 @@
               <a:buNone/>
             </a:pPr>
             <a:r>
-              <a:rPr lang="en-US" sz="2000" dirty="0">
+              <a:rPr lang="en-US" sz="1800" dirty="0">
                 <a:solidFill>
                   <a:srgbClr val="FFFFFF"/>
                 </a:solidFill>
@@ -1138,7 +1138,7 @@
               </a:rPr>
               <a:t>Semua unit</a:t>
             </a:r>
-            <a:endParaRPr lang="en-US" sz="2000" dirty="0"/>
+            <a:endParaRPr lang="en-US" sz="1800" dirty="0"/>
           </a:p>
         </p:txBody>
       </p:sp>
@@ -1625,7 +1625,7 @@
           </a:xfrm>
           <a:prstGeom prst="roundRect">
             <a:avLst>
-              <a:gd name="adj" fmla="val 8333"/>
+              <a:gd name="adj" fmla="val 24028"/>
             </a:avLst>
           </a:prstGeom>
           <a:solidFill>
@@ -2436,7 +2436,7 @@
               <a:buNone/>
             </a:pPr>
             <a:r>
-              <a:rPr lang="en-US" sz="2000" dirty="0">
+              <a:rPr lang="en-US" sz="1800" dirty="0">
                 <a:solidFill>
                   <a:srgbClr val="FFFFFF"/>
                 </a:solidFill>
@@ -2444,9 +2444,9 @@
                 <a:ea typeface="Poppins" pitchFamily="34" charset="-122"/>
                 <a:cs typeface="Poppins" pitchFamily="34" charset="-120"/>
               </a:rPr>
-              <a:t>244 KC MAMUJU</a:t>
-            </a:r>
-            <a:endParaRPr lang="en-US" sz="2000" dirty="0"/>
+              <a:t>KC MAMUJU</a:t>
+            </a:r>
+            <a:endParaRPr lang="en-US" sz="1800" dirty="0"/>
           </a:p>
         </p:txBody>
       </p:sp>
@@ -3022,7 +3022,7 @@
           </a:xfrm>
           <a:prstGeom prst="roundRect">
             <a:avLst>
-              <a:gd name="adj" fmla="val 8333"/>
+              <a:gd name="adj" fmla="val 24028"/>
             </a:avLst>
           </a:prstGeom>
           <a:solidFill>

</xml_diff>

<commit_message>
PPTX: ukuran halaman dibuat identik dengan file referensi
File referensi mendefinisikan <p:sldSz cx=12192000 cy=6858000/> = 13,33333…
x 7,5 inci (16:9, 960 x 540 pt). Kode memakai 13.3333 (dibulatkan) sehingga
lebarnya meleset 30 EMU.

Sekarang ditulis sebagai pecahan 12192000/914400 dan 6858000/914400.

Terverifikasi: cx dan cy aplikasi = cx dan cy referensi, selisih 0 EMU.
Ukuran praktisnya sudah sama sebelumnya (selisih 0,000033 inci, tak
berpengaruh), ini supaya benar-benar identik byte demi byte.

127 unit test lulus.
</commit_message>
<xml_diff>
--- a/ranking-nyata.pptx
+++ b/ranking-nyata.pptx
@@ -11,8 +11,8 @@
   <p:notesMasterIdLst>
     <p:notesMasterId r:id="rId4"/>
   </p:notesMasterIdLst>
-  <p:sldSz cx="12191970" cy="6858000"/>
-  <p:notesSz cx="6858000" cy="12191970"/>
+  <p:sldSz cx="12192000" cy="6858000"/>
+  <p:notesSz cx="6858000" cy="12192000"/>
   <p:defaultTextStyle>
     <a:lvl1pPr marL="0" algn="l" defTabSz="914400" rtl="0" eaLnBrk="1" latinLnBrk="0" hangingPunct="1">
       <a:defRPr sz="1800" kern="1200">
@@ -981,7 +981,7 @@
         <p:spPr>
           <a:xfrm>
             <a:off x="0" y="-28346"/>
-            <a:ext cx="12191970" cy="6986930"/>
+            <a:ext cx="12192000" cy="6986930"/>
           </a:xfrm>
           <a:prstGeom prst="rect">
             <a:avLst/>
@@ -2289,7 +2289,7 @@
         <p:spPr>
           <a:xfrm>
             <a:off x="0" y="-28346"/>
-            <a:ext cx="12191970" cy="6986930"/>
+            <a:ext cx="12192000" cy="6986930"/>
           </a:xfrm>
           <a:prstGeom prst="rect">
             <a:avLst/>

</xml_diff>

<commit_message>
Ranking PPTX: hapus bingkai samar, kriteria mengikuti ujung kotak nilai
1. Bingkai samar sepanjang kolom 0-5 DIHAPUS. Sebelumnya kotak nilai selalu
   digambar penuh (garis #D1D1D1 sepanjang 4,350 inci) sebagai penanda sisa
   skala, lalu batang nilainya di atasnya. Sekarang kotaknya sebesar
   ukurannya saja: garis tepi mengelilingi bagian yang terisi.

2. Kriteria (pil) tidak lagi di posisi tetap. Sebelumnya selalu di
   x=9,639 (ujung kolom), sekarang di xKotak + panjang batang + 0,14
   sehingga benar-benar menempel di samping kanan kotak nilainya.
   Nilai kecil membuat pilnya ikut bergeser ke kiri.

   Diperiksa semua nilai aman (tidak keluar slide):
     nilai 5,00 -> pil 9,639 .. 10,939
     nilai 3,51 -> pil 8,343 ..  9,643
     nilai 0    -> pil 5,289 ..  6,589
   Batas kanan slide 13,333; maksimum aman justru di nilai 5.

136 unit test lulus.
</commit_message>
<xml_diff>
--- a/ranking-nyata.pptx
+++ b/ranking-nyata.pptx
@@ -2855,7 +2855,7 @@
         <p:spPr>
           <a:xfrm>
             <a:off x="4708246" y="2186330"/>
-            <a:ext cx="3977640" cy="365760"/>
+            <a:ext cx="2792303" cy="365760"/>
           </a:xfrm>
           <a:prstGeom prst="rect">
             <a:avLst/>
@@ -2915,7 +2915,7 @@
         </p:nvSpPr>
         <p:spPr>
           <a:xfrm>
-            <a:off x="8813902" y="2186330"/>
+            <a:off x="7628565" y="2186330"/>
             <a:ext cx="1188720" cy="365760"/>
           </a:xfrm>
           <a:prstGeom prst="roundRect">
@@ -2942,7 +2942,7 @@
         </p:nvSpPr>
         <p:spPr>
           <a:xfrm>
-            <a:off x="8813902" y="2186330"/>
+            <a:off x="7628565" y="2186330"/>
             <a:ext cx="1188720" cy="365760"/>
           </a:xfrm>
           <a:prstGeom prst="rect">

</xml_diff>

<commit_message>
Ranking PPTX: pita berpendar kotak nilai diperlebar ke 16,5% per sisi
Riwayat lebar pita berpendar: 6,5% -> 12% -> 16,5% (permintaan user).

  pita per sisi : 16,5% dari tinggi kotak
                  = 4,75 pt di kotak setinggi 28,8 pt (0,40 inci)
  bagian tengah : otomatis 67,0%

Lapis tetap 5 per sisi sehingga tiap lapis 0,95 pt — masih cukup halus,
gradasinya tidak terlihat bergaris.

Terverifikasi di XML hasil: 5 lapis per sisi, masing-masing 3,30%,
total 16,5% per sisi, dan bagian tengah 67,00%.

167 unit test lulus.
</commit_message>
<xml_diff>
--- a/ranking-nyata.pptx
+++ b/ranking-nyata.pptx
@@ -2580,7 +2580,7 @@
         <p:spPr>
           <a:xfrm>
             <a:off x="4317980" y="2186330"/>
-            <a:ext cx="2792303" cy="8778"/>
+            <a:ext cx="2792303" cy="12070"/>
           </a:xfrm>
           <a:prstGeom prst="rect">
             <a:avLst/>
@@ -2604,8 +2604,8 @@
         </p:nvSpPr>
         <p:spPr>
           <a:xfrm>
-            <a:off x="4317980" y="2195109"/>
-            <a:ext cx="2792303" cy="8778"/>
+            <a:off x="4317980" y="2198400"/>
+            <a:ext cx="2792303" cy="12070"/>
           </a:xfrm>
           <a:prstGeom prst="rect">
             <a:avLst/>
@@ -2629,8 +2629,8 @@
         </p:nvSpPr>
         <p:spPr>
           <a:xfrm>
-            <a:off x="4317980" y="2203887"/>
-            <a:ext cx="2792303" cy="8778"/>
+            <a:off x="4317980" y="2210471"/>
+            <a:ext cx="2792303" cy="12070"/>
           </a:xfrm>
           <a:prstGeom prst="rect">
             <a:avLst/>
@@ -2654,8 +2654,8 @@
         </p:nvSpPr>
         <p:spPr>
           <a:xfrm>
-            <a:off x="4317980" y="2212665"/>
-            <a:ext cx="2792303" cy="8778"/>
+            <a:off x="4317980" y="2222541"/>
+            <a:ext cx="2792303" cy="12070"/>
           </a:xfrm>
           <a:prstGeom prst="rect">
             <a:avLst/>
@@ -2679,8 +2679,8 @@
         </p:nvSpPr>
         <p:spPr>
           <a:xfrm>
-            <a:off x="4317980" y="2221443"/>
-            <a:ext cx="2792303" cy="8778"/>
+            <a:off x="4317980" y="2234611"/>
+            <a:ext cx="2792303" cy="12070"/>
           </a:xfrm>
           <a:prstGeom prst="rect">
             <a:avLst/>
@@ -2704,8 +2704,8 @@
         </p:nvSpPr>
         <p:spPr>
           <a:xfrm>
-            <a:off x="4317980" y="2230222"/>
-            <a:ext cx="2792303" cy="277978"/>
+            <a:off x="4317980" y="2246681"/>
+            <a:ext cx="2792303" cy="245059"/>
           </a:xfrm>
           <a:prstGeom prst="rect">
             <a:avLst/>
@@ -2729,8 +2729,8 @@
         </p:nvSpPr>
         <p:spPr>
           <a:xfrm>
-            <a:off x="4317980" y="2508199"/>
-            <a:ext cx="2792303" cy="8778"/>
+            <a:off x="4317980" y="2491740"/>
+            <a:ext cx="2792303" cy="12070"/>
           </a:xfrm>
           <a:prstGeom prst="rect">
             <a:avLst/>
@@ -2754,8 +2754,8 @@
         </p:nvSpPr>
         <p:spPr>
           <a:xfrm>
-            <a:off x="4317980" y="2516977"/>
-            <a:ext cx="2792303" cy="8778"/>
+            <a:off x="4317980" y="2503810"/>
+            <a:ext cx="2792303" cy="12070"/>
           </a:xfrm>
           <a:prstGeom prst="rect">
             <a:avLst/>
@@ -2779,8 +2779,8 @@
         </p:nvSpPr>
         <p:spPr>
           <a:xfrm>
-            <a:off x="4317980" y="2525756"/>
-            <a:ext cx="2792303" cy="8778"/>
+            <a:off x="4317980" y="2515880"/>
+            <a:ext cx="2792303" cy="12070"/>
           </a:xfrm>
           <a:prstGeom prst="rect">
             <a:avLst/>
@@ -2804,8 +2804,8 @@
         </p:nvSpPr>
         <p:spPr>
           <a:xfrm>
-            <a:off x="4317980" y="2534534"/>
-            <a:ext cx="2792303" cy="8778"/>
+            <a:off x="4317980" y="2527950"/>
+            <a:ext cx="2792303" cy="12070"/>
           </a:xfrm>
           <a:prstGeom prst="rect">
             <a:avLst/>
@@ -2829,8 +2829,8 @@
         </p:nvSpPr>
         <p:spPr>
           <a:xfrm>
-            <a:off x="4317980" y="2543312"/>
-            <a:ext cx="2792303" cy="8778"/>
+            <a:off x="4317980" y="2540020"/>
+            <a:ext cx="2792303" cy="12070"/>
           </a:xfrm>
           <a:prstGeom prst="rect">
             <a:avLst/>

</xml_diff>